<commit_message>
delay in generating and downloading sheet controlled by env variables
</commit_message>
<xml_diff>
--- a/src/demo/presentation/cache/americas-occupancy--building-f-alignment--floor-plan--retail-workspace.pptx
+++ b/src/demo/presentation/cache/americas-occupancy--building-f-alignment--floor-plan--retail-workspace.pptx
@@ -4,40 +4,41 @@
   <p:sldMasterIdLst>
     <p:sldMasterId id="2147483678" r:id="rId4"/>
     <p:sldMasterId id="2147483703" r:id="rId5"/>
+    <p:sldMasterId id="2147483745" r:id="rId6"/>
   </p:sldMasterIdLst>
   <p:notesMasterIdLst>
-    <p:notesMasterId r:id="rId12"/>
+    <p:notesMasterId r:id="rId13"/>
   </p:notesMasterIdLst>
   <p:handoutMasterIdLst>
-    <p:handoutMasterId r:id="rId13"/>
+    <p:handoutMasterId r:id="rId14"/>
   </p:handoutMasterIdLst>
   <p:sldIdLst>
-    <p:sldId id="361" r:id="rId6"/>
-    <p:sldId id="432" r:id="rId7"/>
-    <p:sldId id="434" r:id="rId8"/>
-    <p:sldId id="438" r:id="rId9"/>
-    <p:sldId id="441" r:id="rId10"/>
-    <p:sldId id="443" r:id="rId11"/>
+    <p:sldId id="361" r:id="rId7"/>
+    <p:sldId id="444" r:id="rId8"/>
+    <p:sldId id="434" r:id="rId9"/>
+    <p:sldId id="438" r:id="rId10"/>
+    <p:sldId id="441" r:id="rId11"/>
+    <p:sldId id="443" r:id="rId12"/>
   </p:sldIdLst>
   <p:sldSz cx="9906000" cy="6858000" type="A4"/>
   <p:notesSz cx="6797675" cy="9926638"/>
   <p:embeddedFontLst>
     <p:embeddedFont>
       <p:font typeface="Roboto" panose="02000000000000000000" pitchFamily="2" charset="0"/>
-      <p:regular r:id="rId14"/>
-      <p:bold r:id="rId15"/>
-      <p:italic r:id="rId16"/>
-      <p:boldItalic r:id="rId17"/>
+      <p:regular r:id="rId15"/>
+      <p:bold r:id="rId16"/>
+      <p:italic r:id="rId17"/>
+      <p:boldItalic r:id="rId18"/>
     </p:embeddedFont>
     <p:embeddedFont>
       <p:font typeface="Roboto Light" panose="02000000000000000000" pitchFamily="2" charset="0"/>
-      <p:regular r:id="rId18"/>
-      <p:italic r:id="rId19"/>
+      <p:regular r:id="rId19"/>
+      <p:italic r:id="rId20"/>
     </p:embeddedFont>
     <p:embeddedFont>
       <p:font typeface="Roboto Medium" panose="02000000000000000000" pitchFamily="2" charset="0"/>
-      <p:regular r:id="rId20"/>
-      <p:italic r:id="rId21"/>
+      <p:regular r:id="rId21"/>
+      <p:italic r:id="rId22"/>
     </p:embeddedFont>
   </p:embeddedFontLst>
   <p:defaultTextStyle>
@@ -247,7 +248,7 @@
           <a:p>
             <a:fld id="{561635DC-7C77-4EDC-877E-93E281EA2302}" type="datetimeFigureOut">
               <a:rPr lang="en-GB" smtClean="0"/>
-              <a:t>28/07/2026</a:t>
+              <a:t>29/07/2026</a:t>
             </a:fld>
             <a:endParaRPr lang="en-GB"/>
           </a:p>
@@ -412,7 +413,7 @@
           <a:p>
             <a:fld id="{1AC7EAFC-5287-4976-8725-CD476620A400}" type="datetimeFigureOut">
               <a:rPr lang="en-GB" smtClean="0"/>
-              <a:t>28/07/2026</a:t>
+              <a:t>29/07/2026</a:t>
             </a:fld>
             <a:endParaRPr lang="en-GB"/>
           </a:p>
@@ -1042,7 +1043,7 @@
             <a:fld id="{6F80DDAC-FE11-49DC-9261-11C1E994665B}" type="datetimeFigureOut">
               <a:rPr lang="en-GB" smtClean="0"/>
               <a:pPr/>
-              <a:t>28/07/2026</a:t>
+              <a:t>29/07/2026</a:t>
             </a:fld>
             <a:endParaRPr lang="en-GB"/>
           </a:p>
@@ -1294,7 +1295,7 @@
             <a:fld id="{6F80DDAC-FE11-49DC-9261-11C1E994665B}" type="datetimeFigureOut">
               <a:rPr lang="en-GB" smtClean="0"/>
               <a:pPr/>
-              <a:t>28/07/2026</a:t>
+              <a:t>29/07/2026</a:t>
             </a:fld>
             <a:endParaRPr lang="en-GB"/>
           </a:p>
@@ -1580,7 +1581,7 @@
             <a:fld id="{6F80DDAC-FE11-49DC-9261-11C1E994665B}" type="datetimeFigureOut">
               <a:rPr lang="en-GB" smtClean="0"/>
               <a:pPr/>
-              <a:t>28/07/2026</a:t>
+              <a:t>29/07/2026</a:t>
             </a:fld>
             <a:endParaRPr lang="en-GB"/>
           </a:p>
@@ -1699,6 +1700,1644 @@
 </p:sldLayout>
 </file>
 
+<file path=ppt/slideLayouts/slideLayout13.xml><?xml version="1.0" encoding="utf-8"?>
+<p:sldLayout xmlns:a="http://schemas.openxmlformats.org/drawingml/2006/main" xmlns:r="http://schemas.openxmlformats.org/officeDocument/2006/relationships" xmlns:p="http://schemas.openxmlformats.org/presentationml/2006/main" type="title" preserve="1">
+  <p:cSld name="Title Slide">
+    <p:spTree>
+      <p:nvGrpSpPr>
+        <p:cNvPr id="1" name=""/>
+        <p:cNvGrpSpPr/>
+        <p:nvPr/>
+      </p:nvGrpSpPr>
+      <p:grpSpPr>
+        <a:xfrm>
+          <a:off x="0" y="0"/>
+          <a:ext cx="0" cy="0"/>
+          <a:chOff x="0" y="0"/>
+          <a:chExt cx="0" cy="0"/>
+        </a:xfrm>
+      </p:grpSpPr>
+      <p:sp>
+        <p:nvSpPr>
+          <p:cNvPr id="2" name="Title 1">
+            <a:extLst>
+              <a:ext uri="{FF2B5EF4-FFF2-40B4-BE49-F238E27FC236}">
+                <a16:creationId xmlns:a16="http://schemas.microsoft.com/office/drawing/2014/main" id="{D3595819-2C5B-0763-2E8B-04E6752BC387}"/>
+              </a:ext>
+            </a:extLst>
+          </p:cNvPr>
+          <p:cNvSpPr>
+            <a:spLocks noGrp="1"/>
+          </p:cNvSpPr>
+          <p:nvPr>
+            <p:ph type="ctrTitle"/>
+          </p:nvPr>
+        </p:nvSpPr>
+        <p:spPr>
+          <a:xfrm>
+            <a:off x="1238250" y="1122363"/>
+            <a:ext cx="7429500" cy="2387600"/>
+          </a:xfrm>
+        </p:spPr>
+        <p:txBody>
+          <a:bodyPr anchor="b"/>
+          <a:lstStyle>
+            <a:lvl1pPr algn="ctr">
+              <a:defRPr sz="4875"/>
+            </a:lvl1pPr>
+          </a:lstStyle>
+          <a:p>
+            <a:r>
+              <a:rPr lang="en-US"/>
+              <a:t>Click to edit Master title style</a:t>
+            </a:r>
+          </a:p>
+        </p:txBody>
+      </p:sp>
+      <p:sp>
+        <p:nvSpPr>
+          <p:cNvPr id="3" name="Subtitle 2">
+            <a:extLst>
+              <a:ext uri="{FF2B5EF4-FFF2-40B4-BE49-F238E27FC236}">
+                <a16:creationId xmlns:a16="http://schemas.microsoft.com/office/drawing/2014/main" id="{D8ADDE25-AF64-C532-16FC-93EB1FB2957E}"/>
+              </a:ext>
+            </a:extLst>
+          </p:cNvPr>
+          <p:cNvSpPr>
+            <a:spLocks noGrp="1"/>
+          </p:cNvSpPr>
+          <p:nvPr>
+            <p:ph type="subTitle" idx="1"/>
+          </p:nvPr>
+        </p:nvSpPr>
+        <p:spPr>
+          <a:xfrm>
+            <a:off x="1238250" y="3602038"/>
+            <a:ext cx="7429500" cy="1655762"/>
+          </a:xfrm>
+        </p:spPr>
+        <p:txBody>
+          <a:bodyPr/>
+          <a:lstStyle>
+            <a:lvl1pPr marL="0" indent="0" algn="ctr">
+              <a:buNone/>
+              <a:defRPr sz="1950"/>
+            </a:lvl1pPr>
+            <a:lvl2pPr marL="371475" indent="0" algn="ctr">
+              <a:buNone/>
+              <a:defRPr sz="1625"/>
+            </a:lvl2pPr>
+            <a:lvl3pPr marL="742950" indent="0" algn="ctr">
+              <a:buNone/>
+              <a:defRPr sz="1463"/>
+            </a:lvl3pPr>
+            <a:lvl4pPr marL="1114425" indent="0" algn="ctr">
+              <a:buNone/>
+              <a:defRPr sz="1300"/>
+            </a:lvl4pPr>
+            <a:lvl5pPr marL="1485900" indent="0" algn="ctr">
+              <a:buNone/>
+              <a:defRPr sz="1300"/>
+            </a:lvl5pPr>
+            <a:lvl6pPr marL="1857375" indent="0" algn="ctr">
+              <a:buNone/>
+              <a:defRPr sz="1300"/>
+            </a:lvl6pPr>
+            <a:lvl7pPr marL="2228850" indent="0" algn="ctr">
+              <a:buNone/>
+              <a:defRPr sz="1300"/>
+            </a:lvl7pPr>
+            <a:lvl8pPr marL="2600325" indent="0" algn="ctr">
+              <a:buNone/>
+              <a:defRPr sz="1300"/>
+            </a:lvl8pPr>
+            <a:lvl9pPr marL="2971800" indent="0" algn="ctr">
+              <a:buNone/>
+              <a:defRPr sz="1300"/>
+            </a:lvl9pPr>
+          </a:lstStyle>
+          <a:p>
+            <a:r>
+              <a:rPr lang="en-US"/>
+              <a:t>Click to edit Master subtitle style</a:t>
+            </a:r>
+          </a:p>
+        </p:txBody>
+      </p:sp>
+      <p:sp>
+        <p:nvSpPr>
+          <p:cNvPr id="4" name="Date Placeholder 3">
+            <a:extLst>
+              <a:ext uri="{FF2B5EF4-FFF2-40B4-BE49-F238E27FC236}">
+                <a16:creationId xmlns:a16="http://schemas.microsoft.com/office/drawing/2014/main" id="{396A1A39-B8CA-2182-EFF7-2572C798DDB5}"/>
+              </a:ext>
+            </a:extLst>
+          </p:cNvPr>
+          <p:cNvSpPr>
+            <a:spLocks noGrp="1"/>
+          </p:cNvSpPr>
+          <p:nvPr>
+            <p:ph type="dt" sz="half" idx="10"/>
+          </p:nvPr>
+        </p:nvSpPr>
+        <p:spPr/>
+        <p:txBody>
+          <a:bodyPr/>
+          <a:lstStyle/>
+          <a:p>
+            <a:fld id="{6F80DDAC-FE11-49DC-9261-11C1E994665B}" type="datetimeFigureOut">
+              <a:rPr lang="en-GB" smtClean="0"/>
+              <a:pPr/>
+              <a:t>29/07/2026</a:t>
+            </a:fld>
+            <a:endParaRPr lang="en-GB"/>
+          </a:p>
+        </p:txBody>
+      </p:sp>
+      <p:sp>
+        <p:nvSpPr>
+          <p:cNvPr id="5" name="Footer Placeholder 4">
+            <a:extLst>
+              <a:ext uri="{FF2B5EF4-FFF2-40B4-BE49-F238E27FC236}">
+                <a16:creationId xmlns:a16="http://schemas.microsoft.com/office/drawing/2014/main" id="{FD9A4148-14A8-74BB-71CD-7980CAA2AF98}"/>
+              </a:ext>
+            </a:extLst>
+          </p:cNvPr>
+          <p:cNvSpPr>
+            <a:spLocks noGrp="1"/>
+          </p:cNvSpPr>
+          <p:nvPr>
+            <p:ph type="ftr" sz="quarter" idx="11"/>
+          </p:nvPr>
+        </p:nvSpPr>
+        <p:spPr/>
+        <p:txBody>
+          <a:bodyPr/>
+          <a:lstStyle/>
+          <a:p>
+            <a:endParaRPr lang="en-US"/>
+          </a:p>
+        </p:txBody>
+      </p:sp>
+      <p:sp>
+        <p:nvSpPr>
+          <p:cNvPr id="6" name="Slide Number Placeholder 5">
+            <a:extLst>
+              <a:ext uri="{FF2B5EF4-FFF2-40B4-BE49-F238E27FC236}">
+                <a16:creationId xmlns:a16="http://schemas.microsoft.com/office/drawing/2014/main" id="{6374429A-D693-D0D3-F675-C561B12C3E59}"/>
+              </a:ext>
+            </a:extLst>
+          </p:cNvPr>
+          <p:cNvSpPr>
+            <a:spLocks noGrp="1"/>
+          </p:cNvSpPr>
+          <p:nvPr>
+            <p:ph type="sldNum" sz="quarter" idx="12"/>
+          </p:nvPr>
+        </p:nvSpPr>
+        <p:spPr/>
+        <p:txBody>
+          <a:bodyPr/>
+          <a:lstStyle/>
+          <a:p>
+            <a:fld id="{3A73CC0E-67D5-43FD-BD59-BE5F44570CB2}" type="slidenum">
+              <a:rPr lang="en-GB" smtClean="0"/>
+              <a:pPr/>
+              <a:t>‹#›</a:t>
+            </a:fld>
+            <a:endParaRPr lang="en-GB"/>
+          </a:p>
+        </p:txBody>
+      </p:sp>
+    </p:spTree>
+    <p:extLst>
+      <p:ext uri="{BB962C8B-B14F-4D97-AF65-F5344CB8AC3E}">
+        <p14:creationId xmlns:p14="http://schemas.microsoft.com/office/powerpoint/2010/main" val="2596838762"/>
+      </p:ext>
+    </p:extLst>
+  </p:cSld>
+  <p:clrMapOvr>
+    <a:masterClrMapping/>
+  </p:clrMapOvr>
+</p:sldLayout>
+</file>
+
+<file path=ppt/slideLayouts/slideLayout14.xml><?xml version="1.0" encoding="utf-8"?>
+<p:sldLayout xmlns:a="http://schemas.openxmlformats.org/drawingml/2006/main" xmlns:r="http://schemas.openxmlformats.org/officeDocument/2006/relationships" xmlns:p="http://schemas.openxmlformats.org/presentationml/2006/main" type="obj" preserve="1">
+  <p:cSld name="Title and Content">
+    <p:spTree>
+      <p:nvGrpSpPr>
+        <p:cNvPr id="1" name=""/>
+        <p:cNvGrpSpPr/>
+        <p:nvPr/>
+      </p:nvGrpSpPr>
+      <p:grpSpPr>
+        <a:xfrm>
+          <a:off x="0" y="0"/>
+          <a:ext cx="0" cy="0"/>
+          <a:chOff x="0" y="0"/>
+          <a:chExt cx="0" cy="0"/>
+        </a:xfrm>
+      </p:grpSpPr>
+      <p:sp>
+        <p:nvSpPr>
+          <p:cNvPr id="2" name="Title 1">
+            <a:extLst>
+              <a:ext uri="{FF2B5EF4-FFF2-40B4-BE49-F238E27FC236}">
+                <a16:creationId xmlns:a16="http://schemas.microsoft.com/office/drawing/2014/main" id="{34C1C74A-299C-3777-518C-993A0A36FB75}"/>
+              </a:ext>
+            </a:extLst>
+          </p:cNvPr>
+          <p:cNvSpPr>
+            <a:spLocks noGrp="1"/>
+          </p:cNvSpPr>
+          <p:nvPr>
+            <p:ph type="title"/>
+          </p:nvPr>
+        </p:nvSpPr>
+        <p:spPr/>
+        <p:txBody>
+          <a:bodyPr/>
+          <a:lstStyle/>
+          <a:p>
+            <a:r>
+              <a:rPr lang="en-US"/>
+              <a:t>Click to edit Master title style</a:t>
+            </a:r>
+          </a:p>
+        </p:txBody>
+      </p:sp>
+      <p:sp>
+        <p:nvSpPr>
+          <p:cNvPr id="3" name="Content Placeholder 2">
+            <a:extLst>
+              <a:ext uri="{FF2B5EF4-FFF2-40B4-BE49-F238E27FC236}">
+                <a16:creationId xmlns:a16="http://schemas.microsoft.com/office/drawing/2014/main" id="{F9C741E0-D46F-9748-1389-DEA9DF288130}"/>
+              </a:ext>
+            </a:extLst>
+          </p:cNvPr>
+          <p:cNvSpPr>
+            <a:spLocks noGrp="1"/>
+          </p:cNvSpPr>
+          <p:nvPr>
+            <p:ph idx="1"/>
+          </p:nvPr>
+        </p:nvSpPr>
+        <p:spPr/>
+        <p:txBody>
+          <a:bodyPr/>
+          <a:lstStyle/>
+          <a:p>
+            <a:pPr lvl="0"/>
+            <a:r>
+              <a:rPr lang="en-US"/>
+              <a:t>Click to edit Master text styles</a:t>
+            </a:r>
+          </a:p>
+          <a:p>
+            <a:pPr lvl="1"/>
+            <a:r>
+              <a:rPr lang="en-US"/>
+              <a:t>Second level</a:t>
+            </a:r>
+          </a:p>
+          <a:p>
+            <a:pPr lvl="2"/>
+            <a:r>
+              <a:rPr lang="en-US"/>
+              <a:t>Third level</a:t>
+            </a:r>
+          </a:p>
+          <a:p>
+            <a:pPr lvl="3"/>
+            <a:r>
+              <a:rPr lang="en-US"/>
+              <a:t>Fourth level</a:t>
+            </a:r>
+          </a:p>
+          <a:p>
+            <a:pPr lvl="4"/>
+            <a:r>
+              <a:rPr lang="en-US"/>
+              <a:t>Fifth level</a:t>
+            </a:r>
+          </a:p>
+        </p:txBody>
+      </p:sp>
+      <p:sp>
+        <p:nvSpPr>
+          <p:cNvPr id="4" name="Date Placeholder 3">
+            <a:extLst>
+              <a:ext uri="{FF2B5EF4-FFF2-40B4-BE49-F238E27FC236}">
+                <a16:creationId xmlns:a16="http://schemas.microsoft.com/office/drawing/2014/main" id="{8212E565-61C3-7C0F-BCA1-579B433BBC67}"/>
+              </a:ext>
+            </a:extLst>
+          </p:cNvPr>
+          <p:cNvSpPr>
+            <a:spLocks noGrp="1"/>
+          </p:cNvSpPr>
+          <p:nvPr>
+            <p:ph type="dt" sz="half" idx="10"/>
+          </p:nvPr>
+        </p:nvSpPr>
+        <p:spPr/>
+        <p:txBody>
+          <a:bodyPr/>
+          <a:lstStyle/>
+          <a:p>
+            <a:fld id="{6F80DDAC-FE11-49DC-9261-11C1E994665B}" type="datetimeFigureOut">
+              <a:rPr lang="en-GB" smtClean="0"/>
+              <a:pPr/>
+              <a:t>29/07/2026</a:t>
+            </a:fld>
+            <a:endParaRPr lang="en-GB"/>
+          </a:p>
+        </p:txBody>
+      </p:sp>
+      <p:sp>
+        <p:nvSpPr>
+          <p:cNvPr id="5" name="Footer Placeholder 4">
+            <a:extLst>
+              <a:ext uri="{FF2B5EF4-FFF2-40B4-BE49-F238E27FC236}">
+                <a16:creationId xmlns:a16="http://schemas.microsoft.com/office/drawing/2014/main" id="{825A3C1F-1A9B-AC26-34A2-FE3C12AC26EB}"/>
+              </a:ext>
+            </a:extLst>
+          </p:cNvPr>
+          <p:cNvSpPr>
+            <a:spLocks noGrp="1"/>
+          </p:cNvSpPr>
+          <p:nvPr>
+            <p:ph type="ftr" sz="quarter" idx="11"/>
+          </p:nvPr>
+        </p:nvSpPr>
+        <p:spPr/>
+        <p:txBody>
+          <a:bodyPr/>
+          <a:lstStyle/>
+          <a:p>
+            <a:endParaRPr lang="en-US"/>
+          </a:p>
+        </p:txBody>
+      </p:sp>
+      <p:sp>
+        <p:nvSpPr>
+          <p:cNvPr id="6" name="Slide Number Placeholder 5">
+            <a:extLst>
+              <a:ext uri="{FF2B5EF4-FFF2-40B4-BE49-F238E27FC236}">
+                <a16:creationId xmlns:a16="http://schemas.microsoft.com/office/drawing/2014/main" id="{85AD75B3-0B51-C3FC-BD52-AD7739A5BC9A}"/>
+              </a:ext>
+            </a:extLst>
+          </p:cNvPr>
+          <p:cNvSpPr>
+            <a:spLocks noGrp="1"/>
+          </p:cNvSpPr>
+          <p:nvPr>
+            <p:ph type="sldNum" sz="quarter" idx="12"/>
+          </p:nvPr>
+        </p:nvSpPr>
+        <p:spPr/>
+        <p:txBody>
+          <a:bodyPr/>
+          <a:lstStyle/>
+          <a:p>
+            <a:fld id="{3A73CC0E-67D5-43FD-BD59-BE5F44570CB2}" type="slidenum">
+              <a:rPr lang="en-GB" smtClean="0"/>
+              <a:pPr/>
+              <a:t>‹#›</a:t>
+            </a:fld>
+            <a:endParaRPr lang="en-GB"/>
+          </a:p>
+        </p:txBody>
+      </p:sp>
+    </p:spTree>
+    <p:extLst>
+      <p:ext uri="{BB962C8B-B14F-4D97-AF65-F5344CB8AC3E}">
+        <p14:creationId xmlns:p14="http://schemas.microsoft.com/office/powerpoint/2010/main" val="2443293081"/>
+      </p:ext>
+    </p:extLst>
+  </p:cSld>
+  <p:clrMapOvr>
+    <a:masterClrMapping/>
+  </p:clrMapOvr>
+</p:sldLayout>
+</file>
+
+<file path=ppt/slideLayouts/slideLayout15.xml><?xml version="1.0" encoding="utf-8"?>
+<p:sldLayout xmlns:a="http://schemas.openxmlformats.org/drawingml/2006/main" xmlns:r="http://schemas.openxmlformats.org/officeDocument/2006/relationships" xmlns:p="http://schemas.openxmlformats.org/presentationml/2006/main" type="secHead" preserve="1">
+  <p:cSld name="Section Header">
+    <p:spTree>
+      <p:nvGrpSpPr>
+        <p:cNvPr id="1" name=""/>
+        <p:cNvGrpSpPr/>
+        <p:nvPr/>
+      </p:nvGrpSpPr>
+      <p:grpSpPr>
+        <a:xfrm>
+          <a:off x="0" y="0"/>
+          <a:ext cx="0" cy="0"/>
+          <a:chOff x="0" y="0"/>
+          <a:chExt cx="0" cy="0"/>
+        </a:xfrm>
+      </p:grpSpPr>
+      <p:sp>
+        <p:nvSpPr>
+          <p:cNvPr id="2" name="Title 1">
+            <a:extLst>
+              <a:ext uri="{FF2B5EF4-FFF2-40B4-BE49-F238E27FC236}">
+                <a16:creationId xmlns:a16="http://schemas.microsoft.com/office/drawing/2014/main" id="{F7CCCF8F-FC41-BA54-195B-AB0FDD213AD7}"/>
+              </a:ext>
+            </a:extLst>
+          </p:cNvPr>
+          <p:cNvSpPr>
+            <a:spLocks noGrp="1"/>
+          </p:cNvSpPr>
+          <p:nvPr>
+            <p:ph type="title"/>
+          </p:nvPr>
+        </p:nvSpPr>
+        <p:spPr>
+          <a:xfrm>
+            <a:off x="675878" y="1709739"/>
+            <a:ext cx="8543925" cy="2852737"/>
+          </a:xfrm>
+        </p:spPr>
+        <p:txBody>
+          <a:bodyPr anchor="b"/>
+          <a:lstStyle>
+            <a:lvl1pPr>
+              <a:defRPr sz="4875"/>
+            </a:lvl1pPr>
+          </a:lstStyle>
+          <a:p>
+            <a:r>
+              <a:rPr lang="en-US"/>
+              <a:t>Click to edit Master title style</a:t>
+            </a:r>
+          </a:p>
+        </p:txBody>
+      </p:sp>
+      <p:sp>
+        <p:nvSpPr>
+          <p:cNvPr id="3" name="Text Placeholder 2">
+            <a:extLst>
+              <a:ext uri="{FF2B5EF4-FFF2-40B4-BE49-F238E27FC236}">
+                <a16:creationId xmlns:a16="http://schemas.microsoft.com/office/drawing/2014/main" id="{8CED3621-6A4C-891A-4A9F-8CFAB67210F7}"/>
+              </a:ext>
+            </a:extLst>
+          </p:cNvPr>
+          <p:cNvSpPr>
+            <a:spLocks noGrp="1"/>
+          </p:cNvSpPr>
+          <p:nvPr>
+            <p:ph type="body" idx="1"/>
+          </p:nvPr>
+        </p:nvSpPr>
+        <p:spPr>
+          <a:xfrm>
+            <a:off x="675878" y="4589464"/>
+            <a:ext cx="8543925" cy="1500187"/>
+          </a:xfrm>
+        </p:spPr>
+        <p:txBody>
+          <a:bodyPr/>
+          <a:lstStyle>
+            <a:lvl1pPr marL="0" indent="0">
+              <a:buNone/>
+              <a:defRPr sz="1950">
+                <a:solidFill>
+                  <a:schemeClr val="tx1">
+                    <a:tint val="82000"/>
+                  </a:schemeClr>
+                </a:solidFill>
+              </a:defRPr>
+            </a:lvl1pPr>
+            <a:lvl2pPr marL="371475" indent="0">
+              <a:buNone/>
+              <a:defRPr sz="1625">
+                <a:solidFill>
+                  <a:schemeClr val="tx1">
+                    <a:tint val="82000"/>
+                  </a:schemeClr>
+                </a:solidFill>
+              </a:defRPr>
+            </a:lvl2pPr>
+            <a:lvl3pPr marL="742950" indent="0">
+              <a:buNone/>
+              <a:defRPr sz="1463">
+                <a:solidFill>
+                  <a:schemeClr val="tx1">
+                    <a:tint val="82000"/>
+                  </a:schemeClr>
+                </a:solidFill>
+              </a:defRPr>
+            </a:lvl3pPr>
+            <a:lvl4pPr marL="1114425" indent="0">
+              <a:buNone/>
+              <a:defRPr sz="1300">
+                <a:solidFill>
+                  <a:schemeClr val="tx1">
+                    <a:tint val="82000"/>
+                  </a:schemeClr>
+                </a:solidFill>
+              </a:defRPr>
+            </a:lvl4pPr>
+            <a:lvl5pPr marL="1485900" indent="0">
+              <a:buNone/>
+              <a:defRPr sz="1300">
+                <a:solidFill>
+                  <a:schemeClr val="tx1">
+                    <a:tint val="82000"/>
+                  </a:schemeClr>
+                </a:solidFill>
+              </a:defRPr>
+            </a:lvl5pPr>
+            <a:lvl6pPr marL="1857375" indent="0">
+              <a:buNone/>
+              <a:defRPr sz="1300">
+                <a:solidFill>
+                  <a:schemeClr val="tx1">
+                    <a:tint val="82000"/>
+                  </a:schemeClr>
+                </a:solidFill>
+              </a:defRPr>
+            </a:lvl6pPr>
+            <a:lvl7pPr marL="2228850" indent="0">
+              <a:buNone/>
+              <a:defRPr sz="1300">
+                <a:solidFill>
+                  <a:schemeClr val="tx1">
+                    <a:tint val="82000"/>
+                  </a:schemeClr>
+                </a:solidFill>
+              </a:defRPr>
+            </a:lvl7pPr>
+            <a:lvl8pPr marL="2600325" indent="0">
+              <a:buNone/>
+              <a:defRPr sz="1300">
+                <a:solidFill>
+                  <a:schemeClr val="tx1">
+                    <a:tint val="82000"/>
+                  </a:schemeClr>
+                </a:solidFill>
+              </a:defRPr>
+            </a:lvl8pPr>
+            <a:lvl9pPr marL="2971800" indent="0">
+              <a:buNone/>
+              <a:defRPr sz="1300">
+                <a:solidFill>
+                  <a:schemeClr val="tx1">
+                    <a:tint val="82000"/>
+                  </a:schemeClr>
+                </a:solidFill>
+              </a:defRPr>
+            </a:lvl9pPr>
+          </a:lstStyle>
+          <a:p>
+            <a:pPr lvl="0"/>
+            <a:r>
+              <a:rPr lang="en-US"/>
+              <a:t>Click to edit Master text styles</a:t>
+            </a:r>
+          </a:p>
+        </p:txBody>
+      </p:sp>
+      <p:sp>
+        <p:nvSpPr>
+          <p:cNvPr id="4" name="Date Placeholder 3">
+            <a:extLst>
+              <a:ext uri="{FF2B5EF4-FFF2-40B4-BE49-F238E27FC236}">
+                <a16:creationId xmlns:a16="http://schemas.microsoft.com/office/drawing/2014/main" id="{D79F9C5B-09A7-AACE-5899-6C43CC7D6957}"/>
+              </a:ext>
+            </a:extLst>
+          </p:cNvPr>
+          <p:cNvSpPr>
+            <a:spLocks noGrp="1"/>
+          </p:cNvSpPr>
+          <p:nvPr>
+            <p:ph type="dt" sz="half" idx="10"/>
+          </p:nvPr>
+        </p:nvSpPr>
+        <p:spPr/>
+        <p:txBody>
+          <a:bodyPr/>
+          <a:lstStyle/>
+          <a:p>
+            <a:fld id="{6F80DDAC-FE11-49DC-9261-11C1E994665B}" type="datetimeFigureOut">
+              <a:rPr lang="en-GB" smtClean="0"/>
+              <a:pPr/>
+              <a:t>29/07/2026</a:t>
+            </a:fld>
+            <a:endParaRPr lang="en-GB"/>
+          </a:p>
+        </p:txBody>
+      </p:sp>
+      <p:sp>
+        <p:nvSpPr>
+          <p:cNvPr id="5" name="Footer Placeholder 4">
+            <a:extLst>
+              <a:ext uri="{FF2B5EF4-FFF2-40B4-BE49-F238E27FC236}">
+                <a16:creationId xmlns:a16="http://schemas.microsoft.com/office/drawing/2014/main" id="{2418391A-998C-6522-EB07-BBADB269BF14}"/>
+              </a:ext>
+            </a:extLst>
+          </p:cNvPr>
+          <p:cNvSpPr>
+            <a:spLocks noGrp="1"/>
+          </p:cNvSpPr>
+          <p:nvPr>
+            <p:ph type="ftr" sz="quarter" idx="11"/>
+          </p:nvPr>
+        </p:nvSpPr>
+        <p:spPr/>
+        <p:txBody>
+          <a:bodyPr/>
+          <a:lstStyle/>
+          <a:p>
+            <a:endParaRPr lang="en-US"/>
+          </a:p>
+        </p:txBody>
+      </p:sp>
+      <p:sp>
+        <p:nvSpPr>
+          <p:cNvPr id="6" name="Slide Number Placeholder 5">
+            <a:extLst>
+              <a:ext uri="{FF2B5EF4-FFF2-40B4-BE49-F238E27FC236}">
+                <a16:creationId xmlns:a16="http://schemas.microsoft.com/office/drawing/2014/main" id="{B059B3E3-80F3-C318-AE69-CC2389B551D5}"/>
+              </a:ext>
+            </a:extLst>
+          </p:cNvPr>
+          <p:cNvSpPr>
+            <a:spLocks noGrp="1"/>
+          </p:cNvSpPr>
+          <p:nvPr>
+            <p:ph type="sldNum" sz="quarter" idx="12"/>
+          </p:nvPr>
+        </p:nvSpPr>
+        <p:spPr/>
+        <p:txBody>
+          <a:bodyPr/>
+          <a:lstStyle/>
+          <a:p>
+            <a:fld id="{3A73CC0E-67D5-43FD-BD59-BE5F44570CB2}" type="slidenum">
+              <a:rPr lang="en-GB" smtClean="0"/>
+              <a:pPr/>
+              <a:t>‹#›</a:t>
+            </a:fld>
+            <a:endParaRPr lang="en-GB"/>
+          </a:p>
+        </p:txBody>
+      </p:sp>
+    </p:spTree>
+    <p:extLst>
+      <p:ext uri="{BB962C8B-B14F-4D97-AF65-F5344CB8AC3E}">
+        <p14:creationId xmlns:p14="http://schemas.microsoft.com/office/powerpoint/2010/main" val="2828134974"/>
+      </p:ext>
+    </p:extLst>
+  </p:cSld>
+  <p:clrMapOvr>
+    <a:masterClrMapping/>
+  </p:clrMapOvr>
+</p:sldLayout>
+</file>
+
+<file path=ppt/slideLayouts/slideLayout16.xml><?xml version="1.0" encoding="utf-8"?>
+<p:sldLayout xmlns:a="http://schemas.openxmlformats.org/drawingml/2006/main" xmlns:r="http://schemas.openxmlformats.org/officeDocument/2006/relationships" xmlns:p="http://schemas.openxmlformats.org/presentationml/2006/main" type="twoObj" preserve="1">
+  <p:cSld name="Two Content">
+    <p:spTree>
+      <p:nvGrpSpPr>
+        <p:cNvPr id="1" name=""/>
+        <p:cNvGrpSpPr/>
+        <p:nvPr/>
+      </p:nvGrpSpPr>
+      <p:grpSpPr>
+        <a:xfrm>
+          <a:off x="0" y="0"/>
+          <a:ext cx="0" cy="0"/>
+          <a:chOff x="0" y="0"/>
+          <a:chExt cx="0" cy="0"/>
+        </a:xfrm>
+      </p:grpSpPr>
+      <p:sp>
+        <p:nvSpPr>
+          <p:cNvPr id="2" name="Title 1">
+            <a:extLst>
+              <a:ext uri="{FF2B5EF4-FFF2-40B4-BE49-F238E27FC236}">
+                <a16:creationId xmlns:a16="http://schemas.microsoft.com/office/drawing/2014/main" id="{9EE593B0-5543-FD72-265C-601978B645A7}"/>
+              </a:ext>
+            </a:extLst>
+          </p:cNvPr>
+          <p:cNvSpPr>
+            <a:spLocks noGrp="1"/>
+          </p:cNvSpPr>
+          <p:nvPr>
+            <p:ph type="title"/>
+          </p:nvPr>
+        </p:nvSpPr>
+        <p:spPr/>
+        <p:txBody>
+          <a:bodyPr/>
+          <a:lstStyle/>
+          <a:p>
+            <a:r>
+              <a:rPr lang="en-US"/>
+              <a:t>Click to edit Master title style</a:t>
+            </a:r>
+          </a:p>
+        </p:txBody>
+      </p:sp>
+      <p:sp>
+        <p:nvSpPr>
+          <p:cNvPr id="3" name="Content Placeholder 2">
+            <a:extLst>
+              <a:ext uri="{FF2B5EF4-FFF2-40B4-BE49-F238E27FC236}">
+                <a16:creationId xmlns:a16="http://schemas.microsoft.com/office/drawing/2014/main" id="{B7717A1B-1A5C-C49C-1DCB-A4D85232FE22}"/>
+              </a:ext>
+            </a:extLst>
+          </p:cNvPr>
+          <p:cNvSpPr>
+            <a:spLocks noGrp="1"/>
+          </p:cNvSpPr>
+          <p:nvPr>
+            <p:ph sz="half" idx="1"/>
+          </p:nvPr>
+        </p:nvSpPr>
+        <p:spPr>
+          <a:xfrm>
+            <a:off x="681038" y="1825625"/>
+            <a:ext cx="4210050" cy="4351338"/>
+          </a:xfrm>
+        </p:spPr>
+        <p:txBody>
+          <a:bodyPr/>
+          <a:lstStyle/>
+          <a:p>
+            <a:pPr lvl="0"/>
+            <a:r>
+              <a:rPr lang="en-US"/>
+              <a:t>Click to edit Master text styles</a:t>
+            </a:r>
+          </a:p>
+          <a:p>
+            <a:pPr lvl="1"/>
+            <a:r>
+              <a:rPr lang="en-US"/>
+              <a:t>Second level</a:t>
+            </a:r>
+          </a:p>
+          <a:p>
+            <a:pPr lvl="2"/>
+            <a:r>
+              <a:rPr lang="en-US"/>
+              <a:t>Third level</a:t>
+            </a:r>
+          </a:p>
+          <a:p>
+            <a:pPr lvl="3"/>
+            <a:r>
+              <a:rPr lang="en-US"/>
+              <a:t>Fourth level</a:t>
+            </a:r>
+          </a:p>
+          <a:p>
+            <a:pPr lvl="4"/>
+            <a:r>
+              <a:rPr lang="en-US"/>
+              <a:t>Fifth level</a:t>
+            </a:r>
+          </a:p>
+        </p:txBody>
+      </p:sp>
+      <p:sp>
+        <p:nvSpPr>
+          <p:cNvPr id="4" name="Content Placeholder 3">
+            <a:extLst>
+              <a:ext uri="{FF2B5EF4-FFF2-40B4-BE49-F238E27FC236}">
+                <a16:creationId xmlns:a16="http://schemas.microsoft.com/office/drawing/2014/main" id="{48866F6E-92F7-4DE2-94AA-93F66ECA0EB9}"/>
+              </a:ext>
+            </a:extLst>
+          </p:cNvPr>
+          <p:cNvSpPr>
+            <a:spLocks noGrp="1"/>
+          </p:cNvSpPr>
+          <p:nvPr>
+            <p:ph sz="half" idx="2"/>
+          </p:nvPr>
+        </p:nvSpPr>
+        <p:spPr>
+          <a:xfrm>
+            <a:off x="5014913" y="1825625"/>
+            <a:ext cx="4210050" cy="4351338"/>
+          </a:xfrm>
+        </p:spPr>
+        <p:txBody>
+          <a:bodyPr/>
+          <a:lstStyle/>
+          <a:p>
+            <a:pPr lvl="0"/>
+            <a:r>
+              <a:rPr lang="en-US"/>
+              <a:t>Click to edit Master text styles</a:t>
+            </a:r>
+          </a:p>
+          <a:p>
+            <a:pPr lvl="1"/>
+            <a:r>
+              <a:rPr lang="en-US"/>
+              <a:t>Second level</a:t>
+            </a:r>
+          </a:p>
+          <a:p>
+            <a:pPr lvl="2"/>
+            <a:r>
+              <a:rPr lang="en-US"/>
+              <a:t>Third level</a:t>
+            </a:r>
+          </a:p>
+          <a:p>
+            <a:pPr lvl="3"/>
+            <a:r>
+              <a:rPr lang="en-US"/>
+              <a:t>Fourth level</a:t>
+            </a:r>
+          </a:p>
+          <a:p>
+            <a:pPr lvl="4"/>
+            <a:r>
+              <a:rPr lang="en-US"/>
+              <a:t>Fifth level</a:t>
+            </a:r>
+          </a:p>
+        </p:txBody>
+      </p:sp>
+      <p:sp>
+        <p:nvSpPr>
+          <p:cNvPr id="5" name="Date Placeholder 4">
+            <a:extLst>
+              <a:ext uri="{FF2B5EF4-FFF2-40B4-BE49-F238E27FC236}">
+                <a16:creationId xmlns:a16="http://schemas.microsoft.com/office/drawing/2014/main" id="{B139B6FA-F1AE-16C1-0F53-BED48027C798}"/>
+              </a:ext>
+            </a:extLst>
+          </p:cNvPr>
+          <p:cNvSpPr>
+            <a:spLocks noGrp="1"/>
+          </p:cNvSpPr>
+          <p:nvPr>
+            <p:ph type="dt" sz="half" idx="10"/>
+          </p:nvPr>
+        </p:nvSpPr>
+        <p:spPr/>
+        <p:txBody>
+          <a:bodyPr/>
+          <a:lstStyle/>
+          <a:p>
+            <a:fld id="{6F80DDAC-FE11-49DC-9261-11C1E994665B}" type="datetimeFigureOut">
+              <a:rPr lang="en-GB" smtClean="0"/>
+              <a:pPr/>
+              <a:t>29/07/2026</a:t>
+            </a:fld>
+            <a:endParaRPr lang="en-GB"/>
+          </a:p>
+        </p:txBody>
+      </p:sp>
+      <p:sp>
+        <p:nvSpPr>
+          <p:cNvPr id="6" name="Footer Placeholder 5">
+            <a:extLst>
+              <a:ext uri="{FF2B5EF4-FFF2-40B4-BE49-F238E27FC236}">
+                <a16:creationId xmlns:a16="http://schemas.microsoft.com/office/drawing/2014/main" id="{3303BDA8-F3F8-F242-735E-85C7C2C32E6E}"/>
+              </a:ext>
+            </a:extLst>
+          </p:cNvPr>
+          <p:cNvSpPr>
+            <a:spLocks noGrp="1"/>
+          </p:cNvSpPr>
+          <p:nvPr>
+            <p:ph type="ftr" sz="quarter" idx="11"/>
+          </p:nvPr>
+        </p:nvSpPr>
+        <p:spPr/>
+        <p:txBody>
+          <a:bodyPr/>
+          <a:lstStyle/>
+          <a:p>
+            <a:endParaRPr lang="en-US"/>
+          </a:p>
+        </p:txBody>
+      </p:sp>
+      <p:sp>
+        <p:nvSpPr>
+          <p:cNvPr id="7" name="Slide Number Placeholder 6">
+            <a:extLst>
+              <a:ext uri="{FF2B5EF4-FFF2-40B4-BE49-F238E27FC236}">
+                <a16:creationId xmlns:a16="http://schemas.microsoft.com/office/drawing/2014/main" id="{F915B592-7087-A77B-3B2B-1D78D9EBEC80}"/>
+              </a:ext>
+            </a:extLst>
+          </p:cNvPr>
+          <p:cNvSpPr>
+            <a:spLocks noGrp="1"/>
+          </p:cNvSpPr>
+          <p:nvPr>
+            <p:ph type="sldNum" sz="quarter" idx="12"/>
+          </p:nvPr>
+        </p:nvSpPr>
+        <p:spPr/>
+        <p:txBody>
+          <a:bodyPr/>
+          <a:lstStyle/>
+          <a:p>
+            <a:fld id="{3A73CC0E-67D5-43FD-BD59-BE5F44570CB2}" type="slidenum">
+              <a:rPr lang="en-GB" smtClean="0"/>
+              <a:pPr/>
+              <a:t>‹#›</a:t>
+            </a:fld>
+            <a:endParaRPr lang="en-GB"/>
+          </a:p>
+        </p:txBody>
+      </p:sp>
+    </p:spTree>
+    <p:extLst>
+      <p:ext uri="{BB962C8B-B14F-4D97-AF65-F5344CB8AC3E}">
+        <p14:creationId xmlns:p14="http://schemas.microsoft.com/office/powerpoint/2010/main" val="2617435831"/>
+      </p:ext>
+    </p:extLst>
+  </p:cSld>
+  <p:clrMapOvr>
+    <a:masterClrMapping/>
+  </p:clrMapOvr>
+</p:sldLayout>
+</file>
+
+<file path=ppt/slideLayouts/slideLayout17.xml><?xml version="1.0" encoding="utf-8"?>
+<p:sldLayout xmlns:a="http://schemas.openxmlformats.org/drawingml/2006/main" xmlns:r="http://schemas.openxmlformats.org/officeDocument/2006/relationships" xmlns:p="http://schemas.openxmlformats.org/presentationml/2006/main" type="twoTxTwoObj" preserve="1">
+  <p:cSld name="Comparison">
+    <p:spTree>
+      <p:nvGrpSpPr>
+        <p:cNvPr id="1" name=""/>
+        <p:cNvGrpSpPr/>
+        <p:nvPr/>
+      </p:nvGrpSpPr>
+      <p:grpSpPr>
+        <a:xfrm>
+          <a:off x="0" y="0"/>
+          <a:ext cx="0" cy="0"/>
+          <a:chOff x="0" y="0"/>
+          <a:chExt cx="0" cy="0"/>
+        </a:xfrm>
+      </p:grpSpPr>
+      <p:sp>
+        <p:nvSpPr>
+          <p:cNvPr id="2" name="Title 1">
+            <a:extLst>
+              <a:ext uri="{FF2B5EF4-FFF2-40B4-BE49-F238E27FC236}">
+                <a16:creationId xmlns:a16="http://schemas.microsoft.com/office/drawing/2014/main" id="{CB6784EC-9816-8C42-4A2D-296F1A38341E}"/>
+              </a:ext>
+            </a:extLst>
+          </p:cNvPr>
+          <p:cNvSpPr>
+            <a:spLocks noGrp="1"/>
+          </p:cNvSpPr>
+          <p:nvPr>
+            <p:ph type="title"/>
+          </p:nvPr>
+        </p:nvSpPr>
+        <p:spPr>
+          <a:xfrm>
+            <a:off x="682328" y="365126"/>
+            <a:ext cx="8543925" cy="1325563"/>
+          </a:xfrm>
+        </p:spPr>
+        <p:txBody>
+          <a:bodyPr/>
+          <a:lstStyle/>
+          <a:p>
+            <a:r>
+              <a:rPr lang="en-US"/>
+              <a:t>Click to edit Master title style</a:t>
+            </a:r>
+          </a:p>
+        </p:txBody>
+      </p:sp>
+      <p:sp>
+        <p:nvSpPr>
+          <p:cNvPr id="3" name="Text Placeholder 2">
+            <a:extLst>
+              <a:ext uri="{FF2B5EF4-FFF2-40B4-BE49-F238E27FC236}">
+                <a16:creationId xmlns:a16="http://schemas.microsoft.com/office/drawing/2014/main" id="{6646B347-D4D6-CB98-1E64-CCAAE65E5D7A}"/>
+              </a:ext>
+            </a:extLst>
+          </p:cNvPr>
+          <p:cNvSpPr>
+            <a:spLocks noGrp="1"/>
+          </p:cNvSpPr>
+          <p:nvPr>
+            <p:ph type="body" idx="1"/>
+          </p:nvPr>
+        </p:nvSpPr>
+        <p:spPr>
+          <a:xfrm>
+            <a:off x="682328" y="1681163"/>
+            <a:ext cx="4190702" cy="823912"/>
+          </a:xfrm>
+        </p:spPr>
+        <p:txBody>
+          <a:bodyPr anchor="b"/>
+          <a:lstStyle>
+            <a:lvl1pPr marL="0" indent="0">
+              <a:buNone/>
+              <a:defRPr sz="1950" b="1"/>
+            </a:lvl1pPr>
+            <a:lvl2pPr marL="371475" indent="0">
+              <a:buNone/>
+              <a:defRPr sz="1625" b="1"/>
+            </a:lvl2pPr>
+            <a:lvl3pPr marL="742950" indent="0">
+              <a:buNone/>
+              <a:defRPr sz="1463" b="1"/>
+            </a:lvl3pPr>
+            <a:lvl4pPr marL="1114425" indent="0">
+              <a:buNone/>
+              <a:defRPr sz="1300" b="1"/>
+            </a:lvl4pPr>
+            <a:lvl5pPr marL="1485900" indent="0">
+              <a:buNone/>
+              <a:defRPr sz="1300" b="1"/>
+            </a:lvl5pPr>
+            <a:lvl6pPr marL="1857375" indent="0">
+              <a:buNone/>
+              <a:defRPr sz="1300" b="1"/>
+            </a:lvl6pPr>
+            <a:lvl7pPr marL="2228850" indent="0">
+              <a:buNone/>
+              <a:defRPr sz="1300" b="1"/>
+            </a:lvl7pPr>
+            <a:lvl8pPr marL="2600325" indent="0">
+              <a:buNone/>
+              <a:defRPr sz="1300" b="1"/>
+            </a:lvl8pPr>
+            <a:lvl9pPr marL="2971800" indent="0">
+              <a:buNone/>
+              <a:defRPr sz="1300" b="1"/>
+            </a:lvl9pPr>
+          </a:lstStyle>
+          <a:p>
+            <a:pPr lvl="0"/>
+            <a:r>
+              <a:rPr lang="en-US"/>
+              <a:t>Click to edit Master text styles</a:t>
+            </a:r>
+          </a:p>
+        </p:txBody>
+      </p:sp>
+      <p:sp>
+        <p:nvSpPr>
+          <p:cNvPr id="4" name="Content Placeholder 3">
+            <a:extLst>
+              <a:ext uri="{FF2B5EF4-FFF2-40B4-BE49-F238E27FC236}">
+                <a16:creationId xmlns:a16="http://schemas.microsoft.com/office/drawing/2014/main" id="{5C7B7206-5AE9-8437-3DCF-E86B48DD1D51}"/>
+              </a:ext>
+            </a:extLst>
+          </p:cNvPr>
+          <p:cNvSpPr>
+            <a:spLocks noGrp="1"/>
+          </p:cNvSpPr>
+          <p:nvPr>
+            <p:ph sz="half" idx="2"/>
+          </p:nvPr>
+        </p:nvSpPr>
+        <p:spPr>
+          <a:xfrm>
+            <a:off x="682328" y="2505075"/>
+            <a:ext cx="4190702" cy="3684588"/>
+          </a:xfrm>
+        </p:spPr>
+        <p:txBody>
+          <a:bodyPr/>
+          <a:lstStyle/>
+          <a:p>
+            <a:pPr lvl="0"/>
+            <a:r>
+              <a:rPr lang="en-US"/>
+              <a:t>Click to edit Master text styles</a:t>
+            </a:r>
+          </a:p>
+          <a:p>
+            <a:pPr lvl="1"/>
+            <a:r>
+              <a:rPr lang="en-US"/>
+              <a:t>Second level</a:t>
+            </a:r>
+          </a:p>
+          <a:p>
+            <a:pPr lvl="2"/>
+            <a:r>
+              <a:rPr lang="en-US"/>
+              <a:t>Third level</a:t>
+            </a:r>
+          </a:p>
+          <a:p>
+            <a:pPr lvl="3"/>
+            <a:r>
+              <a:rPr lang="en-US"/>
+              <a:t>Fourth level</a:t>
+            </a:r>
+          </a:p>
+          <a:p>
+            <a:pPr lvl="4"/>
+            <a:r>
+              <a:rPr lang="en-US"/>
+              <a:t>Fifth level</a:t>
+            </a:r>
+          </a:p>
+        </p:txBody>
+      </p:sp>
+      <p:sp>
+        <p:nvSpPr>
+          <p:cNvPr id="5" name="Text Placeholder 4">
+            <a:extLst>
+              <a:ext uri="{FF2B5EF4-FFF2-40B4-BE49-F238E27FC236}">
+                <a16:creationId xmlns:a16="http://schemas.microsoft.com/office/drawing/2014/main" id="{C3AD6CF7-7157-DA71-23AF-44C6E862B892}"/>
+              </a:ext>
+            </a:extLst>
+          </p:cNvPr>
+          <p:cNvSpPr>
+            <a:spLocks noGrp="1"/>
+          </p:cNvSpPr>
+          <p:nvPr>
+            <p:ph type="body" sz="quarter" idx="3"/>
+          </p:nvPr>
+        </p:nvSpPr>
+        <p:spPr>
+          <a:xfrm>
+            <a:off x="5014913" y="1681163"/>
+            <a:ext cx="4211340" cy="823912"/>
+          </a:xfrm>
+        </p:spPr>
+        <p:txBody>
+          <a:bodyPr anchor="b"/>
+          <a:lstStyle>
+            <a:lvl1pPr marL="0" indent="0">
+              <a:buNone/>
+              <a:defRPr sz="1950" b="1"/>
+            </a:lvl1pPr>
+            <a:lvl2pPr marL="371475" indent="0">
+              <a:buNone/>
+              <a:defRPr sz="1625" b="1"/>
+            </a:lvl2pPr>
+            <a:lvl3pPr marL="742950" indent="0">
+              <a:buNone/>
+              <a:defRPr sz="1463" b="1"/>
+            </a:lvl3pPr>
+            <a:lvl4pPr marL="1114425" indent="0">
+              <a:buNone/>
+              <a:defRPr sz="1300" b="1"/>
+            </a:lvl4pPr>
+            <a:lvl5pPr marL="1485900" indent="0">
+              <a:buNone/>
+              <a:defRPr sz="1300" b="1"/>
+            </a:lvl5pPr>
+            <a:lvl6pPr marL="1857375" indent="0">
+              <a:buNone/>
+              <a:defRPr sz="1300" b="1"/>
+            </a:lvl6pPr>
+            <a:lvl7pPr marL="2228850" indent="0">
+              <a:buNone/>
+              <a:defRPr sz="1300" b="1"/>
+            </a:lvl7pPr>
+            <a:lvl8pPr marL="2600325" indent="0">
+              <a:buNone/>
+              <a:defRPr sz="1300" b="1"/>
+            </a:lvl8pPr>
+            <a:lvl9pPr marL="2971800" indent="0">
+              <a:buNone/>
+              <a:defRPr sz="1300" b="1"/>
+            </a:lvl9pPr>
+          </a:lstStyle>
+          <a:p>
+            <a:pPr lvl="0"/>
+            <a:r>
+              <a:rPr lang="en-US"/>
+              <a:t>Click to edit Master text styles</a:t>
+            </a:r>
+          </a:p>
+        </p:txBody>
+      </p:sp>
+      <p:sp>
+        <p:nvSpPr>
+          <p:cNvPr id="6" name="Content Placeholder 5">
+            <a:extLst>
+              <a:ext uri="{FF2B5EF4-FFF2-40B4-BE49-F238E27FC236}">
+                <a16:creationId xmlns:a16="http://schemas.microsoft.com/office/drawing/2014/main" id="{0FF685C0-509A-B904-DA26-4520A0B8CA29}"/>
+              </a:ext>
+            </a:extLst>
+          </p:cNvPr>
+          <p:cNvSpPr>
+            <a:spLocks noGrp="1"/>
+          </p:cNvSpPr>
+          <p:nvPr>
+            <p:ph sz="quarter" idx="4"/>
+          </p:nvPr>
+        </p:nvSpPr>
+        <p:spPr>
+          <a:xfrm>
+            <a:off x="5014913" y="2505075"/>
+            <a:ext cx="4211340" cy="3684588"/>
+          </a:xfrm>
+        </p:spPr>
+        <p:txBody>
+          <a:bodyPr/>
+          <a:lstStyle/>
+          <a:p>
+            <a:pPr lvl="0"/>
+            <a:r>
+              <a:rPr lang="en-US"/>
+              <a:t>Click to edit Master text styles</a:t>
+            </a:r>
+          </a:p>
+          <a:p>
+            <a:pPr lvl="1"/>
+            <a:r>
+              <a:rPr lang="en-US"/>
+              <a:t>Second level</a:t>
+            </a:r>
+          </a:p>
+          <a:p>
+            <a:pPr lvl="2"/>
+            <a:r>
+              <a:rPr lang="en-US"/>
+              <a:t>Third level</a:t>
+            </a:r>
+          </a:p>
+          <a:p>
+            <a:pPr lvl="3"/>
+            <a:r>
+              <a:rPr lang="en-US"/>
+              <a:t>Fourth level</a:t>
+            </a:r>
+          </a:p>
+          <a:p>
+            <a:pPr lvl="4"/>
+            <a:r>
+              <a:rPr lang="en-US"/>
+              <a:t>Fifth level</a:t>
+            </a:r>
+          </a:p>
+        </p:txBody>
+      </p:sp>
+      <p:sp>
+        <p:nvSpPr>
+          <p:cNvPr id="7" name="Date Placeholder 6">
+            <a:extLst>
+              <a:ext uri="{FF2B5EF4-FFF2-40B4-BE49-F238E27FC236}">
+                <a16:creationId xmlns:a16="http://schemas.microsoft.com/office/drawing/2014/main" id="{699FFE35-A219-9C26-3E28-8C0B65690425}"/>
+              </a:ext>
+            </a:extLst>
+          </p:cNvPr>
+          <p:cNvSpPr>
+            <a:spLocks noGrp="1"/>
+          </p:cNvSpPr>
+          <p:nvPr>
+            <p:ph type="dt" sz="half" idx="10"/>
+          </p:nvPr>
+        </p:nvSpPr>
+        <p:spPr/>
+        <p:txBody>
+          <a:bodyPr/>
+          <a:lstStyle/>
+          <a:p>
+            <a:fld id="{6F80DDAC-FE11-49DC-9261-11C1E994665B}" type="datetimeFigureOut">
+              <a:rPr lang="en-GB" smtClean="0"/>
+              <a:pPr/>
+              <a:t>29/07/2026</a:t>
+            </a:fld>
+            <a:endParaRPr lang="en-GB"/>
+          </a:p>
+        </p:txBody>
+      </p:sp>
+      <p:sp>
+        <p:nvSpPr>
+          <p:cNvPr id="8" name="Footer Placeholder 7">
+            <a:extLst>
+              <a:ext uri="{FF2B5EF4-FFF2-40B4-BE49-F238E27FC236}">
+                <a16:creationId xmlns:a16="http://schemas.microsoft.com/office/drawing/2014/main" id="{189BDAF1-D1A8-865D-87DB-C8FADFFA2EC4}"/>
+              </a:ext>
+            </a:extLst>
+          </p:cNvPr>
+          <p:cNvSpPr>
+            <a:spLocks noGrp="1"/>
+          </p:cNvSpPr>
+          <p:nvPr>
+            <p:ph type="ftr" sz="quarter" idx="11"/>
+          </p:nvPr>
+        </p:nvSpPr>
+        <p:spPr/>
+        <p:txBody>
+          <a:bodyPr/>
+          <a:lstStyle/>
+          <a:p>
+            <a:endParaRPr lang="en-US"/>
+          </a:p>
+        </p:txBody>
+      </p:sp>
+      <p:sp>
+        <p:nvSpPr>
+          <p:cNvPr id="9" name="Slide Number Placeholder 8">
+            <a:extLst>
+              <a:ext uri="{FF2B5EF4-FFF2-40B4-BE49-F238E27FC236}">
+                <a16:creationId xmlns:a16="http://schemas.microsoft.com/office/drawing/2014/main" id="{FD12CC93-F984-AE23-A772-6DF65E0A139A}"/>
+              </a:ext>
+            </a:extLst>
+          </p:cNvPr>
+          <p:cNvSpPr>
+            <a:spLocks noGrp="1"/>
+          </p:cNvSpPr>
+          <p:nvPr>
+            <p:ph type="sldNum" sz="quarter" idx="12"/>
+          </p:nvPr>
+        </p:nvSpPr>
+        <p:spPr/>
+        <p:txBody>
+          <a:bodyPr/>
+          <a:lstStyle/>
+          <a:p>
+            <a:fld id="{3A73CC0E-67D5-43FD-BD59-BE5F44570CB2}" type="slidenum">
+              <a:rPr lang="en-GB" smtClean="0"/>
+              <a:pPr/>
+              <a:t>‹#›</a:t>
+            </a:fld>
+            <a:endParaRPr lang="en-GB"/>
+          </a:p>
+        </p:txBody>
+      </p:sp>
+    </p:spTree>
+    <p:extLst>
+      <p:ext uri="{BB962C8B-B14F-4D97-AF65-F5344CB8AC3E}">
+        <p14:creationId xmlns:p14="http://schemas.microsoft.com/office/powerpoint/2010/main" val="2821268332"/>
+      </p:ext>
+    </p:extLst>
+  </p:cSld>
+  <p:clrMapOvr>
+    <a:masterClrMapping/>
+  </p:clrMapOvr>
+</p:sldLayout>
+</file>
+
+<file path=ppt/slideLayouts/slideLayout18.xml><?xml version="1.0" encoding="utf-8"?>
+<p:sldLayout xmlns:a="http://schemas.openxmlformats.org/drawingml/2006/main" xmlns:r="http://schemas.openxmlformats.org/officeDocument/2006/relationships" xmlns:p="http://schemas.openxmlformats.org/presentationml/2006/main" type="titleOnly" preserve="1">
+  <p:cSld name="Title Only">
+    <p:spTree>
+      <p:nvGrpSpPr>
+        <p:cNvPr id="1" name=""/>
+        <p:cNvGrpSpPr/>
+        <p:nvPr/>
+      </p:nvGrpSpPr>
+      <p:grpSpPr>
+        <a:xfrm>
+          <a:off x="0" y="0"/>
+          <a:ext cx="0" cy="0"/>
+          <a:chOff x="0" y="0"/>
+          <a:chExt cx="0" cy="0"/>
+        </a:xfrm>
+      </p:grpSpPr>
+      <p:sp>
+        <p:nvSpPr>
+          <p:cNvPr id="2" name="Title 1">
+            <a:extLst>
+              <a:ext uri="{FF2B5EF4-FFF2-40B4-BE49-F238E27FC236}">
+                <a16:creationId xmlns:a16="http://schemas.microsoft.com/office/drawing/2014/main" id="{5B053813-8CBC-6EC2-6472-451315FB3E41}"/>
+              </a:ext>
+            </a:extLst>
+          </p:cNvPr>
+          <p:cNvSpPr>
+            <a:spLocks noGrp="1"/>
+          </p:cNvSpPr>
+          <p:nvPr>
+            <p:ph type="title"/>
+          </p:nvPr>
+        </p:nvSpPr>
+        <p:spPr/>
+        <p:txBody>
+          <a:bodyPr/>
+          <a:lstStyle/>
+          <a:p>
+            <a:r>
+              <a:rPr lang="en-US"/>
+              <a:t>Click to edit Master title style</a:t>
+            </a:r>
+          </a:p>
+        </p:txBody>
+      </p:sp>
+      <p:sp>
+        <p:nvSpPr>
+          <p:cNvPr id="3" name="Date Placeholder 2">
+            <a:extLst>
+              <a:ext uri="{FF2B5EF4-FFF2-40B4-BE49-F238E27FC236}">
+                <a16:creationId xmlns:a16="http://schemas.microsoft.com/office/drawing/2014/main" id="{72AF1B0D-A722-7B98-5246-E687C04851EB}"/>
+              </a:ext>
+            </a:extLst>
+          </p:cNvPr>
+          <p:cNvSpPr>
+            <a:spLocks noGrp="1"/>
+          </p:cNvSpPr>
+          <p:nvPr>
+            <p:ph type="dt" sz="half" idx="10"/>
+          </p:nvPr>
+        </p:nvSpPr>
+        <p:spPr/>
+        <p:txBody>
+          <a:bodyPr/>
+          <a:lstStyle/>
+          <a:p>
+            <a:fld id="{6F80DDAC-FE11-49DC-9261-11C1E994665B}" type="datetimeFigureOut">
+              <a:rPr lang="en-GB" smtClean="0"/>
+              <a:pPr/>
+              <a:t>29/07/2026</a:t>
+            </a:fld>
+            <a:endParaRPr lang="en-GB"/>
+          </a:p>
+        </p:txBody>
+      </p:sp>
+      <p:sp>
+        <p:nvSpPr>
+          <p:cNvPr id="4" name="Footer Placeholder 3">
+            <a:extLst>
+              <a:ext uri="{FF2B5EF4-FFF2-40B4-BE49-F238E27FC236}">
+                <a16:creationId xmlns:a16="http://schemas.microsoft.com/office/drawing/2014/main" id="{1369F1F6-743A-5F5A-56CE-5E37FF4D6D81}"/>
+              </a:ext>
+            </a:extLst>
+          </p:cNvPr>
+          <p:cNvSpPr>
+            <a:spLocks noGrp="1"/>
+          </p:cNvSpPr>
+          <p:nvPr>
+            <p:ph type="ftr" sz="quarter" idx="11"/>
+          </p:nvPr>
+        </p:nvSpPr>
+        <p:spPr/>
+        <p:txBody>
+          <a:bodyPr/>
+          <a:lstStyle/>
+          <a:p>
+            <a:endParaRPr lang="en-US"/>
+          </a:p>
+        </p:txBody>
+      </p:sp>
+      <p:sp>
+        <p:nvSpPr>
+          <p:cNvPr id="5" name="Slide Number Placeholder 4">
+            <a:extLst>
+              <a:ext uri="{FF2B5EF4-FFF2-40B4-BE49-F238E27FC236}">
+                <a16:creationId xmlns:a16="http://schemas.microsoft.com/office/drawing/2014/main" id="{2F33372C-6CE0-94BA-CEAA-6E70AC14E331}"/>
+              </a:ext>
+            </a:extLst>
+          </p:cNvPr>
+          <p:cNvSpPr>
+            <a:spLocks noGrp="1"/>
+          </p:cNvSpPr>
+          <p:nvPr>
+            <p:ph type="sldNum" sz="quarter" idx="12"/>
+          </p:nvPr>
+        </p:nvSpPr>
+        <p:spPr/>
+        <p:txBody>
+          <a:bodyPr/>
+          <a:lstStyle/>
+          <a:p>
+            <a:fld id="{3A73CC0E-67D5-43FD-BD59-BE5F44570CB2}" type="slidenum">
+              <a:rPr lang="en-GB" smtClean="0"/>
+              <a:pPr/>
+              <a:t>‹#›</a:t>
+            </a:fld>
+            <a:endParaRPr lang="en-GB"/>
+          </a:p>
+        </p:txBody>
+      </p:sp>
+    </p:spTree>
+    <p:extLst>
+      <p:ext uri="{BB962C8B-B14F-4D97-AF65-F5344CB8AC3E}">
+        <p14:creationId xmlns:p14="http://schemas.microsoft.com/office/powerpoint/2010/main" val="4154055688"/>
+      </p:ext>
+    </p:extLst>
+  </p:cSld>
+  <p:clrMapOvr>
+    <a:masterClrMapping/>
+  </p:clrMapOvr>
+</p:sldLayout>
+</file>
+
+<file path=ppt/slideLayouts/slideLayout19.xml><?xml version="1.0" encoding="utf-8"?>
+<p:sldLayout xmlns:a="http://schemas.openxmlformats.org/drawingml/2006/main" xmlns:r="http://schemas.openxmlformats.org/officeDocument/2006/relationships" xmlns:p="http://schemas.openxmlformats.org/presentationml/2006/main" type="blank" preserve="1">
+  <p:cSld name="Blank">
+    <p:spTree>
+      <p:nvGrpSpPr>
+        <p:cNvPr id="1" name=""/>
+        <p:cNvGrpSpPr/>
+        <p:nvPr/>
+      </p:nvGrpSpPr>
+      <p:grpSpPr>
+        <a:xfrm>
+          <a:off x="0" y="0"/>
+          <a:ext cx="0" cy="0"/>
+          <a:chOff x="0" y="0"/>
+          <a:chExt cx="0" cy="0"/>
+        </a:xfrm>
+      </p:grpSpPr>
+      <p:sp>
+        <p:nvSpPr>
+          <p:cNvPr id="2" name="Date Placeholder 1">
+            <a:extLst>
+              <a:ext uri="{FF2B5EF4-FFF2-40B4-BE49-F238E27FC236}">
+                <a16:creationId xmlns:a16="http://schemas.microsoft.com/office/drawing/2014/main" id="{19E1A100-3ECD-0F08-8FAB-72763E00D570}"/>
+              </a:ext>
+            </a:extLst>
+          </p:cNvPr>
+          <p:cNvSpPr>
+            <a:spLocks noGrp="1"/>
+          </p:cNvSpPr>
+          <p:nvPr>
+            <p:ph type="dt" sz="half" idx="10"/>
+          </p:nvPr>
+        </p:nvSpPr>
+        <p:spPr/>
+        <p:txBody>
+          <a:bodyPr/>
+          <a:lstStyle/>
+          <a:p>
+            <a:fld id="{6F80DDAC-FE11-49DC-9261-11C1E994665B}" type="datetimeFigureOut">
+              <a:rPr lang="en-GB" smtClean="0"/>
+              <a:pPr/>
+              <a:t>29/07/2026</a:t>
+            </a:fld>
+            <a:endParaRPr lang="en-GB"/>
+          </a:p>
+        </p:txBody>
+      </p:sp>
+      <p:sp>
+        <p:nvSpPr>
+          <p:cNvPr id="3" name="Footer Placeholder 2">
+            <a:extLst>
+              <a:ext uri="{FF2B5EF4-FFF2-40B4-BE49-F238E27FC236}">
+                <a16:creationId xmlns:a16="http://schemas.microsoft.com/office/drawing/2014/main" id="{A702BD16-0ED5-38A3-DB97-54E7D2D628E9}"/>
+              </a:ext>
+            </a:extLst>
+          </p:cNvPr>
+          <p:cNvSpPr>
+            <a:spLocks noGrp="1"/>
+          </p:cNvSpPr>
+          <p:nvPr>
+            <p:ph type="ftr" sz="quarter" idx="11"/>
+          </p:nvPr>
+        </p:nvSpPr>
+        <p:spPr/>
+        <p:txBody>
+          <a:bodyPr/>
+          <a:lstStyle/>
+          <a:p>
+            <a:endParaRPr lang="en-US"/>
+          </a:p>
+        </p:txBody>
+      </p:sp>
+      <p:sp>
+        <p:nvSpPr>
+          <p:cNvPr id="4" name="Slide Number Placeholder 3">
+            <a:extLst>
+              <a:ext uri="{FF2B5EF4-FFF2-40B4-BE49-F238E27FC236}">
+                <a16:creationId xmlns:a16="http://schemas.microsoft.com/office/drawing/2014/main" id="{4629CEB7-379E-AD7A-5F8F-72D05B8089FF}"/>
+              </a:ext>
+            </a:extLst>
+          </p:cNvPr>
+          <p:cNvSpPr>
+            <a:spLocks noGrp="1"/>
+          </p:cNvSpPr>
+          <p:nvPr>
+            <p:ph type="sldNum" sz="quarter" idx="12"/>
+          </p:nvPr>
+        </p:nvSpPr>
+        <p:spPr/>
+        <p:txBody>
+          <a:bodyPr/>
+          <a:lstStyle/>
+          <a:p>
+            <a:fld id="{3A73CC0E-67D5-43FD-BD59-BE5F44570CB2}" type="slidenum">
+              <a:rPr lang="en-GB" smtClean="0"/>
+              <a:pPr/>
+              <a:t>‹#›</a:t>
+            </a:fld>
+            <a:endParaRPr lang="en-GB"/>
+          </a:p>
+        </p:txBody>
+      </p:sp>
+    </p:spTree>
+    <p:extLst>
+      <p:ext uri="{BB962C8B-B14F-4D97-AF65-F5344CB8AC3E}">
+        <p14:creationId xmlns:p14="http://schemas.microsoft.com/office/powerpoint/2010/main" val="4056235112"/>
+      </p:ext>
+    </p:extLst>
+  </p:cSld>
+  <p:clrMapOvr>
+    <a:masterClrMapping/>
+  </p:clrMapOvr>
+</p:sldLayout>
+</file>
+
 <file path=ppt/slideLayouts/slideLayout2.xml><?xml version="1.0" encoding="utf-8"?>
 <p:sldLayout xmlns:a="http://schemas.openxmlformats.org/drawingml/2006/main" xmlns:r="http://schemas.openxmlformats.org/officeDocument/2006/relationships" xmlns:p="http://schemas.openxmlformats.org/presentationml/2006/main" preserve="1" userDrawn="1">
   <p:cSld name="Back Cover">
@@ -2065,6 +3704,1307 @@
     <a:masterClrMapping/>
   </p:clrMapOvr>
   <p:hf hdr="0" ftr="0" dt="0"/>
+</p:sldLayout>
+</file>
+
+<file path=ppt/slideLayouts/slideLayout20.xml><?xml version="1.0" encoding="utf-8"?>
+<p:sldLayout xmlns:a="http://schemas.openxmlformats.org/drawingml/2006/main" xmlns:r="http://schemas.openxmlformats.org/officeDocument/2006/relationships" xmlns:p="http://schemas.openxmlformats.org/presentationml/2006/main" type="objTx" preserve="1">
+  <p:cSld name="Content with Caption">
+    <p:spTree>
+      <p:nvGrpSpPr>
+        <p:cNvPr id="1" name=""/>
+        <p:cNvGrpSpPr/>
+        <p:nvPr/>
+      </p:nvGrpSpPr>
+      <p:grpSpPr>
+        <a:xfrm>
+          <a:off x="0" y="0"/>
+          <a:ext cx="0" cy="0"/>
+          <a:chOff x="0" y="0"/>
+          <a:chExt cx="0" cy="0"/>
+        </a:xfrm>
+      </p:grpSpPr>
+      <p:sp>
+        <p:nvSpPr>
+          <p:cNvPr id="2" name="Title 1">
+            <a:extLst>
+              <a:ext uri="{FF2B5EF4-FFF2-40B4-BE49-F238E27FC236}">
+                <a16:creationId xmlns:a16="http://schemas.microsoft.com/office/drawing/2014/main" id="{4A7F6907-CF1C-35E1-F97E-1C5D6F257E40}"/>
+              </a:ext>
+            </a:extLst>
+          </p:cNvPr>
+          <p:cNvSpPr>
+            <a:spLocks noGrp="1"/>
+          </p:cNvSpPr>
+          <p:nvPr>
+            <p:ph type="title"/>
+          </p:nvPr>
+        </p:nvSpPr>
+        <p:spPr>
+          <a:xfrm>
+            <a:off x="682328" y="457200"/>
+            <a:ext cx="3194943" cy="1600200"/>
+          </a:xfrm>
+        </p:spPr>
+        <p:txBody>
+          <a:bodyPr anchor="b"/>
+          <a:lstStyle>
+            <a:lvl1pPr>
+              <a:defRPr sz="2600"/>
+            </a:lvl1pPr>
+          </a:lstStyle>
+          <a:p>
+            <a:r>
+              <a:rPr lang="en-US"/>
+              <a:t>Click to edit Master title style</a:t>
+            </a:r>
+          </a:p>
+        </p:txBody>
+      </p:sp>
+      <p:sp>
+        <p:nvSpPr>
+          <p:cNvPr id="3" name="Content Placeholder 2">
+            <a:extLst>
+              <a:ext uri="{FF2B5EF4-FFF2-40B4-BE49-F238E27FC236}">
+                <a16:creationId xmlns:a16="http://schemas.microsoft.com/office/drawing/2014/main" id="{B556CC27-EBD3-4B45-2A3F-4B0A79F6479C}"/>
+              </a:ext>
+            </a:extLst>
+          </p:cNvPr>
+          <p:cNvSpPr>
+            <a:spLocks noGrp="1"/>
+          </p:cNvSpPr>
+          <p:nvPr>
+            <p:ph idx="1"/>
+          </p:nvPr>
+        </p:nvSpPr>
+        <p:spPr>
+          <a:xfrm>
+            <a:off x="4211340" y="987426"/>
+            <a:ext cx="5014913" cy="4873625"/>
+          </a:xfrm>
+        </p:spPr>
+        <p:txBody>
+          <a:bodyPr/>
+          <a:lstStyle>
+            <a:lvl1pPr>
+              <a:defRPr sz="2600"/>
+            </a:lvl1pPr>
+            <a:lvl2pPr>
+              <a:defRPr sz="2275"/>
+            </a:lvl2pPr>
+            <a:lvl3pPr>
+              <a:defRPr sz="1950"/>
+            </a:lvl3pPr>
+            <a:lvl4pPr>
+              <a:defRPr sz="1625"/>
+            </a:lvl4pPr>
+            <a:lvl5pPr>
+              <a:defRPr sz="1625"/>
+            </a:lvl5pPr>
+            <a:lvl6pPr>
+              <a:defRPr sz="1625"/>
+            </a:lvl6pPr>
+            <a:lvl7pPr>
+              <a:defRPr sz="1625"/>
+            </a:lvl7pPr>
+            <a:lvl8pPr>
+              <a:defRPr sz="1625"/>
+            </a:lvl8pPr>
+            <a:lvl9pPr>
+              <a:defRPr sz="1625"/>
+            </a:lvl9pPr>
+          </a:lstStyle>
+          <a:p>
+            <a:pPr lvl="0"/>
+            <a:r>
+              <a:rPr lang="en-US"/>
+              <a:t>Click to edit Master text styles</a:t>
+            </a:r>
+          </a:p>
+          <a:p>
+            <a:pPr lvl="1"/>
+            <a:r>
+              <a:rPr lang="en-US"/>
+              <a:t>Second level</a:t>
+            </a:r>
+          </a:p>
+          <a:p>
+            <a:pPr lvl="2"/>
+            <a:r>
+              <a:rPr lang="en-US"/>
+              <a:t>Third level</a:t>
+            </a:r>
+          </a:p>
+          <a:p>
+            <a:pPr lvl="3"/>
+            <a:r>
+              <a:rPr lang="en-US"/>
+              <a:t>Fourth level</a:t>
+            </a:r>
+          </a:p>
+          <a:p>
+            <a:pPr lvl="4"/>
+            <a:r>
+              <a:rPr lang="en-US"/>
+              <a:t>Fifth level</a:t>
+            </a:r>
+          </a:p>
+        </p:txBody>
+      </p:sp>
+      <p:sp>
+        <p:nvSpPr>
+          <p:cNvPr id="4" name="Text Placeholder 3">
+            <a:extLst>
+              <a:ext uri="{FF2B5EF4-FFF2-40B4-BE49-F238E27FC236}">
+                <a16:creationId xmlns:a16="http://schemas.microsoft.com/office/drawing/2014/main" id="{7E3E76F3-BCF6-D2FE-2681-301A92CFAB58}"/>
+              </a:ext>
+            </a:extLst>
+          </p:cNvPr>
+          <p:cNvSpPr>
+            <a:spLocks noGrp="1"/>
+          </p:cNvSpPr>
+          <p:nvPr>
+            <p:ph type="body" sz="half" idx="2"/>
+          </p:nvPr>
+        </p:nvSpPr>
+        <p:spPr>
+          <a:xfrm>
+            <a:off x="682328" y="2057400"/>
+            <a:ext cx="3194943" cy="3811588"/>
+          </a:xfrm>
+        </p:spPr>
+        <p:txBody>
+          <a:bodyPr/>
+          <a:lstStyle>
+            <a:lvl1pPr marL="0" indent="0">
+              <a:buNone/>
+              <a:defRPr sz="1300"/>
+            </a:lvl1pPr>
+            <a:lvl2pPr marL="371475" indent="0">
+              <a:buNone/>
+              <a:defRPr sz="1138"/>
+            </a:lvl2pPr>
+            <a:lvl3pPr marL="742950" indent="0">
+              <a:buNone/>
+              <a:defRPr sz="975"/>
+            </a:lvl3pPr>
+            <a:lvl4pPr marL="1114425" indent="0">
+              <a:buNone/>
+              <a:defRPr sz="813"/>
+            </a:lvl4pPr>
+            <a:lvl5pPr marL="1485900" indent="0">
+              <a:buNone/>
+              <a:defRPr sz="813"/>
+            </a:lvl5pPr>
+            <a:lvl6pPr marL="1857375" indent="0">
+              <a:buNone/>
+              <a:defRPr sz="813"/>
+            </a:lvl6pPr>
+            <a:lvl7pPr marL="2228850" indent="0">
+              <a:buNone/>
+              <a:defRPr sz="813"/>
+            </a:lvl7pPr>
+            <a:lvl8pPr marL="2600325" indent="0">
+              <a:buNone/>
+              <a:defRPr sz="813"/>
+            </a:lvl8pPr>
+            <a:lvl9pPr marL="2971800" indent="0">
+              <a:buNone/>
+              <a:defRPr sz="813"/>
+            </a:lvl9pPr>
+          </a:lstStyle>
+          <a:p>
+            <a:pPr lvl="0"/>
+            <a:r>
+              <a:rPr lang="en-US"/>
+              <a:t>Click to edit Master text styles</a:t>
+            </a:r>
+          </a:p>
+        </p:txBody>
+      </p:sp>
+      <p:sp>
+        <p:nvSpPr>
+          <p:cNvPr id="5" name="Date Placeholder 4">
+            <a:extLst>
+              <a:ext uri="{FF2B5EF4-FFF2-40B4-BE49-F238E27FC236}">
+                <a16:creationId xmlns:a16="http://schemas.microsoft.com/office/drawing/2014/main" id="{F9B94648-A232-E19E-7F27-DF25D939E498}"/>
+              </a:ext>
+            </a:extLst>
+          </p:cNvPr>
+          <p:cNvSpPr>
+            <a:spLocks noGrp="1"/>
+          </p:cNvSpPr>
+          <p:nvPr>
+            <p:ph type="dt" sz="half" idx="10"/>
+          </p:nvPr>
+        </p:nvSpPr>
+        <p:spPr/>
+        <p:txBody>
+          <a:bodyPr/>
+          <a:lstStyle/>
+          <a:p>
+            <a:fld id="{6F80DDAC-FE11-49DC-9261-11C1E994665B}" type="datetimeFigureOut">
+              <a:rPr lang="en-GB" smtClean="0"/>
+              <a:pPr/>
+              <a:t>29/07/2026</a:t>
+            </a:fld>
+            <a:endParaRPr lang="en-GB"/>
+          </a:p>
+        </p:txBody>
+      </p:sp>
+      <p:sp>
+        <p:nvSpPr>
+          <p:cNvPr id="6" name="Footer Placeholder 5">
+            <a:extLst>
+              <a:ext uri="{FF2B5EF4-FFF2-40B4-BE49-F238E27FC236}">
+                <a16:creationId xmlns:a16="http://schemas.microsoft.com/office/drawing/2014/main" id="{DC7139CB-4739-DC6B-B8D1-5EB4874B75FF}"/>
+              </a:ext>
+            </a:extLst>
+          </p:cNvPr>
+          <p:cNvSpPr>
+            <a:spLocks noGrp="1"/>
+          </p:cNvSpPr>
+          <p:nvPr>
+            <p:ph type="ftr" sz="quarter" idx="11"/>
+          </p:nvPr>
+        </p:nvSpPr>
+        <p:spPr/>
+        <p:txBody>
+          <a:bodyPr/>
+          <a:lstStyle/>
+          <a:p>
+            <a:endParaRPr lang="en-US"/>
+          </a:p>
+        </p:txBody>
+      </p:sp>
+      <p:sp>
+        <p:nvSpPr>
+          <p:cNvPr id="7" name="Slide Number Placeholder 6">
+            <a:extLst>
+              <a:ext uri="{FF2B5EF4-FFF2-40B4-BE49-F238E27FC236}">
+                <a16:creationId xmlns:a16="http://schemas.microsoft.com/office/drawing/2014/main" id="{7FDC1281-25F7-F770-6D28-94F37807E1F9}"/>
+              </a:ext>
+            </a:extLst>
+          </p:cNvPr>
+          <p:cNvSpPr>
+            <a:spLocks noGrp="1"/>
+          </p:cNvSpPr>
+          <p:nvPr>
+            <p:ph type="sldNum" sz="quarter" idx="12"/>
+          </p:nvPr>
+        </p:nvSpPr>
+        <p:spPr/>
+        <p:txBody>
+          <a:bodyPr/>
+          <a:lstStyle/>
+          <a:p>
+            <a:fld id="{3A73CC0E-67D5-43FD-BD59-BE5F44570CB2}" type="slidenum">
+              <a:rPr lang="en-GB" smtClean="0"/>
+              <a:pPr/>
+              <a:t>‹#›</a:t>
+            </a:fld>
+            <a:endParaRPr lang="en-GB"/>
+          </a:p>
+        </p:txBody>
+      </p:sp>
+    </p:spTree>
+    <p:extLst>
+      <p:ext uri="{BB962C8B-B14F-4D97-AF65-F5344CB8AC3E}">
+        <p14:creationId xmlns:p14="http://schemas.microsoft.com/office/powerpoint/2010/main" val="4135746447"/>
+      </p:ext>
+    </p:extLst>
+  </p:cSld>
+  <p:clrMapOvr>
+    <a:masterClrMapping/>
+  </p:clrMapOvr>
+</p:sldLayout>
+</file>
+
+<file path=ppt/slideLayouts/slideLayout21.xml><?xml version="1.0" encoding="utf-8"?>
+<p:sldLayout xmlns:a="http://schemas.openxmlformats.org/drawingml/2006/main" xmlns:r="http://schemas.openxmlformats.org/officeDocument/2006/relationships" xmlns:p="http://schemas.openxmlformats.org/presentationml/2006/main" type="picTx" preserve="1">
+  <p:cSld name="Picture with Caption">
+    <p:spTree>
+      <p:nvGrpSpPr>
+        <p:cNvPr id="1" name=""/>
+        <p:cNvGrpSpPr/>
+        <p:nvPr/>
+      </p:nvGrpSpPr>
+      <p:grpSpPr>
+        <a:xfrm>
+          <a:off x="0" y="0"/>
+          <a:ext cx="0" cy="0"/>
+          <a:chOff x="0" y="0"/>
+          <a:chExt cx="0" cy="0"/>
+        </a:xfrm>
+      </p:grpSpPr>
+      <p:sp>
+        <p:nvSpPr>
+          <p:cNvPr id="2" name="Title 1">
+            <a:extLst>
+              <a:ext uri="{FF2B5EF4-FFF2-40B4-BE49-F238E27FC236}">
+                <a16:creationId xmlns:a16="http://schemas.microsoft.com/office/drawing/2014/main" id="{68FCF7B5-78C0-68DA-D0CA-E721D6A1895D}"/>
+              </a:ext>
+            </a:extLst>
+          </p:cNvPr>
+          <p:cNvSpPr>
+            <a:spLocks noGrp="1"/>
+          </p:cNvSpPr>
+          <p:nvPr>
+            <p:ph type="title"/>
+          </p:nvPr>
+        </p:nvSpPr>
+        <p:spPr>
+          <a:xfrm>
+            <a:off x="682328" y="457200"/>
+            <a:ext cx="3194943" cy="1600200"/>
+          </a:xfrm>
+        </p:spPr>
+        <p:txBody>
+          <a:bodyPr anchor="b"/>
+          <a:lstStyle>
+            <a:lvl1pPr>
+              <a:defRPr sz="2600"/>
+            </a:lvl1pPr>
+          </a:lstStyle>
+          <a:p>
+            <a:r>
+              <a:rPr lang="en-US"/>
+              <a:t>Click to edit Master title style</a:t>
+            </a:r>
+          </a:p>
+        </p:txBody>
+      </p:sp>
+      <p:sp>
+        <p:nvSpPr>
+          <p:cNvPr id="3" name="Picture Placeholder 2">
+            <a:extLst>
+              <a:ext uri="{FF2B5EF4-FFF2-40B4-BE49-F238E27FC236}">
+                <a16:creationId xmlns:a16="http://schemas.microsoft.com/office/drawing/2014/main" id="{ED58C724-76CE-199C-2F48-12B35E1808C7}"/>
+              </a:ext>
+            </a:extLst>
+          </p:cNvPr>
+          <p:cNvSpPr>
+            <a:spLocks noGrp="1"/>
+          </p:cNvSpPr>
+          <p:nvPr>
+            <p:ph type="pic" idx="1"/>
+          </p:nvPr>
+        </p:nvSpPr>
+        <p:spPr>
+          <a:xfrm>
+            <a:off x="4211340" y="987426"/>
+            <a:ext cx="5014913" cy="4873625"/>
+          </a:xfrm>
+        </p:spPr>
+        <p:txBody>
+          <a:bodyPr/>
+          <a:lstStyle>
+            <a:lvl1pPr marL="0" indent="0">
+              <a:buNone/>
+              <a:defRPr sz="2600"/>
+            </a:lvl1pPr>
+            <a:lvl2pPr marL="371475" indent="0">
+              <a:buNone/>
+              <a:defRPr sz="2275"/>
+            </a:lvl2pPr>
+            <a:lvl3pPr marL="742950" indent="0">
+              <a:buNone/>
+              <a:defRPr sz="1950"/>
+            </a:lvl3pPr>
+            <a:lvl4pPr marL="1114425" indent="0">
+              <a:buNone/>
+              <a:defRPr sz="1625"/>
+            </a:lvl4pPr>
+            <a:lvl5pPr marL="1485900" indent="0">
+              <a:buNone/>
+              <a:defRPr sz="1625"/>
+            </a:lvl5pPr>
+            <a:lvl6pPr marL="1857375" indent="0">
+              <a:buNone/>
+              <a:defRPr sz="1625"/>
+            </a:lvl6pPr>
+            <a:lvl7pPr marL="2228850" indent="0">
+              <a:buNone/>
+              <a:defRPr sz="1625"/>
+            </a:lvl7pPr>
+            <a:lvl8pPr marL="2600325" indent="0">
+              <a:buNone/>
+              <a:defRPr sz="1625"/>
+            </a:lvl8pPr>
+            <a:lvl9pPr marL="2971800" indent="0">
+              <a:buNone/>
+              <a:defRPr sz="1625"/>
+            </a:lvl9pPr>
+          </a:lstStyle>
+          <a:p>
+            <a:endParaRPr lang="en-US"/>
+          </a:p>
+        </p:txBody>
+      </p:sp>
+      <p:sp>
+        <p:nvSpPr>
+          <p:cNvPr id="4" name="Text Placeholder 3">
+            <a:extLst>
+              <a:ext uri="{FF2B5EF4-FFF2-40B4-BE49-F238E27FC236}">
+                <a16:creationId xmlns:a16="http://schemas.microsoft.com/office/drawing/2014/main" id="{0EBC6708-4A56-2AD6-1973-17D4E4BBB660}"/>
+              </a:ext>
+            </a:extLst>
+          </p:cNvPr>
+          <p:cNvSpPr>
+            <a:spLocks noGrp="1"/>
+          </p:cNvSpPr>
+          <p:nvPr>
+            <p:ph type="body" sz="half" idx="2"/>
+          </p:nvPr>
+        </p:nvSpPr>
+        <p:spPr>
+          <a:xfrm>
+            <a:off x="682328" y="2057400"/>
+            <a:ext cx="3194943" cy="3811588"/>
+          </a:xfrm>
+        </p:spPr>
+        <p:txBody>
+          <a:bodyPr/>
+          <a:lstStyle>
+            <a:lvl1pPr marL="0" indent="0">
+              <a:buNone/>
+              <a:defRPr sz="1300"/>
+            </a:lvl1pPr>
+            <a:lvl2pPr marL="371475" indent="0">
+              <a:buNone/>
+              <a:defRPr sz="1138"/>
+            </a:lvl2pPr>
+            <a:lvl3pPr marL="742950" indent="0">
+              <a:buNone/>
+              <a:defRPr sz="975"/>
+            </a:lvl3pPr>
+            <a:lvl4pPr marL="1114425" indent="0">
+              <a:buNone/>
+              <a:defRPr sz="813"/>
+            </a:lvl4pPr>
+            <a:lvl5pPr marL="1485900" indent="0">
+              <a:buNone/>
+              <a:defRPr sz="813"/>
+            </a:lvl5pPr>
+            <a:lvl6pPr marL="1857375" indent="0">
+              <a:buNone/>
+              <a:defRPr sz="813"/>
+            </a:lvl6pPr>
+            <a:lvl7pPr marL="2228850" indent="0">
+              <a:buNone/>
+              <a:defRPr sz="813"/>
+            </a:lvl7pPr>
+            <a:lvl8pPr marL="2600325" indent="0">
+              <a:buNone/>
+              <a:defRPr sz="813"/>
+            </a:lvl8pPr>
+            <a:lvl9pPr marL="2971800" indent="0">
+              <a:buNone/>
+              <a:defRPr sz="813"/>
+            </a:lvl9pPr>
+          </a:lstStyle>
+          <a:p>
+            <a:pPr lvl="0"/>
+            <a:r>
+              <a:rPr lang="en-US"/>
+              <a:t>Click to edit Master text styles</a:t>
+            </a:r>
+          </a:p>
+        </p:txBody>
+      </p:sp>
+      <p:sp>
+        <p:nvSpPr>
+          <p:cNvPr id="5" name="Date Placeholder 4">
+            <a:extLst>
+              <a:ext uri="{FF2B5EF4-FFF2-40B4-BE49-F238E27FC236}">
+                <a16:creationId xmlns:a16="http://schemas.microsoft.com/office/drawing/2014/main" id="{E339DD7A-904D-9541-50D0-324097228DED}"/>
+              </a:ext>
+            </a:extLst>
+          </p:cNvPr>
+          <p:cNvSpPr>
+            <a:spLocks noGrp="1"/>
+          </p:cNvSpPr>
+          <p:nvPr>
+            <p:ph type="dt" sz="half" idx="10"/>
+          </p:nvPr>
+        </p:nvSpPr>
+        <p:spPr/>
+        <p:txBody>
+          <a:bodyPr/>
+          <a:lstStyle/>
+          <a:p>
+            <a:fld id="{6F80DDAC-FE11-49DC-9261-11C1E994665B}" type="datetimeFigureOut">
+              <a:rPr lang="en-GB" smtClean="0"/>
+              <a:pPr/>
+              <a:t>29/07/2026</a:t>
+            </a:fld>
+            <a:endParaRPr lang="en-GB"/>
+          </a:p>
+        </p:txBody>
+      </p:sp>
+      <p:sp>
+        <p:nvSpPr>
+          <p:cNvPr id="6" name="Footer Placeholder 5">
+            <a:extLst>
+              <a:ext uri="{FF2B5EF4-FFF2-40B4-BE49-F238E27FC236}">
+                <a16:creationId xmlns:a16="http://schemas.microsoft.com/office/drawing/2014/main" id="{AEC1D43E-D8EA-6631-57D2-27CC02B595F4}"/>
+              </a:ext>
+            </a:extLst>
+          </p:cNvPr>
+          <p:cNvSpPr>
+            <a:spLocks noGrp="1"/>
+          </p:cNvSpPr>
+          <p:nvPr>
+            <p:ph type="ftr" sz="quarter" idx="11"/>
+          </p:nvPr>
+        </p:nvSpPr>
+        <p:spPr/>
+        <p:txBody>
+          <a:bodyPr/>
+          <a:lstStyle/>
+          <a:p>
+            <a:endParaRPr lang="en-US"/>
+          </a:p>
+        </p:txBody>
+      </p:sp>
+      <p:sp>
+        <p:nvSpPr>
+          <p:cNvPr id="7" name="Slide Number Placeholder 6">
+            <a:extLst>
+              <a:ext uri="{FF2B5EF4-FFF2-40B4-BE49-F238E27FC236}">
+                <a16:creationId xmlns:a16="http://schemas.microsoft.com/office/drawing/2014/main" id="{EDDD0AAE-91E6-6A71-0994-F3398C7EE377}"/>
+              </a:ext>
+            </a:extLst>
+          </p:cNvPr>
+          <p:cNvSpPr>
+            <a:spLocks noGrp="1"/>
+          </p:cNvSpPr>
+          <p:nvPr>
+            <p:ph type="sldNum" sz="quarter" idx="12"/>
+          </p:nvPr>
+        </p:nvSpPr>
+        <p:spPr/>
+        <p:txBody>
+          <a:bodyPr/>
+          <a:lstStyle/>
+          <a:p>
+            <a:fld id="{3A73CC0E-67D5-43FD-BD59-BE5F44570CB2}" type="slidenum">
+              <a:rPr lang="en-GB" smtClean="0"/>
+              <a:pPr/>
+              <a:t>‹#›</a:t>
+            </a:fld>
+            <a:endParaRPr lang="en-GB"/>
+          </a:p>
+        </p:txBody>
+      </p:sp>
+    </p:spTree>
+    <p:extLst>
+      <p:ext uri="{BB962C8B-B14F-4D97-AF65-F5344CB8AC3E}">
+        <p14:creationId xmlns:p14="http://schemas.microsoft.com/office/powerpoint/2010/main" val="2863476953"/>
+      </p:ext>
+    </p:extLst>
+  </p:cSld>
+  <p:clrMapOvr>
+    <a:masterClrMapping/>
+  </p:clrMapOvr>
+</p:sldLayout>
+</file>
+
+<file path=ppt/slideLayouts/slideLayout22.xml><?xml version="1.0" encoding="utf-8"?>
+<p:sldLayout xmlns:a="http://schemas.openxmlformats.org/drawingml/2006/main" xmlns:r="http://schemas.openxmlformats.org/officeDocument/2006/relationships" xmlns:p="http://schemas.openxmlformats.org/presentationml/2006/main" type="vertTx" preserve="1">
+  <p:cSld name="Title and Vertical Text">
+    <p:spTree>
+      <p:nvGrpSpPr>
+        <p:cNvPr id="1" name=""/>
+        <p:cNvGrpSpPr/>
+        <p:nvPr/>
+      </p:nvGrpSpPr>
+      <p:grpSpPr>
+        <a:xfrm>
+          <a:off x="0" y="0"/>
+          <a:ext cx="0" cy="0"/>
+          <a:chOff x="0" y="0"/>
+          <a:chExt cx="0" cy="0"/>
+        </a:xfrm>
+      </p:grpSpPr>
+      <p:sp>
+        <p:nvSpPr>
+          <p:cNvPr id="2" name="Title 1">
+            <a:extLst>
+              <a:ext uri="{FF2B5EF4-FFF2-40B4-BE49-F238E27FC236}">
+                <a16:creationId xmlns:a16="http://schemas.microsoft.com/office/drawing/2014/main" id="{56F05169-F474-260D-B705-70A46DF4C53E}"/>
+              </a:ext>
+            </a:extLst>
+          </p:cNvPr>
+          <p:cNvSpPr>
+            <a:spLocks noGrp="1"/>
+          </p:cNvSpPr>
+          <p:nvPr>
+            <p:ph type="title"/>
+          </p:nvPr>
+        </p:nvSpPr>
+        <p:spPr/>
+        <p:txBody>
+          <a:bodyPr/>
+          <a:lstStyle/>
+          <a:p>
+            <a:r>
+              <a:rPr lang="en-US"/>
+              <a:t>Click to edit Master title style</a:t>
+            </a:r>
+          </a:p>
+        </p:txBody>
+      </p:sp>
+      <p:sp>
+        <p:nvSpPr>
+          <p:cNvPr id="3" name="Vertical Text Placeholder 2">
+            <a:extLst>
+              <a:ext uri="{FF2B5EF4-FFF2-40B4-BE49-F238E27FC236}">
+                <a16:creationId xmlns:a16="http://schemas.microsoft.com/office/drawing/2014/main" id="{1CDEF85A-B4ED-FA31-8264-4CE6C242B938}"/>
+              </a:ext>
+            </a:extLst>
+          </p:cNvPr>
+          <p:cNvSpPr>
+            <a:spLocks noGrp="1"/>
+          </p:cNvSpPr>
+          <p:nvPr>
+            <p:ph type="body" orient="vert" idx="1"/>
+          </p:nvPr>
+        </p:nvSpPr>
+        <p:spPr/>
+        <p:txBody>
+          <a:bodyPr vert="eaVert"/>
+          <a:lstStyle/>
+          <a:p>
+            <a:pPr lvl="0"/>
+            <a:r>
+              <a:rPr lang="en-US"/>
+              <a:t>Click to edit Master text styles</a:t>
+            </a:r>
+          </a:p>
+          <a:p>
+            <a:pPr lvl="1"/>
+            <a:r>
+              <a:rPr lang="en-US"/>
+              <a:t>Second level</a:t>
+            </a:r>
+          </a:p>
+          <a:p>
+            <a:pPr lvl="2"/>
+            <a:r>
+              <a:rPr lang="en-US"/>
+              <a:t>Third level</a:t>
+            </a:r>
+          </a:p>
+          <a:p>
+            <a:pPr lvl="3"/>
+            <a:r>
+              <a:rPr lang="en-US"/>
+              <a:t>Fourth level</a:t>
+            </a:r>
+          </a:p>
+          <a:p>
+            <a:pPr lvl="4"/>
+            <a:r>
+              <a:rPr lang="en-US"/>
+              <a:t>Fifth level</a:t>
+            </a:r>
+          </a:p>
+        </p:txBody>
+      </p:sp>
+      <p:sp>
+        <p:nvSpPr>
+          <p:cNvPr id="4" name="Date Placeholder 3">
+            <a:extLst>
+              <a:ext uri="{FF2B5EF4-FFF2-40B4-BE49-F238E27FC236}">
+                <a16:creationId xmlns:a16="http://schemas.microsoft.com/office/drawing/2014/main" id="{AAF0C1F1-B01A-7A14-5133-211694F27170}"/>
+              </a:ext>
+            </a:extLst>
+          </p:cNvPr>
+          <p:cNvSpPr>
+            <a:spLocks noGrp="1"/>
+          </p:cNvSpPr>
+          <p:nvPr>
+            <p:ph type="dt" sz="half" idx="10"/>
+          </p:nvPr>
+        </p:nvSpPr>
+        <p:spPr/>
+        <p:txBody>
+          <a:bodyPr/>
+          <a:lstStyle/>
+          <a:p>
+            <a:fld id="{6F80DDAC-FE11-49DC-9261-11C1E994665B}" type="datetimeFigureOut">
+              <a:rPr lang="en-GB" smtClean="0"/>
+              <a:pPr/>
+              <a:t>29/07/2026</a:t>
+            </a:fld>
+            <a:endParaRPr lang="en-GB"/>
+          </a:p>
+        </p:txBody>
+      </p:sp>
+      <p:sp>
+        <p:nvSpPr>
+          <p:cNvPr id="5" name="Footer Placeholder 4">
+            <a:extLst>
+              <a:ext uri="{FF2B5EF4-FFF2-40B4-BE49-F238E27FC236}">
+                <a16:creationId xmlns:a16="http://schemas.microsoft.com/office/drawing/2014/main" id="{C889AB10-2B24-46A7-518C-CD230CDCC37C}"/>
+              </a:ext>
+            </a:extLst>
+          </p:cNvPr>
+          <p:cNvSpPr>
+            <a:spLocks noGrp="1"/>
+          </p:cNvSpPr>
+          <p:nvPr>
+            <p:ph type="ftr" sz="quarter" idx="11"/>
+          </p:nvPr>
+        </p:nvSpPr>
+        <p:spPr/>
+        <p:txBody>
+          <a:bodyPr/>
+          <a:lstStyle/>
+          <a:p>
+            <a:endParaRPr lang="en-US"/>
+          </a:p>
+        </p:txBody>
+      </p:sp>
+      <p:sp>
+        <p:nvSpPr>
+          <p:cNvPr id="6" name="Slide Number Placeholder 5">
+            <a:extLst>
+              <a:ext uri="{FF2B5EF4-FFF2-40B4-BE49-F238E27FC236}">
+                <a16:creationId xmlns:a16="http://schemas.microsoft.com/office/drawing/2014/main" id="{050D1DBB-D9C9-9C89-2BC3-598094A06770}"/>
+              </a:ext>
+            </a:extLst>
+          </p:cNvPr>
+          <p:cNvSpPr>
+            <a:spLocks noGrp="1"/>
+          </p:cNvSpPr>
+          <p:nvPr>
+            <p:ph type="sldNum" sz="quarter" idx="12"/>
+          </p:nvPr>
+        </p:nvSpPr>
+        <p:spPr/>
+        <p:txBody>
+          <a:bodyPr/>
+          <a:lstStyle/>
+          <a:p>
+            <a:fld id="{3A73CC0E-67D5-43FD-BD59-BE5F44570CB2}" type="slidenum">
+              <a:rPr lang="en-GB" smtClean="0"/>
+              <a:pPr/>
+              <a:t>‹#›</a:t>
+            </a:fld>
+            <a:endParaRPr lang="en-GB"/>
+          </a:p>
+        </p:txBody>
+      </p:sp>
+    </p:spTree>
+    <p:extLst>
+      <p:ext uri="{BB962C8B-B14F-4D97-AF65-F5344CB8AC3E}">
+        <p14:creationId xmlns:p14="http://schemas.microsoft.com/office/powerpoint/2010/main" val="137758170"/>
+      </p:ext>
+    </p:extLst>
+  </p:cSld>
+  <p:clrMapOvr>
+    <a:masterClrMapping/>
+  </p:clrMapOvr>
+</p:sldLayout>
+</file>
+
+<file path=ppt/slideLayouts/slideLayout23.xml><?xml version="1.0" encoding="utf-8"?>
+<p:sldLayout xmlns:a="http://schemas.openxmlformats.org/drawingml/2006/main" xmlns:r="http://schemas.openxmlformats.org/officeDocument/2006/relationships" xmlns:p="http://schemas.openxmlformats.org/presentationml/2006/main" type="vertTitleAndTx" preserve="1">
+  <p:cSld name="Vertical Title and Text">
+    <p:spTree>
+      <p:nvGrpSpPr>
+        <p:cNvPr id="1" name=""/>
+        <p:cNvGrpSpPr/>
+        <p:nvPr/>
+      </p:nvGrpSpPr>
+      <p:grpSpPr>
+        <a:xfrm>
+          <a:off x="0" y="0"/>
+          <a:ext cx="0" cy="0"/>
+          <a:chOff x="0" y="0"/>
+          <a:chExt cx="0" cy="0"/>
+        </a:xfrm>
+      </p:grpSpPr>
+      <p:sp>
+        <p:nvSpPr>
+          <p:cNvPr id="2" name="Vertical Title 1">
+            <a:extLst>
+              <a:ext uri="{FF2B5EF4-FFF2-40B4-BE49-F238E27FC236}">
+                <a16:creationId xmlns:a16="http://schemas.microsoft.com/office/drawing/2014/main" id="{0379E52E-0060-6B07-F383-113847D2F715}"/>
+              </a:ext>
+            </a:extLst>
+          </p:cNvPr>
+          <p:cNvSpPr>
+            <a:spLocks noGrp="1"/>
+          </p:cNvSpPr>
+          <p:nvPr>
+            <p:ph type="title" orient="vert"/>
+          </p:nvPr>
+        </p:nvSpPr>
+        <p:spPr>
+          <a:xfrm>
+            <a:off x="7088981" y="365125"/>
+            <a:ext cx="2135981" cy="5811838"/>
+          </a:xfrm>
+        </p:spPr>
+        <p:txBody>
+          <a:bodyPr vert="eaVert"/>
+          <a:lstStyle/>
+          <a:p>
+            <a:r>
+              <a:rPr lang="en-US"/>
+              <a:t>Click to edit Master title style</a:t>
+            </a:r>
+          </a:p>
+        </p:txBody>
+      </p:sp>
+      <p:sp>
+        <p:nvSpPr>
+          <p:cNvPr id="3" name="Vertical Text Placeholder 2">
+            <a:extLst>
+              <a:ext uri="{FF2B5EF4-FFF2-40B4-BE49-F238E27FC236}">
+                <a16:creationId xmlns:a16="http://schemas.microsoft.com/office/drawing/2014/main" id="{6D929278-A0F1-64D3-5304-A0606E4AFA40}"/>
+              </a:ext>
+            </a:extLst>
+          </p:cNvPr>
+          <p:cNvSpPr>
+            <a:spLocks noGrp="1"/>
+          </p:cNvSpPr>
+          <p:nvPr>
+            <p:ph type="body" orient="vert" idx="1"/>
+          </p:nvPr>
+        </p:nvSpPr>
+        <p:spPr>
+          <a:xfrm>
+            <a:off x="681037" y="365125"/>
+            <a:ext cx="6284119" cy="5811838"/>
+          </a:xfrm>
+        </p:spPr>
+        <p:txBody>
+          <a:bodyPr vert="eaVert"/>
+          <a:lstStyle/>
+          <a:p>
+            <a:pPr lvl="0"/>
+            <a:r>
+              <a:rPr lang="en-US"/>
+              <a:t>Click to edit Master text styles</a:t>
+            </a:r>
+          </a:p>
+          <a:p>
+            <a:pPr lvl="1"/>
+            <a:r>
+              <a:rPr lang="en-US"/>
+              <a:t>Second level</a:t>
+            </a:r>
+          </a:p>
+          <a:p>
+            <a:pPr lvl="2"/>
+            <a:r>
+              <a:rPr lang="en-US"/>
+              <a:t>Third level</a:t>
+            </a:r>
+          </a:p>
+          <a:p>
+            <a:pPr lvl="3"/>
+            <a:r>
+              <a:rPr lang="en-US"/>
+              <a:t>Fourth level</a:t>
+            </a:r>
+          </a:p>
+          <a:p>
+            <a:pPr lvl="4"/>
+            <a:r>
+              <a:rPr lang="en-US"/>
+              <a:t>Fifth level</a:t>
+            </a:r>
+          </a:p>
+        </p:txBody>
+      </p:sp>
+      <p:sp>
+        <p:nvSpPr>
+          <p:cNvPr id="4" name="Date Placeholder 3">
+            <a:extLst>
+              <a:ext uri="{FF2B5EF4-FFF2-40B4-BE49-F238E27FC236}">
+                <a16:creationId xmlns:a16="http://schemas.microsoft.com/office/drawing/2014/main" id="{4BBCF91E-A3F1-0403-311B-0B302558CFD3}"/>
+              </a:ext>
+            </a:extLst>
+          </p:cNvPr>
+          <p:cNvSpPr>
+            <a:spLocks noGrp="1"/>
+          </p:cNvSpPr>
+          <p:nvPr>
+            <p:ph type="dt" sz="half" idx="10"/>
+          </p:nvPr>
+        </p:nvSpPr>
+        <p:spPr/>
+        <p:txBody>
+          <a:bodyPr/>
+          <a:lstStyle/>
+          <a:p>
+            <a:fld id="{6F80DDAC-FE11-49DC-9261-11C1E994665B}" type="datetimeFigureOut">
+              <a:rPr lang="en-GB" smtClean="0"/>
+              <a:pPr/>
+              <a:t>29/07/2026</a:t>
+            </a:fld>
+            <a:endParaRPr lang="en-GB"/>
+          </a:p>
+        </p:txBody>
+      </p:sp>
+      <p:sp>
+        <p:nvSpPr>
+          <p:cNvPr id="5" name="Footer Placeholder 4">
+            <a:extLst>
+              <a:ext uri="{FF2B5EF4-FFF2-40B4-BE49-F238E27FC236}">
+                <a16:creationId xmlns:a16="http://schemas.microsoft.com/office/drawing/2014/main" id="{8F7EDA70-C912-8325-0339-221ACF266C68}"/>
+              </a:ext>
+            </a:extLst>
+          </p:cNvPr>
+          <p:cNvSpPr>
+            <a:spLocks noGrp="1"/>
+          </p:cNvSpPr>
+          <p:nvPr>
+            <p:ph type="ftr" sz="quarter" idx="11"/>
+          </p:nvPr>
+        </p:nvSpPr>
+        <p:spPr/>
+        <p:txBody>
+          <a:bodyPr/>
+          <a:lstStyle/>
+          <a:p>
+            <a:endParaRPr lang="en-US"/>
+          </a:p>
+        </p:txBody>
+      </p:sp>
+      <p:sp>
+        <p:nvSpPr>
+          <p:cNvPr id="6" name="Slide Number Placeholder 5">
+            <a:extLst>
+              <a:ext uri="{FF2B5EF4-FFF2-40B4-BE49-F238E27FC236}">
+                <a16:creationId xmlns:a16="http://schemas.microsoft.com/office/drawing/2014/main" id="{09A3C9B7-156A-E408-499B-DB7FFED307D2}"/>
+              </a:ext>
+            </a:extLst>
+          </p:cNvPr>
+          <p:cNvSpPr>
+            <a:spLocks noGrp="1"/>
+          </p:cNvSpPr>
+          <p:nvPr>
+            <p:ph type="sldNum" sz="quarter" idx="12"/>
+          </p:nvPr>
+        </p:nvSpPr>
+        <p:spPr/>
+        <p:txBody>
+          <a:bodyPr/>
+          <a:lstStyle/>
+          <a:p>
+            <a:fld id="{3A73CC0E-67D5-43FD-BD59-BE5F44570CB2}" type="slidenum">
+              <a:rPr lang="en-GB" smtClean="0"/>
+              <a:pPr/>
+              <a:t>‹#›</a:t>
+            </a:fld>
+            <a:endParaRPr lang="en-GB"/>
+          </a:p>
+        </p:txBody>
+      </p:sp>
+    </p:spTree>
+    <p:extLst>
+      <p:ext uri="{BB962C8B-B14F-4D97-AF65-F5344CB8AC3E}">
+        <p14:creationId xmlns:p14="http://schemas.microsoft.com/office/powerpoint/2010/main" val="3530029153"/>
+      </p:ext>
+    </p:extLst>
+  </p:cSld>
+  <p:clrMapOvr>
+    <a:masterClrMapping/>
+  </p:clrMapOvr>
+</p:sldLayout>
+</file>
+
+<file path=ppt/slideLayouts/slideLayout24.xml><?xml version="1.0" encoding="utf-8"?>
+<p:sldLayout xmlns:a="http://schemas.openxmlformats.org/drawingml/2006/main" xmlns:r="http://schemas.openxmlformats.org/officeDocument/2006/relationships" xmlns:p="http://schemas.openxmlformats.org/presentationml/2006/main" userDrawn="1">
+  <p:cSld name="Contents &amp; Photo">
+    <p:spTree>
+      <p:nvGrpSpPr>
+        <p:cNvPr id="1" name=""/>
+        <p:cNvGrpSpPr/>
+        <p:nvPr/>
+      </p:nvGrpSpPr>
+      <p:grpSpPr>
+        <a:xfrm>
+          <a:off x="0" y="0"/>
+          <a:ext cx="0" cy="0"/>
+          <a:chOff x="0" y="0"/>
+          <a:chExt cx="0" cy="0"/>
+        </a:xfrm>
+      </p:grpSpPr>
+      <p:sp>
+        <p:nvSpPr>
+          <p:cNvPr id="13" name="Picture Placeholder 10"/>
+          <p:cNvSpPr>
+            <a:spLocks noGrp="1"/>
+          </p:cNvSpPr>
+          <p:nvPr>
+            <p:ph type="pic" sz="quarter" idx="14"/>
+          </p:nvPr>
+        </p:nvSpPr>
+        <p:spPr>
+          <a:xfrm>
+            <a:off x="4953004" y="1270000"/>
+            <a:ext cx="4952996" cy="5588000"/>
+          </a:xfrm>
+        </p:spPr>
+        <p:txBody>
+          <a:bodyPr/>
+          <a:lstStyle/>
+          <a:p>
+            <a:endParaRPr lang="en-GB"/>
+          </a:p>
+        </p:txBody>
+      </p:sp>
+      <p:sp>
+        <p:nvSpPr>
+          <p:cNvPr id="17" name="Date Placeholder 3"/>
+          <p:cNvSpPr>
+            <a:spLocks noGrp="1"/>
+          </p:cNvSpPr>
+          <p:nvPr>
+            <p:ph type="dt" sz="half" idx="2"/>
+          </p:nvPr>
+        </p:nvSpPr>
+        <p:spPr>
+          <a:xfrm>
+            <a:off x="624841" y="6310630"/>
+            <a:ext cx="2341244" cy="547370"/>
+          </a:xfrm>
+          <a:prstGeom prst="rect">
+            <a:avLst/>
+          </a:prstGeom>
+        </p:spPr>
+        <p:txBody>
+          <a:bodyPr vert="horz" lIns="91440" tIns="45720" rIns="91440" bIns="45720" rtlCol="0" anchor="ctr"/>
+          <a:lstStyle>
+            <a:lvl1pPr algn="l">
+              <a:defRPr sz="1200">
+                <a:solidFill>
+                  <a:schemeClr val="tx1"/>
+                </a:solidFill>
+              </a:defRPr>
+            </a:lvl1pPr>
+          </a:lstStyle>
+          <a:p>
+            <a:fld id="{6F80DDAC-FE11-49DC-9261-11C1E994665B}" type="datetimeFigureOut">
+              <a:rPr lang="en-GB" smtClean="0"/>
+              <a:pPr/>
+              <a:t>29/07/2026</a:t>
+            </a:fld>
+            <a:endParaRPr lang="en-GB"/>
+          </a:p>
+        </p:txBody>
+      </p:sp>
+      <p:sp>
+        <p:nvSpPr>
+          <p:cNvPr id="18" name="Slide Number Placeholder 5"/>
+          <p:cNvSpPr>
+            <a:spLocks noGrp="1"/>
+          </p:cNvSpPr>
+          <p:nvPr>
+            <p:ph type="sldNum" sz="quarter" idx="4"/>
+          </p:nvPr>
+        </p:nvSpPr>
+        <p:spPr>
+          <a:xfrm>
+            <a:off x="6939916" y="6310630"/>
+            <a:ext cx="2341244" cy="547370"/>
+          </a:xfrm>
+          <a:prstGeom prst="rect">
+            <a:avLst/>
+          </a:prstGeom>
+        </p:spPr>
+        <p:txBody>
+          <a:bodyPr vert="horz" lIns="91440" tIns="45720" rIns="91440" bIns="45720" rtlCol="0" anchor="ctr"/>
+          <a:lstStyle>
+            <a:lvl1pPr algn="r">
+              <a:defRPr sz="1200">
+                <a:solidFill>
+                  <a:schemeClr val="bg1"/>
+                </a:solidFill>
+              </a:defRPr>
+            </a:lvl1pPr>
+          </a:lstStyle>
+          <a:p>
+            <a:fld id="{3A73CC0E-67D5-43FD-BD59-BE5F44570CB2}" type="slidenum">
+              <a:rPr lang="en-GB" smtClean="0"/>
+              <a:pPr/>
+              <a:t>‹#›</a:t>
+            </a:fld>
+            <a:endParaRPr lang="en-GB"/>
+          </a:p>
+        </p:txBody>
+      </p:sp>
+      <p:sp>
+        <p:nvSpPr>
+          <p:cNvPr id="19" name="Text Placeholder 2"/>
+          <p:cNvSpPr>
+            <a:spLocks noGrp="1"/>
+          </p:cNvSpPr>
+          <p:nvPr>
+            <p:ph idx="1"/>
+          </p:nvPr>
+        </p:nvSpPr>
+        <p:spPr>
+          <a:xfrm>
+            <a:off x="624841" y="1270000"/>
+            <a:ext cx="3619499" cy="5040630"/>
+          </a:xfrm>
+          <a:prstGeom prst="rect">
+            <a:avLst/>
+          </a:prstGeom>
+        </p:spPr>
+        <p:txBody>
+          <a:bodyPr vert="horz" lIns="91440" tIns="180000" rIns="91440" bIns="180000" rtlCol="0" anchor="ctr">
+            <a:normAutofit/>
+          </a:bodyPr>
+          <a:lstStyle>
+            <a:lvl1pPr marL="0" indent="0">
+              <a:spcBef>
+                <a:spcPts val="1800"/>
+              </a:spcBef>
+              <a:buNone/>
+              <a:defRPr sz="1400" b="0">
+                <a:latin typeface="Roboto Medium" panose="02000000000000000000" pitchFamily="2" charset="0"/>
+                <a:ea typeface="Roboto Medium" panose="02000000000000000000" pitchFamily="2" charset="0"/>
+              </a:defRPr>
+            </a:lvl1pPr>
+            <a:lvl2pPr marL="800100" indent="-342900">
+              <a:spcBef>
+                <a:spcPts val="0"/>
+              </a:spcBef>
+              <a:buClr>
+                <a:schemeClr val="accent1"/>
+              </a:buClr>
+              <a:buFont typeface="Wingdings" panose="05000000000000000000" pitchFamily="2" charset="2"/>
+              <a:buChar char="§"/>
+              <a:defRPr sz="1200">
+                <a:latin typeface="+mn-lt"/>
+              </a:defRPr>
+            </a:lvl2pPr>
+            <a:lvl3pPr marL="1257300" indent="-342900">
+              <a:spcBef>
+                <a:spcPts val="0"/>
+              </a:spcBef>
+              <a:buFont typeface="Roboto Light" panose="02000000000000000000" pitchFamily="2" charset="0"/>
+              <a:buChar char="-"/>
+              <a:defRPr sz="1200">
+                <a:latin typeface="+mn-lt"/>
+              </a:defRPr>
+            </a:lvl3pPr>
+            <a:lvl4pPr marL="1657350" indent="-285750">
+              <a:spcBef>
+                <a:spcPts val="0"/>
+              </a:spcBef>
+              <a:buFont typeface="Roboto Light" panose="02000000000000000000" pitchFamily="2" charset="0"/>
+              <a:buChar char="-"/>
+              <a:defRPr sz="1200">
+                <a:latin typeface="+mn-lt"/>
+              </a:defRPr>
+            </a:lvl4pPr>
+            <a:lvl5pPr marL="2114550" indent="-285750">
+              <a:spcBef>
+                <a:spcPts val="0"/>
+              </a:spcBef>
+              <a:buFont typeface="Roboto Light" panose="02000000000000000000" pitchFamily="2" charset="0"/>
+              <a:buChar char="-"/>
+              <a:defRPr sz="1200">
+                <a:latin typeface="+mn-lt"/>
+              </a:defRPr>
+            </a:lvl5pPr>
+          </a:lstStyle>
+          <a:p>
+            <a:pPr lvl="0"/>
+            <a:r>
+              <a:rPr lang="en-US"/>
+              <a:t>Edit Master text styles</a:t>
+            </a:r>
+          </a:p>
+          <a:p>
+            <a:pPr lvl="1"/>
+            <a:r>
+              <a:rPr lang="en-US"/>
+              <a:t>Second level</a:t>
+            </a:r>
+          </a:p>
+          <a:p>
+            <a:pPr lvl="2"/>
+            <a:r>
+              <a:rPr lang="en-US"/>
+              <a:t>Third level</a:t>
+            </a:r>
+          </a:p>
+          <a:p>
+            <a:pPr lvl="3"/>
+            <a:r>
+              <a:rPr lang="en-US"/>
+              <a:t>Fourth level</a:t>
+            </a:r>
+          </a:p>
+          <a:p>
+            <a:pPr lvl="4"/>
+            <a:r>
+              <a:rPr lang="en-US"/>
+              <a:t>Fifth level</a:t>
+            </a:r>
+          </a:p>
+        </p:txBody>
+      </p:sp>
+      <p:sp>
+        <p:nvSpPr>
+          <p:cNvPr id="7" name="Title Placeholder 1">
+            <a:extLst>
+              <a:ext uri="{FF2B5EF4-FFF2-40B4-BE49-F238E27FC236}">
+                <a16:creationId xmlns:a16="http://schemas.microsoft.com/office/drawing/2014/main" id="{49863A12-A66A-429E-8F66-C5A5F81F1B27}"/>
+              </a:ext>
+            </a:extLst>
+          </p:cNvPr>
+          <p:cNvSpPr>
+            <a:spLocks noGrp="1"/>
+          </p:cNvSpPr>
+          <p:nvPr>
+            <p:ph type="title"/>
+          </p:nvPr>
+        </p:nvSpPr>
+        <p:spPr>
+          <a:xfrm>
+            <a:off x="596204" y="191149"/>
+            <a:ext cx="8656319" cy="654201"/>
+          </a:xfrm>
+          <a:prstGeom prst="rect">
+            <a:avLst/>
+          </a:prstGeom>
+        </p:spPr>
+        <p:txBody>
+          <a:bodyPr vert="horz" lIns="91440" tIns="45720" rIns="91440" bIns="45720" rtlCol="0" anchor="ctr">
+            <a:noAutofit/>
+          </a:bodyPr>
+          <a:lstStyle/>
+          <a:p>
+            <a:r>
+              <a:rPr lang="en-US"/>
+              <a:t>Click to edit Master title style</a:t>
+            </a:r>
+            <a:endParaRPr lang="en-GB"/>
+          </a:p>
+        </p:txBody>
+      </p:sp>
+    </p:spTree>
+    <p:extLst>
+      <p:ext uri="{BB962C8B-B14F-4D97-AF65-F5344CB8AC3E}">
+        <p14:creationId xmlns:p14="http://schemas.microsoft.com/office/powerpoint/2010/main" val="3988602008"/>
+      </p:ext>
+    </p:extLst>
+  </p:cSld>
+  <p:clrMapOvr>
+    <a:masterClrMapping/>
+  </p:clrMapOvr>
 </p:sldLayout>
 </file>
 
@@ -2523,7 +5463,7 @@
             <a:fld id="{6F80DDAC-FE11-49DC-9261-11C1E994665B}" type="datetimeFigureOut">
               <a:rPr lang="en-GB" smtClean="0"/>
               <a:pPr/>
-              <a:t>28/07/2026</a:t>
+              <a:t>29/07/2026</a:t>
             </a:fld>
             <a:endParaRPr lang="en-GB"/>
           </a:p>
@@ -2693,7 +5633,7 @@
             <a:fld id="{6F80DDAC-FE11-49DC-9261-11C1E994665B}" type="datetimeFigureOut">
               <a:rPr lang="en-GB" smtClean="0"/>
               <a:pPr/>
-              <a:t>28/07/2026</a:t>
+              <a:t>29/07/2026</a:t>
             </a:fld>
             <a:endParaRPr lang="en-GB"/>
           </a:p>
@@ -2919,7 +5859,7 @@
             <a:fld id="{6F80DDAC-FE11-49DC-9261-11C1E994665B}" type="datetimeFigureOut">
               <a:rPr lang="en-GB" smtClean="0"/>
               <a:pPr/>
-              <a:t>28/07/2026</a:t>
+              <a:t>29/07/2026</a:t>
             </a:fld>
             <a:endParaRPr lang="en-GB"/>
           </a:p>
@@ -3165,7 +6105,7 @@
             <a:fld id="{6F80DDAC-FE11-49DC-9261-11C1E994665B}" type="datetimeFigureOut">
               <a:rPr lang="en-GB" smtClean="0"/>
               <a:pPr/>
-              <a:t>28/07/2026</a:t>
+              <a:t>29/07/2026</a:t>
             </a:fld>
             <a:endParaRPr lang="en-GB"/>
           </a:p>
@@ -3502,7 +6442,7 @@
             <a:fld id="{6F80DDAC-FE11-49DC-9261-11C1E994665B}" type="datetimeFigureOut">
               <a:rPr lang="en-GB" smtClean="0"/>
               <a:pPr/>
-              <a:t>28/07/2026</a:t>
+              <a:t>29/07/2026</a:t>
             </a:fld>
             <a:endParaRPr lang="en-GB"/>
           </a:p>
@@ -3771,7 +6711,7 @@
             <a:fld id="{6F80DDAC-FE11-49DC-9261-11C1E994665B}" type="datetimeFigureOut">
               <a:rPr lang="en-GB" smtClean="0"/>
               <a:pPr/>
-              <a:t>28/07/2026</a:t>
+              <a:t>29/07/2026</a:t>
             </a:fld>
             <a:endParaRPr lang="en-GB"/>
           </a:p>
@@ -4134,7 +7074,7 @@
           <a:p>
             <a:fld id="{B3200F2B-F467-4C29-9963-7410829293A6}" type="datetime1">
               <a:rPr lang="en-GB" smtClean="0"/>
-              <a:t>28/07/2026</a:t>
+              <a:t>29/07/2026</a:t>
             </a:fld>
             <a:endParaRPr lang="en-GB"/>
           </a:p>
@@ -4743,7 +7683,7 @@
             <a:fld id="{6F80DDAC-FE11-49DC-9261-11C1E994665B}" type="datetimeFigureOut">
               <a:rPr lang="en-GB" smtClean="0"/>
               <a:pPr/>
-              <a:t>28/07/2026</a:t>
+              <a:t>29/07/2026</a:t>
             </a:fld>
             <a:endParaRPr lang="en-GB"/>
           </a:p>
@@ -5226,6 +8166,748 @@
 </p:sldMaster>
 </file>
 
+<file path=ppt/slideMasters/slideMaster3.xml><?xml version="1.0" encoding="utf-8"?>
+<p:sldMaster xmlns:a="http://schemas.openxmlformats.org/drawingml/2006/main" xmlns:r="http://schemas.openxmlformats.org/officeDocument/2006/relationships" xmlns:p="http://schemas.openxmlformats.org/presentationml/2006/main">
+  <p:cSld>
+    <p:bg>
+      <p:bgRef idx="1001">
+        <a:schemeClr val="bg1"/>
+      </p:bgRef>
+    </p:bg>
+    <p:spTree>
+      <p:nvGrpSpPr>
+        <p:cNvPr id="1" name=""/>
+        <p:cNvGrpSpPr/>
+        <p:nvPr/>
+      </p:nvGrpSpPr>
+      <p:grpSpPr>
+        <a:xfrm>
+          <a:off x="0" y="0"/>
+          <a:ext cx="0" cy="0"/>
+          <a:chOff x="0" y="0"/>
+          <a:chExt cx="0" cy="0"/>
+        </a:xfrm>
+      </p:grpSpPr>
+      <p:sp>
+        <p:nvSpPr>
+          <p:cNvPr id="2" name="Title Placeholder 1">
+            <a:extLst>
+              <a:ext uri="{FF2B5EF4-FFF2-40B4-BE49-F238E27FC236}">
+                <a16:creationId xmlns:a16="http://schemas.microsoft.com/office/drawing/2014/main" id="{A26706E2-5FAA-84FA-2BA5-FE79CAD3CBE7}"/>
+              </a:ext>
+            </a:extLst>
+          </p:cNvPr>
+          <p:cNvSpPr>
+            <a:spLocks noGrp="1"/>
+          </p:cNvSpPr>
+          <p:nvPr>
+            <p:ph type="title"/>
+          </p:nvPr>
+        </p:nvSpPr>
+        <p:spPr>
+          <a:xfrm>
+            <a:off x="681038" y="365126"/>
+            <a:ext cx="8543925" cy="1325563"/>
+          </a:xfrm>
+          <a:prstGeom prst="rect">
+            <a:avLst/>
+          </a:prstGeom>
+        </p:spPr>
+        <p:txBody>
+          <a:bodyPr vert="horz" lIns="91440" tIns="45720" rIns="91440" bIns="45720" rtlCol="0" anchor="ctr">
+            <a:normAutofit/>
+          </a:bodyPr>
+          <a:lstStyle/>
+          <a:p>
+            <a:r>
+              <a:rPr lang="en-US"/>
+              <a:t>Click to edit Master title style</a:t>
+            </a:r>
+          </a:p>
+        </p:txBody>
+      </p:sp>
+      <p:sp>
+        <p:nvSpPr>
+          <p:cNvPr id="3" name="Text Placeholder 2">
+            <a:extLst>
+              <a:ext uri="{FF2B5EF4-FFF2-40B4-BE49-F238E27FC236}">
+                <a16:creationId xmlns:a16="http://schemas.microsoft.com/office/drawing/2014/main" id="{874C0190-CDC1-B11F-77F2-806F5CA2BFE7}"/>
+              </a:ext>
+            </a:extLst>
+          </p:cNvPr>
+          <p:cNvSpPr>
+            <a:spLocks noGrp="1"/>
+          </p:cNvSpPr>
+          <p:nvPr>
+            <p:ph type="body" idx="1"/>
+          </p:nvPr>
+        </p:nvSpPr>
+        <p:spPr>
+          <a:xfrm>
+            <a:off x="681038" y="1825625"/>
+            <a:ext cx="8543925" cy="4351338"/>
+          </a:xfrm>
+          <a:prstGeom prst="rect">
+            <a:avLst/>
+          </a:prstGeom>
+        </p:spPr>
+        <p:txBody>
+          <a:bodyPr vert="horz" lIns="91440" tIns="45720" rIns="91440" bIns="45720" rtlCol="0">
+            <a:normAutofit/>
+          </a:bodyPr>
+          <a:lstStyle/>
+          <a:p>
+            <a:pPr lvl="0"/>
+            <a:r>
+              <a:rPr lang="en-US"/>
+              <a:t>Click to edit Master text styles</a:t>
+            </a:r>
+          </a:p>
+          <a:p>
+            <a:pPr lvl="1"/>
+            <a:r>
+              <a:rPr lang="en-US"/>
+              <a:t>Second level</a:t>
+            </a:r>
+          </a:p>
+          <a:p>
+            <a:pPr lvl="2"/>
+            <a:r>
+              <a:rPr lang="en-US"/>
+              <a:t>Third level</a:t>
+            </a:r>
+          </a:p>
+          <a:p>
+            <a:pPr lvl="3"/>
+            <a:r>
+              <a:rPr lang="en-US"/>
+              <a:t>Fourth level</a:t>
+            </a:r>
+          </a:p>
+          <a:p>
+            <a:pPr lvl="4"/>
+            <a:r>
+              <a:rPr lang="en-US"/>
+              <a:t>Fifth level</a:t>
+            </a:r>
+          </a:p>
+        </p:txBody>
+      </p:sp>
+      <p:sp>
+        <p:nvSpPr>
+          <p:cNvPr id="4" name="Date Placeholder 3">
+            <a:extLst>
+              <a:ext uri="{FF2B5EF4-FFF2-40B4-BE49-F238E27FC236}">
+                <a16:creationId xmlns:a16="http://schemas.microsoft.com/office/drawing/2014/main" id="{4EDD5702-9985-065D-0AB2-8A50FAB462B3}"/>
+              </a:ext>
+            </a:extLst>
+          </p:cNvPr>
+          <p:cNvSpPr>
+            <a:spLocks noGrp="1"/>
+          </p:cNvSpPr>
+          <p:nvPr>
+            <p:ph type="dt" sz="half" idx="2"/>
+          </p:nvPr>
+        </p:nvSpPr>
+        <p:spPr>
+          <a:xfrm>
+            <a:off x="681038" y="6356351"/>
+            <a:ext cx="2228850" cy="365125"/>
+          </a:xfrm>
+          <a:prstGeom prst="rect">
+            <a:avLst/>
+          </a:prstGeom>
+        </p:spPr>
+        <p:txBody>
+          <a:bodyPr vert="horz" lIns="91440" tIns="45720" rIns="91440" bIns="45720" rtlCol="0" anchor="ctr"/>
+          <a:lstStyle>
+            <a:lvl1pPr algn="l">
+              <a:defRPr sz="975">
+                <a:solidFill>
+                  <a:schemeClr val="tx1">
+                    <a:tint val="82000"/>
+                  </a:schemeClr>
+                </a:solidFill>
+              </a:defRPr>
+            </a:lvl1pPr>
+          </a:lstStyle>
+          <a:p>
+            <a:fld id="{B3200F2B-F467-4C29-9963-7410829293A6}" type="datetime1">
+              <a:rPr lang="en-GB" smtClean="0"/>
+              <a:t>29/07/2026</a:t>
+            </a:fld>
+            <a:endParaRPr lang="en-GB"/>
+          </a:p>
+        </p:txBody>
+      </p:sp>
+      <p:sp>
+        <p:nvSpPr>
+          <p:cNvPr id="5" name="Footer Placeholder 4">
+            <a:extLst>
+              <a:ext uri="{FF2B5EF4-FFF2-40B4-BE49-F238E27FC236}">
+                <a16:creationId xmlns:a16="http://schemas.microsoft.com/office/drawing/2014/main" id="{F757D5C0-8D58-1C1F-A78A-228B0436F7C8}"/>
+              </a:ext>
+            </a:extLst>
+          </p:cNvPr>
+          <p:cNvSpPr>
+            <a:spLocks noGrp="1"/>
+          </p:cNvSpPr>
+          <p:nvPr>
+            <p:ph type="ftr" sz="quarter" idx="3"/>
+          </p:nvPr>
+        </p:nvSpPr>
+        <p:spPr>
+          <a:xfrm>
+            <a:off x="3281363" y="6356351"/>
+            <a:ext cx="3343275" cy="365125"/>
+          </a:xfrm>
+          <a:prstGeom prst="rect">
+            <a:avLst/>
+          </a:prstGeom>
+        </p:spPr>
+        <p:txBody>
+          <a:bodyPr vert="horz" lIns="91440" tIns="45720" rIns="91440" bIns="45720" rtlCol="0" anchor="ctr"/>
+          <a:lstStyle>
+            <a:lvl1pPr algn="ctr">
+              <a:defRPr sz="975">
+                <a:solidFill>
+                  <a:schemeClr val="tx1">
+                    <a:tint val="82000"/>
+                  </a:schemeClr>
+                </a:solidFill>
+              </a:defRPr>
+            </a:lvl1pPr>
+          </a:lstStyle>
+          <a:p>
+            <a:endParaRPr lang="en-GB"/>
+          </a:p>
+        </p:txBody>
+      </p:sp>
+      <p:sp>
+        <p:nvSpPr>
+          <p:cNvPr id="6" name="Slide Number Placeholder 5">
+            <a:extLst>
+              <a:ext uri="{FF2B5EF4-FFF2-40B4-BE49-F238E27FC236}">
+                <a16:creationId xmlns:a16="http://schemas.microsoft.com/office/drawing/2014/main" id="{90DE8CF6-4336-9D2A-79F2-C80B07BBF415}"/>
+              </a:ext>
+            </a:extLst>
+          </p:cNvPr>
+          <p:cNvSpPr>
+            <a:spLocks noGrp="1"/>
+          </p:cNvSpPr>
+          <p:nvPr>
+            <p:ph type="sldNum" sz="quarter" idx="4"/>
+          </p:nvPr>
+        </p:nvSpPr>
+        <p:spPr>
+          <a:xfrm>
+            <a:off x="6996113" y="6356351"/>
+            <a:ext cx="2228850" cy="365125"/>
+          </a:xfrm>
+          <a:prstGeom prst="rect">
+            <a:avLst/>
+          </a:prstGeom>
+        </p:spPr>
+        <p:txBody>
+          <a:bodyPr vert="horz" lIns="91440" tIns="45720" rIns="91440" bIns="45720" rtlCol="0" anchor="ctr"/>
+          <a:lstStyle>
+            <a:lvl1pPr algn="r">
+              <a:defRPr sz="975">
+                <a:solidFill>
+                  <a:schemeClr val="tx1">
+                    <a:tint val="82000"/>
+                  </a:schemeClr>
+                </a:solidFill>
+              </a:defRPr>
+            </a:lvl1pPr>
+          </a:lstStyle>
+          <a:p>
+            <a:fld id="{6854B3B4-4093-4FBB-A391-3009E9C94F95}" type="slidenum">
+              <a:rPr lang="en-GB" smtClean="0"/>
+              <a:t>‹#›</a:t>
+            </a:fld>
+            <a:endParaRPr lang="en-GB"/>
+          </a:p>
+        </p:txBody>
+      </p:sp>
+      <p:sp>
+        <p:nvSpPr>
+          <p:cNvPr id="7" name="Rectangle 6">
+            <a:extLst>
+              <a:ext uri="{FF2B5EF4-FFF2-40B4-BE49-F238E27FC236}">
+                <a16:creationId xmlns:a16="http://schemas.microsoft.com/office/drawing/2014/main" id="{ACF4DD7E-A58E-ABD5-09A2-5FB5700DB8C3}"/>
+              </a:ext>
+            </a:extLst>
+          </p:cNvPr>
+          <p:cNvSpPr/>
+          <p:nvPr userDrawn="1"/>
+        </p:nvSpPr>
+        <p:spPr>
+          <a:xfrm>
+            <a:off x="0" y="0"/>
+            <a:ext cx="9906000" cy="937697"/>
+          </a:xfrm>
+          <a:prstGeom prst="rect">
+            <a:avLst/>
+          </a:prstGeom>
+          <a:solidFill>
+            <a:srgbClr val="1767D2"/>
+          </a:solidFill>
+          <a:ln>
+            <a:noFill/>
+          </a:ln>
+        </p:spPr>
+        <p:style>
+          <a:lnRef idx="2">
+            <a:schemeClr val="accent1">
+              <a:shade val="50000"/>
+            </a:schemeClr>
+          </a:lnRef>
+          <a:fillRef idx="1">
+            <a:schemeClr val="accent1"/>
+          </a:fillRef>
+          <a:effectRef idx="0">
+            <a:schemeClr val="accent1"/>
+          </a:effectRef>
+          <a:fontRef idx="minor">
+            <a:schemeClr val="lt1"/>
+          </a:fontRef>
+        </p:style>
+        <p:txBody>
+          <a:bodyPr rtlCol="0" anchor="ctr"/>
+          <a:lstStyle/>
+          <a:p>
+            <a:pPr algn="ctr"/>
+            <a:endParaRPr lang="en-GB"/>
+          </a:p>
+        </p:txBody>
+      </p:sp>
+      <p:sp>
+        <p:nvSpPr>
+          <p:cNvPr id="8" name="Rectangle 7">
+            <a:extLst>
+              <a:ext uri="{FF2B5EF4-FFF2-40B4-BE49-F238E27FC236}">
+                <a16:creationId xmlns:a16="http://schemas.microsoft.com/office/drawing/2014/main" id="{CF83EFDE-40D5-5DED-EC2D-04C76685548C}"/>
+              </a:ext>
+            </a:extLst>
+          </p:cNvPr>
+          <p:cNvSpPr/>
+          <p:nvPr userDrawn="1"/>
+        </p:nvSpPr>
+        <p:spPr>
+          <a:xfrm>
+            <a:off x="82510" y="376501"/>
+            <a:ext cx="9906000" cy="937697"/>
+          </a:xfrm>
+          <a:prstGeom prst="rect">
+            <a:avLst/>
+          </a:prstGeom>
+          <a:noFill/>
+          <a:ln>
+            <a:noFill/>
+          </a:ln>
+        </p:spPr>
+        <p:style>
+          <a:lnRef idx="2">
+            <a:schemeClr val="accent1">
+              <a:shade val="50000"/>
+            </a:schemeClr>
+          </a:lnRef>
+          <a:fillRef idx="1">
+            <a:schemeClr val="accent1"/>
+          </a:fillRef>
+          <a:effectRef idx="0">
+            <a:schemeClr val="accent1"/>
+          </a:effectRef>
+          <a:fontRef idx="minor">
+            <a:schemeClr val="lt1"/>
+          </a:fontRef>
+        </p:style>
+        <p:txBody>
+          <a:bodyPr rtlCol="0" anchor="ctr"/>
+          <a:lstStyle/>
+          <a:p>
+            <a:pPr algn="ctr"/>
+            <a:endParaRPr lang="en-GB"/>
+          </a:p>
+        </p:txBody>
+      </p:sp>
+      <p:pic>
+        <p:nvPicPr>
+          <p:cNvPr id="9" name="Graphic 8">
+            <a:extLst>
+              <a:ext uri="{FF2B5EF4-FFF2-40B4-BE49-F238E27FC236}">
+                <a16:creationId xmlns:a16="http://schemas.microsoft.com/office/drawing/2014/main" id="{1857AE01-FD5E-3922-26A9-AC9765042781}"/>
+              </a:ext>
+            </a:extLst>
+          </p:cNvPr>
+          <p:cNvPicPr>
+            <a:picLocks noChangeAspect="1"/>
+          </p:cNvPicPr>
+          <p:nvPr userDrawn="1"/>
+        </p:nvPicPr>
+        <p:blipFill>
+          <a:blip>
+            <a:extLst>
+              <a:ext uri="{28A0092B-C50C-407E-A947-70E740481C1C}">
+                <a14:useLocalDpi xmlns:a14="http://schemas.microsoft.com/office/drawing/2010/main" val="0"/>
+              </a:ext>
+              <a:ext uri="{96DAC541-7B7A-43D3-8B79-37D633B846F1}">
+                <asvg:svgBlip xmlns:asvg="http://schemas.microsoft.com/office/drawing/2016/SVG/main" r:embed="rId14"/>
+              </a:ext>
+            </a:extLst>
+          </a:blip>
+          <a:stretch>
+            <a:fillRect/>
+          </a:stretch>
+        </p:blipFill>
+        <p:spPr>
+          <a:xfrm>
+            <a:off x="7029258" y="-559124"/>
+            <a:ext cx="2688790" cy="2993641"/>
+          </a:xfrm>
+          <a:prstGeom prst="rect">
+            <a:avLst/>
+          </a:prstGeom>
+        </p:spPr>
+      </p:pic>
+    </p:spTree>
+    <p:extLst>
+      <p:ext uri="{BB962C8B-B14F-4D97-AF65-F5344CB8AC3E}">
+        <p14:creationId xmlns:p14="http://schemas.microsoft.com/office/powerpoint/2010/main" val="1674215266"/>
+      </p:ext>
+    </p:extLst>
+  </p:cSld>
+  <p:clrMap bg1="lt1" tx1="dk1" bg2="lt2" tx2="dk2" accent1="accent1" accent2="accent2" accent3="accent3" accent4="accent4" accent5="accent5" accent6="accent6" hlink="hlink" folHlink="folHlink"/>
+  <p:sldLayoutIdLst>
+    <p:sldLayoutId id="2147483746" r:id="rId1"/>
+    <p:sldLayoutId id="2147483747" r:id="rId2"/>
+    <p:sldLayoutId id="2147483748" r:id="rId3"/>
+    <p:sldLayoutId id="2147483749" r:id="rId4"/>
+    <p:sldLayoutId id="2147483750" r:id="rId5"/>
+    <p:sldLayoutId id="2147483751" r:id="rId6"/>
+    <p:sldLayoutId id="2147483752" r:id="rId7"/>
+    <p:sldLayoutId id="2147483753" r:id="rId8"/>
+    <p:sldLayoutId id="2147483754" r:id="rId9"/>
+    <p:sldLayoutId id="2147483755" r:id="rId10"/>
+    <p:sldLayoutId id="2147483756" r:id="rId11"/>
+    <p:sldLayoutId id="2147483757" r:id="rId12"/>
+  </p:sldLayoutIdLst>
+  <p:hf hdr="0" ftr="0" dt="0"/>
+  <p:txStyles>
+    <p:titleStyle>
+      <a:lvl1pPr algn="l" defTabSz="742950" rtl="0" eaLnBrk="1" latinLnBrk="0" hangingPunct="1">
+        <a:lnSpc>
+          <a:spcPct val="90000"/>
+        </a:lnSpc>
+        <a:spcBef>
+          <a:spcPct val="0"/>
+        </a:spcBef>
+        <a:buNone/>
+        <a:defRPr sz="3575" kern="1200">
+          <a:solidFill>
+            <a:schemeClr val="tx1"/>
+          </a:solidFill>
+          <a:latin typeface="+mj-lt"/>
+          <a:ea typeface="+mj-ea"/>
+          <a:cs typeface="+mj-cs"/>
+        </a:defRPr>
+      </a:lvl1pPr>
+    </p:titleStyle>
+    <p:bodyStyle>
+      <a:lvl1pPr marL="185738" indent="-185738" algn="l" defTabSz="742950" rtl="0" eaLnBrk="1" latinLnBrk="0" hangingPunct="1">
+        <a:lnSpc>
+          <a:spcPct val="90000"/>
+        </a:lnSpc>
+        <a:spcBef>
+          <a:spcPts val="813"/>
+        </a:spcBef>
+        <a:buFont typeface="Arial" panose="020B0604020202020204" pitchFamily="34" charset="0"/>
+        <a:buChar char="•"/>
+        <a:defRPr sz="2275" kern="1200">
+          <a:solidFill>
+            <a:schemeClr val="tx1"/>
+          </a:solidFill>
+          <a:latin typeface="+mn-lt"/>
+          <a:ea typeface="+mn-ea"/>
+          <a:cs typeface="+mn-cs"/>
+        </a:defRPr>
+      </a:lvl1pPr>
+      <a:lvl2pPr marL="557213" indent="-185738" algn="l" defTabSz="742950" rtl="0" eaLnBrk="1" latinLnBrk="0" hangingPunct="1">
+        <a:lnSpc>
+          <a:spcPct val="90000"/>
+        </a:lnSpc>
+        <a:spcBef>
+          <a:spcPts val="406"/>
+        </a:spcBef>
+        <a:buFont typeface="Arial" panose="020B0604020202020204" pitchFamily="34" charset="0"/>
+        <a:buChar char="•"/>
+        <a:defRPr sz="1950" kern="1200">
+          <a:solidFill>
+            <a:schemeClr val="tx1"/>
+          </a:solidFill>
+          <a:latin typeface="+mn-lt"/>
+          <a:ea typeface="+mn-ea"/>
+          <a:cs typeface="+mn-cs"/>
+        </a:defRPr>
+      </a:lvl2pPr>
+      <a:lvl3pPr marL="928688" indent="-185738" algn="l" defTabSz="742950" rtl="0" eaLnBrk="1" latinLnBrk="0" hangingPunct="1">
+        <a:lnSpc>
+          <a:spcPct val="90000"/>
+        </a:lnSpc>
+        <a:spcBef>
+          <a:spcPts val="406"/>
+        </a:spcBef>
+        <a:buFont typeface="Arial" panose="020B0604020202020204" pitchFamily="34" charset="0"/>
+        <a:buChar char="•"/>
+        <a:defRPr sz="1625" kern="1200">
+          <a:solidFill>
+            <a:schemeClr val="tx1"/>
+          </a:solidFill>
+          <a:latin typeface="+mn-lt"/>
+          <a:ea typeface="+mn-ea"/>
+          <a:cs typeface="+mn-cs"/>
+        </a:defRPr>
+      </a:lvl3pPr>
+      <a:lvl4pPr marL="1300163" indent="-185738" algn="l" defTabSz="742950" rtl="0" eaLnBrk="1" latinLnBrk="0" hangingPunct="1">
+        <a:lnSpc>
+          <a:spcPct val="90000"/>
+        </a:lnSpc>
+        <a:spcBef>
+          <a:spcPts val="406"/>
+        </a:spcBef>
+        <a:buFont typeface="Arial" panose="020B0604020202020204" pitchFamily="34" charset="0"/>
+        <a:buChar char="•"/>
+        <a:defRPr sz="1463" kern="1200">
+          <a:solidFill>
+            <a:schemeClr val="tx1"/>
+          </a:solidFill>
+          <a:latin typeface="+mn-lt"/>
+          <a:ea typeface="+mn-ea"/>
+          <a:cs typeface="+mn-cs"/>
+        </a:defRPr>
+      </a:lvl4pPr>
+      <a:lvl5pPr marL="1671638" indent="-185738" algn="l" defTabSz="742950" rtl="0" eaLnBrk="1" latinLnBrk="0" hangingPunct="1">
+        <a:lnSpc>
+          <a:spcPct val="90000"/>
+        </a:lnSpc>
+        <a:spcBef>
+          <a:spcPts val="406"/>
+        </a:spcBef>
+        <a:buFont typeface="Arial" panose="020B0604020202020204" pitchFamily="34" charset="0"/>
+        <a:buChar char="•"/>
+        <a:defRPr sz="1463" kern="1200">
+          <a:solidFill>
+            <a:schemeClr val="tx1"/>
+          </a:solidFill>
+          <a:latin typeface="+mn-lt"/>
+          <a:ea typeface="+mn-ea"/>
+          <a:cs typeface="+mn-cs"/>
+        </a:defRPr>
+      </a:lvl5pPr>
+      <a:lvl6pPr marL="2043113" indent="-185738" algn="l" defTabSz="742950" rtl="0" eaLnBrk="1" latinLnBrk="0" hangingPunct="1">
+        <a:lnSpc>
+          <a:spcPct val="90000"/>
+        </a:lnSpc>
+        <a:spcBef>
+          <a:spcPts val="406"/>
+        </a:spcBef>
+        <a:buFont typeface="Arial" panose="020B0604020202020204" pitchFamily="34" charset="0"/>
+        <a:buChar char="•"/>
+        <a:defRPr sz="1463" kern="1200">
+          <a:solidFill>
+            <a:schemeClr val="tx1"/>
+          </a:solidFill>
+          <a:latin typeface="+mn-lt"/>
+          <a:ea typeface="+mn-ea"/>
+          <a:cs typeface="+mn-cs"/>
+        </a:defRPr>
+      </a:lvl6pPr>
+      <a:lvl7pPr marL="2414588" indent="-185738" algn="l" defTabSz="742950" rtl="0" eaLnBrk="1" latinLnBrk="0" hangingPunct="1">
+        <a:lnSpc>
+          <a:spcPct val="90000"/>
+        </a:lnSpc>
+        <a:spcBef>
+          <a:spcPts val="406"/>
+        </a:spcBef>
+        <a:buFont typeface="Arial" panose="020B0604020202020204" pitchFamily="34" charset="0"/>
+        <a:buChar char="•"/>
+        <a:defRPr sz="1463" kern="1200">
+          <a:solidFill>
+            <a:schemeClr val="tx1"/>
+          </a:solidFill>
+          <a:latin typeface="+mn-lt"/>
+          <a:ea typeface="+mn-ea"/>
+          <a:cs typeface="+mn-cs"/>
+        </a:defRPr>
+      </a:lvl7pPr>
+      <a:lvl8pPr marL="2786063" indent="-185738" algn="l" defTabSz="742950" rtl="0" eaLnBrk="1" latinLnBrk="0" hangingPunct="1">
+        <a:lnSpc>
+          <a:spcPct val="90000"/>
+        </a:lnSpc>
+        <a:spcBef>
+          <a:spcPts val="406"/>
+        </a:spcBef>
+        <a:buFont typeface="Arial" panose="020B0604020202020204" pitchFamily="34" charset="0"/>
+        <a:buChar char="•"/>
+        <a:defRPr sz="1463" kern="1200">
+          <a:solidFill>
+            <a:schemeClr val="tx1"/>
+          </a:solidFill>
+          <a:latin typeface="+mn-lt"/>
+          <a:ea typeface="+mn-ea"/>
+          <a:cs typeface="+mn-cs"/>
+        </a:defRPr>
+      </a:lvl8pPr>
+      <a:lvl9pPr marL="3157538" indent="-185738" algn="l" defTabSz="742950" rtl="0" eaLnBrk="1" latinLnBrk="0" hangingPunct="1">
+        <a:lnSpc>
+          <a:spcPct val="90000"/>
+        </a:lnSpc>
+        <a:spcBef>
+          <a:spcPts val="406"/>
+        </a:spcBef>
+        <a:buFont typeface="Arial" panose="020B0604020202020204" pitchFamily="34" charset="0"/>
+        <a:buChar char="•"/>
+        <a:defRPr sz="1463" kern="1200">
+          <a:solidFill>
+            <a:schemeClr val="tx1"/>
+          </a:solidFill>
+          <a:latin typeface="+mn-lt"/>
+          <a:ea typeface="+mn-ea"/>
+          <a:cs typeface="+mn-cs"/>
+        </a:defRPr>
+      </a:lvl9pPr>
+    </p:bodyStyle>
+    <p:otherStyle>
+      <a:defPPr>
+        <a:defRPr lang="en-US"/>
+      </a:defPPr>
+      <a:lvl1pPr marL="0" algn="l" defTabSz="742950" rtl="0" eaLnBrk="1" latinLnBrk="0" hangingPunct="1">
+        <a:defRPr sz="1463" kern="1200">
+          <a:solidFill>
+            <a:schemeClr val="tx1"/>
+          </a:solidFill>
+          <a:latin typeface="+mn-lt"/>
+          <a:ea typeface="+mn-ea"/>
+          <a:cs typeface="+mn-cs"/>
+        </a:defRPr>
+      </a:lvl1pPr>
+      <a:lvl2pPr marL="371475" algn="l" defTabSz="742950" rtl="0" eaLnBrk="1" latinLnBrk="0" hangingPunct="1">
+        <a:defRPr sz="1463" kern="1200">
+          <a:solidFill>
+            <a:schemeClr val="tx1"/>
+          </a:solidFill>
+          <a:latin typeface="+mn-lt"/>
+          <a:ea typeface="+mn-ea"/>
+          <a:cs typeface="+mn-cs"/>
+        </a:defRPr>
+      </a:lvl2pPr>
+      <a:lvl3pPr marL="742950" algn="l" defTabSz="742950" rtl="0" eaLnBrk="1" latinLnBrk="0" hangingPunct="1">
+        <a:defRPr sz="1463" kern="1200">
+          <a:solidFill>
+            <a:schemeClr val="tx1"/>
+          </a:solidFill>
+          <a:latin typeface="+mn-lt"/>
+          <a:ea typeface="+mn-ea"/>
+          <a:cs typeface="+mn-cs"/>
+        </a:defRPr>
+      </a:lvl3pPr>
+      <a:lvl4pPr marL="1114425" algn="l" defTabSz="742950" rtl="0" eaLnBrk="1" latinLnBrk="0" hangingPunct="1">
+        <a:defRPr sz="1463" kern="1200">
+          <a:solidFill>
+            <a:schemeClr val="tx1"/>
+          </a:solidFill>
+          <a:latin typeface="+mn-lt"/>
+          <a:ea typeface="+mn-ea"/>
+          <a:cs typeface="+mn-cs"/>
+        </a:defRPr>
+      </a:lvl4pPr>
+      <a:lvl5pPr marL="1485900" algn="l" defTabSz="742950" rtl="0" eaLnBrk="1" latinLnBrk="0" hangingPunct="1">
+        <a:defRPr sz="1463" kern="1200">
+          <a:solidFill>
+            <a:schemeClr val="tx1"/>
+          </a:solidFill>
+          <a:latin typeface="+mn-lt"/>
+          <a:ea typeface="+mn-ea"/>
+          <a:cs typeface="+mn-cs"/>
+        </a:defRPr>
+      </a:lvl5pPr>
+      <a:lvl6pPr marL="1857375" algn="l" defTabSz="742950" rtl="0" eaLnBrk="1" latinLnBrk="0" hangingPunct="1">
+        <a:defRPr sz="1463" kern="1200">
+          <a:solidFill>
+            <a:schemeClr val="tx1"/>
+          </a:solidFill>
+          <a:latin typeface="+mn-lt"/>
+          <a:ea typeface="+mn-ea"/>
+          <a:cs typeface="+mn-cs"/>
+        </a:defRPr>
+      </a:lvl6pPr>
+      <a:lvl7pPr marL="2228850" algn="l" defTabSz="742950" rtl="0" eaLnBrk="1" latinLnBrk="0" hangingPunct="1">
+        <a:defRPr sz="1463" kern="1200">
+          <a:solidFill>
+            <a:schemeClr val="tx1"/>
+          </a:solidFill>
+          <a:latin typeface="+mn-lt"/>
+          <a:ea typeface="+mn-ea"/>
+          <a:cs typeface="+mn-cs"/>
+        </a:defRPr>
+      </a:lvl7pPr>
+      <a:lvl8pPr marL="2600325" algn="l" defTabSz="742950" rtl="0" eaLnBrk="1" latinLnBrk="0" hangingPunct="1">
+        <a:defRPr sz="1463" kern="1200">
+          <a:solidFill>
+            <a:schemeClr val="tx1"/>
+          </a:solidFill>
+          <a:latin typeface="+mn-lt"/>
+          <a:ea typeface="+mn-ea"/>
+          <a:cs typeface="+mn-cs"/>
+        </a:defRPr>
+      </a:lvl8pPr>
+      <a:lvl9pPr marL="2971800" algn="l" defTabSz="742950" rtl="0" eaLnBrk="1" latinLnBrk="0" hangingPunct="1">
+        <a:defRPr sz="1463" kern="1200">
+          <a:solidFill>
+            <a:schemeClr val="tx1"/>
+          </a:solidFill>
+          <a:latin typeface="+mn-lt"/>
+          <a:ea typeface="+mn-ea"/>
+          <a:cs typeface="+mn-cs"/>
+        </a:defRPr>
+      </a:lvl9pPr>
+    </p:otherStyle>
+  </p:txStyles>
+  <p:extLst>
+    <p:ext uri="{27BBF7A9-308A-43DC-89C8-2F10F3537804}">
+      <p15:sldGuideLst xmlns:p15="http://schemas.microsoft.com/office/powerpoint/2012/main">
+        <p15:guide id="1" orient="horz" pos="1026" userDrawn="1">
+          <p15:clr>
+            <a:srgbClr val="F26B43"/>
+          </p15:clr>
+        </p15:guide>
+        <p15:guide id="2" orient="horz" pos="3748" userDrawn="1">
+          <p15:clr>
+            <a:srgbClr val="F26B43"/>
+          </p15:clr>
+        </p15:guide>
+        <p15:guide id="3" pos="3120" userDrawn="1">
+          <p15:clr>
+            <a:srgbClr val="F26B43"/>
+          </p15:clr>
+        </p15:guide>
+        <p15:guide id="4" pos="466" userDrawn="1">
+          <p15:clr>
+            <a:srgbClr val="F26B43"/>
+          </p15:clr>
+        </p15:guide>
+        <p15:guide id="5" pos="5774" userDrawn="1">
+          <p15:clr>
+            <a:srgbClr val="F26B43"/>
+          </p15:clr>
+        </p15:guide>
+      </p15:sldGuideLst>
+    </p:ext>
+  </p:extLst>
+</p:sldMaster>
+</file>
+
 <file path=ppt/slides/slide1.xml><?xml version="1.0" encoding="utf-8"?>
 <p:sld xmlns:a="http://schemas.openxmlformats.org/drawingml/2006/main" xmlns:r="http://schemas.openxmlformats.org/officeDocument/2006/relationships" xmlns:p="http://schemas.openxmlformats.org/presentationml/2006/main">
   <p:cSld>
@@ -5353,127 +9035,155 @@
       </p:grpSpPr>
       <p:sp>
         <p:nvSpPr>
-          <p:cNvPr id="3" name="Content Placeholder 2">
+          <p:cNvPr id="10" name="TextBox 9">
             <a:extLst>
               <a:ext uri="{FF2B5EF4-FFF2-40B4-BE49-F238E27FC236}">
-                <a16:creationId xmlns:a16="http://schemas.microsoft.com/office/drawing/2014/main" id="{11FB3DFF-F363-798A-E6FA-6D522062A47C}"/>
+                <a16:creationId xmlns:a16="http://schemas.microsoft.com/office/drawing/2014/main" id="{0D81F1DA-39EA-A422-4FB7-F151AE75E95B}"/>
               </a:ext>
             </a:extLst>
           </p:cNvPr>
-          <p:cNvSpPr>
-            <a:spLocks noGrp="1"/>
-          </p:cNvSpPr>
-          <p:nvPr>
-            <p:ph idx="1"/>
-          </p:nvPr>
-        </p:nvSpPr>
-        <p:spPr>
-          <a:xfrm>
-            <a:off x="389237" y="1708922"/>
-            <a:ext cx="4074607" cy="4023283"/>
-          </a:xfrm>
-        </p:spPr>
-        <p:txBody>
-          <a:bodyPr>
-            <a:normAutofit/>
+          <p:cNvSpPr txBox="1"/>
+          <p:nvPr/>
+        </p:nvSpPr>
+        <p:spPr>
+          <a:xfrm>
+            <a:off x="4642375" y="4100053"/>
+            <a:ext cx="4973574" cy="2308324"/>
+          </a:xfrm>
+          <a:prstGeom prst="rect">
+            <a:avLst/>
+          </a:prstGeom>
+          <a:noFill/>
+        </p:spPr>
+        <p:txBody>
+          <a:bodyPr wrap="square">
+            <a:spAutoFit/>
           </a:bodyPr>
           <a:lstStyle/>
           <a:p>
-            <a:pPr marL="285750" indent="-285750">
-              <a:lnSpc>
-                <a:spcPct val="100000"/>
-              </a:lnSpc>
-              <a:buFont typeface="Arial" panose="020B0604020202020204" pitchFamily="34" charset="0"/>
-              <a:buChar char="•"/>
+            <a:pPr>
+              <a:buNone/>
             </a:pPr>
             <a:r>
-              <a:rPr lang="en-US" sz="1600" dirty="0">
-                <a:latin typeface="Roboto" panose="02000000000000000000" pitchFamily="2" charset="0"/>
-                <a:ea typeface="Roboto" panose="02000000000000000000" pitchFamily="2" charset="0"/>
-                <a:cs typeface="Roboto" panose="02000000000000000000" pitchFamily="2" charset="0"/>
-              </a:rPr>
-              <a:t>Analyzed 10 buildings across the Americas region</a:t>
-            </a:r>
-          </a:p>
-          <a:p>
-            <a:pPr marL="285750" indent="-285750">
-              <a:lnSpc>
-                <a:spcPct val="100000"/>
-              </a:lnSpc>
-              <a:buFont typeface="Arial" panose="020B0604020202020204" pitchFamily="34" charset="0"/>
-              <a:buChar char="•"/>
+              <a:rPr lang="en-US" sz="1600" dirty="0"/>
+              <a:t>Across the 10 Americas buildings, vacancy rates are consistently low — ranging from 4.1% to 5.7% for nine of the buildings. Building F stands as a significant outlier at 24% vacancy, nearly 5x the portfolio average.</a:t>
+            </a:r>
+          </a:p>
+          <a:p>
+            <a:pPr>
+              <a:buNone/>
             </a:pPr>
-            <a:r>
-              <a:rPr lang="en-US" sz="1600" dirty="0">
-                <a:latin typeface="Roboto" panose="02000000000000000000" pitchFamily="2" charset="0"/>
-                <a:ea typeface="Roboto" panose="02000000000000000000" pitchFamily="2" charset="0"/>
-                <a:cs typeface="Roboto" panose="02000000000000000000" pitchFamily="2" charset="0"/>
-              </a:rPr>
-              <a:t>Building F is a clear outlier at 24% vacancy - well above portfolio average</a:t>
-            </a:r>
-          </a:p>
-          <a:p>
-            <a:pPr marL="285750" indent="-285750">
-              <a:lnSpc>
-                <a:spcPct val="100000"/>
-              </a:lnSpc>
-              <a:buFont typeface="Arial" panose="020B0604020202020204" pitchFamily="34" charset="0"/>
-              <a:buChar char="•"/>
+            <a:endParaRPr lang="en-US" sz="1600" dirty="0"/>
+          </a:p>
+          <a:p>
+            <a:pPr>
+              <a:buNone/>
             </a:pPr>
             <a:r>
-              <a:rPr lang="en-US" sz="1600" dirty="0">
-                <a:latin typeface="Roboto" panose="02000000000000000000" pitchFamily="2" charset="0"/>
-                <a:ea typeface="Roboto" panose="02000000000000000000" pitchFamily="2" charset="0"/>
-                <a:cs typeface="Roboto" panose="02000000000000000000" pitchFamily="2" charset="0"/>
-              </a:rPr>
-              <a:t>Remaining buildings (E, H, C, B, etc.) mostly below 10% vacancy</a:t>
-            </a:r>
-          </a:p>
-          <a:p>
-            <a:pPr marL="285750" indent="-285750">
-              <a:lnSpc>
-                <a:spcPct val="100000"/>
-              </a:lnSpc>
-              <a:buFont typeface="Arial" panose="020B0604020202020204" pitchFamily="34" charset="0"/>
-              <a:buChar char="•"/>
-            </a:pPr>
-            <a:r>
-              <a:rPr lang="en-US" sz="1600" dirty="0">
-                <a:latin typeface="Roboto" panose="02000000000000000000" pitchFamily="2" charset="0"/>
-                <a:ea typeface="Roboto" panose="02000000000000000000" pitchFamily="2" charset="0"/>
-                <a:cs typeface="Roboto" panose="02000000000000000000" pitchFamily="2" charset="0"/>
-              </a:rPr>
-              <a:t>Indicates strong space utilization across the region, aside from Building F</a:t>
-            </a:r>
-          </a:p>
-        </p:txBody>
-      </p:sp>
-      <p:sp>
-        <p:nvSpPr>
-          <p:cNvPr id="4" name="Title 3">
+              <a:rPr lang="en-US" sz="1600" dirty="0"/>
+              <a:t>Building E has the next highest vacancy at 5.7%, followed by Building H at 5.6%. Buildings G and A are the most efficiently utilized at 4.1% and 4.4% respectively.</a:t>
+            </a:r>
+          </a:p>
+        </p:txBody>
+      </p:sp>
+      <p:sp>
+        <p:nvSpPr>
+          <p:cNvPr id="13" name="Rectangle 12">
             <a:extLst>
               <a:ext uri="{FF2B5EF4-FFF2-40B4-BE49-F238E27FC236}">
-                <a16:creationId xmlns:a16="http://schemas.microsoft.com/office/drawing/2014/main" id="{E77FB41C-C19D-1AAB-E6F7-39A65C3E5098}"/>
+                <a16:creationId xmlns:a16="http://schemas.microsoft.com/office/drawing/2014/main" id="{7C0FE98C-A16B-B331-9711-B23546B52257}"/>
               </a:ext>
             </a:extLst>
           </p:cNvPr>
-          <p:cNvSpPr>
-            <a:spLocks noGrp="1"/>
-          </p:cNvSpPr>
-          <p:nvPr>
-            <p:ph type="title"/>
-          </p:nvPr>
-        </p:nvSpPr>
-        <p:spPr/>
-        <p:txBody>
-          <a:bodyPr/>
+          <p:cNvSpPr/>
+          <p:nvPr/>
+        </p:nvSpPr>
+        <p:spPr>
+          <a:xfrm>
+            <a:off x="0" y="0"/>
+            <a:ext cx="9906000" cy="953729"/>
+          </a:xfrm>
+          <a:prstGeom prst="rect">
+            <a:avLst/>
+          </a:prstGeom>
+          <a:solidFill>
+            <a:schemeClr val="bg1"/>
+          </a:solidFill>
+          <a:ln>
+            <a:solidFill>
+              <a:schemeClr val="bg1"/>
+            </a:solidFill>
+          </a:ln>
+        </p:spPr>
+        <p:style>
+          <a:lnRef idx="2">
+            <a:schemeClr val="accent1">
+              <a:shade val="15000"/>
+            </a:schemeClr>
+          </a:lnRef>
+          <a:fillRef idx="1">
+            <a:schemeClr val="accent1"/>
+          </a:fillRef>
+          <a:effectRef idx="0">
+            <a:schemeClr val="accent1"/>
+          </a:effectRef>
+          <a:fontRef idx="minor">
+            <a:schemeClr val="lt1"/>
+          </a:fontRef>
+        </p:style>
+        <p:txBody>
+          <a:bodyPr rtlCol="0" anchor="ctr"/>
           <a:lstStyle/>
           <a:p>
-            <a:r>
-              <a:rPr lang="en-US" b="1" spc="200" dirty="0"/>
-              <a:t>Vacancy Analysis Across Americas Portfolio</a:t>
-            </a:r>
-            <a:endParaRPr lang="en-US" spc="200" dirty="0"/>
+            <a:pPr algn="ctr"/>
+            <a:endParaRPr lang="en-US"/>
+          </a:p>
+        </p:txBody>
+      </p:sp>
+      <p:sp>
+        <p:nvSpPr>
+          <p:cNvPr id="12" name="TextBox 11">
+            <a:extLst>
+              <a:ext uri="{FF2B5EF4-FFF2-40B4-BE49-F238E27FC236}">
+                <a16:creationId xmlns:a16="http://schemas.microsoft.com/office/drawing/2014/main" id="{D1D04286-3226-6A86-B428-27A06188B343}"/>
+              </a:ext>
+            </a:extLst>
+          </p:cNvPr>
+          <p:cNvSpPr txBox="1"/>
+          <p:nvPr/>
+        </p:nvSpPr>
+        <p:spPr>
+          <a:xfrm>
+            <a:off x="290051" y="4208208"/>
+            <a:ext cx="4026309" cy="954107"/>
+          </a:xfrm>
+          <a:prstGeom prst="rect">
+            <a:avLst/>
+          </a:prstGeom>
+          <a:noFill/>
+        </p:spPr>
+        <p:txBody>
+          <a:bodyPr wrap="square">
+            <a:spAutoFit/>
+          </a:bodyPr>
+          <a:lstStyle/>
+          <a:p>
+            <a:pPr>
+              <a:buNone/>
+            </a:pPr>
+            <a:r>
+              <a:rPr lang="en-US" sz="2800" b="1" dirty="0"/>
+              <a:t>Building Level Metrics – </a:t>
+            </a:r>
+          </a:p>
+          <a:p>
+            <a:pPr>
+              <a:buNone/>
+            </a:pPr>
+            <a:r>
+              <a:rPr lang="en-US" sz="2800" b="1" dirty="0"/>
+              <a:t>Vacant % by Building</a:t>
+            </a:r>
           </a:p>
         </p:txBody>
       </p:sp>
@@ -5482,7 +9192,7 @@
           <p:cNvPr id="6" name="Picture 5">
             <a:extLst>
               <a:ext uri="{FF2B5EF4-FFF2-40B4-BE49-F238E27FC236}">
-                <a16:creationId xmlns:a16="http://schemas.microsoft.com/office/drawing/2014/main" id="{FD0B32CF-9704-7512-908D-082698FDAF76}"/>
+                <a16:creationId xmlns:a16="http://schemas.microsoft.com/office/drawing/2014/main" id="{6313C5A4-A268-7C6A-1F86-CD3588472186}"/>
               </a:ext>
             </a:extLst>
           </p:cNvPr>
@@ -5499,23 +9209,18 @@
         </p:blipFill>
         <p:spPr>
           <a:xfrm>
-            <a:off x="4748981" y="1272168"/>
-            <a:ext cx="4698955" cy="4726076"/>
+            <a:off x="144115" y="202654"/>
+            <a:ext cx="9617769" cy="3422991"/>
           </a:xfrm>
           <a:prstGeom prst="rect">
             <a:avLst/>
           </a:prstGeom>
-          <a:ln>
-            <a:solidFill>
-              <a:schemeClr val="tx1"/>
-            </a:solidFill>
-          </a:ln>
         </p:spPr>
       </p:pic>
     </p:spTree>
     <p:extLst>
       <p:ext uri="{BB962C8B-B14F-4D97-AF65-F5344CB8AC3E}">
-        <p14:creationId xmlns:p14="http://schemas.microsoft.com/office/powerpoint/2010/main" val="2784006949"/>
+        <p14:creationId xmlns:p14="http://schemas.microsoft.com/office/powerpoint/2010/main" val="1578780350"/>
       </p:ext>
     </p:extLst>
   </p:cSld>
@@ -5957,6 +9662,77 @@
       </p:grpSpPr>
       <p:sp>
         <p:nvSpPr>
+          <p:cNvPr id="7" name="Content Placeholder 2">
+            <a:extLst>
+              <a:ext uri="{FF2B5EF4-FFF2-40B4-BE49-F238E27FC236}">
+                <a16:creationId xmlns:a16="http://schemas.microsoft.com/office/drawing/2014/main" id="{307F34A8-1176-3F01-4E4F-F3D3C293A21D}"/>
+              </a:ext>
+            </a:extLst>
+          </p:cNvPr>
+          <p:cNvSpPr>
+            <a:spLocks noGrp="1"/>
+          </p:cNvSpPr>
+          <p:nvPr>
+            <p:ph idx="1"/>
+          </p:nvPr>
+        </p:nvSpPr>
+        <p:spPr>
+          <a:xfrm>
+            <a:off x="438398" y="1440082"/>
+            <a:ext cx="4261421" cy="2706329"/>
+          </a:xfrm>
+        </p:spPr>
+        <p:txBody>
+          <a:bodyPr>
+            <a:normAutofit/>
+          </a:bodyPr>
+          <a:lstStyle/>
+          <a:p>
+            <a:pPr marL="285750" indent="-285750">
+              <a:buFont typeface="Arial" panose="020B0604020202020204" pitchFamily="34" charset="0"/>
+              <a:buChar char="•"/>
+            </a:pPr>
+            <a:r>
+              <a:rPr lang="en-US" sz="1600" dirty="0">
+                <a:latin typeface="Roboto" panose="02000000000000000000" pitchFamily="2" charset="0"/>
+                <a:ea typeface="Roboto" panose="02000000000000000000" pitchFamily="2" charset="0"/>
+                <a:cs typeface="Roboto" panose="02000000000000000000" pitchFamily="2" charset="0"/>
+              </a:rPr>
+              <a:t>Floor 1: 72% aligned — office-heavy, low flex capacity</a:t>
+            </a:r>
+          </a:p>
+          <a:p>
+            <a:pPr marL="285750" indent="-285750">
+              <a:buFont typeface="Arial" panose="020B0604020202020204" pitchFamily="34" charset="0"/>
+              <a:buChar char="•"/>
+            </a:pPr>
+            <a:r>
+              <a:rPr lang="en-US" sz="1600" dirty="0">
+                <a:latin typeface="Roboto" panose="02000000000000000000" pitchFamily="2" charset="0"/>
+                <a:ea typeface="Roboto" panose="02000000000000000000" pitchFamily="2" charset="0"/>
+                <a:cs typeface="Roboto" panose="02000000000000000000" pitchFamily="2" charset="0"/>
+              </a:rPr>
+              <a:t>Floor 2: 65% aligned — more flex seats, but overflow spills into other orgs' space</a:t>
+            </a:r>
+          </a:p>
+          <a:p>
+            <a:pPr marL="285750" indent="-285750">
+              <a:buFont typeface="Arial" panose="020B0604020202020204" pitchFamily="34" charset="0"/>
+              <a:buChar char="•"/>
+            </a:pPr>
+            <a:r>
+              <a:rPr lang="en-US" sz="1600" dirty="0">
+                <a:latin typeface="Roboto" panose="02000000000000000000" pitchFamily="2" charset="0"/>
+                <a:ea typeface="Roboto" panose="02000000000000000000" pitchFamily="2" charset="0"/>
+                <a:cs typeface="Roboto" panose="02000000000000000000" pitchFamily="2" charset="0"/>
+              </a:rPr>
+              <a:t>Root cause: insufficient Retail-allocated seats on either floor</a:t>
+            </a:r>
+          </a:p>
+        </p:txBody>
+      </p:sp>
+      <p:sp>
+        <p:nvSpPr>
           <p:cNvPr id="4" name="Title 3">
             <a:extLst>
               <a:ext uri="{FF2B5EF4-FFF2-40B4-BE49-F238E27FC236}">
@@ -6018,77 +9794,6 @@
           </a:ln>
         </p:spPr>
       </p:pic>
-      <p:sp>
-        <p:nvSpPr>
-          <p:cNvPr id="7" name="Content Placeholder 2">
-            <a:extLst>
-              <a:ext uri="{FF2B5EF4-FFF2-40B4-BE49-F238E27FC236}">
-                <a16:creationId xmlns:a16="http://schemas.microsoft.com/office/drawing/2014/main" id="{307F34A8-1176-3F01-4E4F-F3D3C293A21D}"/>
-              </a:ext>
-            </a:extLst>
-          </p:cNvPr>
-          <p:cNvSpPr>
-            <a:spLocks noGrp="1"/>
-          </p:cNvSpPr>
-          <p:nvPr>
-            <p:ph idx="1"/>
-          </p:nvPr>
-        </p:nvSpPr>
-        <p:spPr>
-          <a:xfrm>
-            <a:off x="438398" y="1440082"/>
-            <a:ext cx="4261421" cy="2706329"/>
-          </a:xfrm>
-        </p:spPr>
-        <p:txBody>
-          <a:bodyPr>
-            <a:normAutofit/>
-          </a:bodyPr>
-          <a:lstStyle/>
-          <a:p>
-            <a:pPr marL="285750" indent="-285750">
-              <a:buFont typeface="Arial" panose="020B0604020202020204" pitchFamily="34" charset="0"/>
-              <a:buChar char="•"/>
-            </a:pPr>
-            <a:r>
-              <a:rPr lang="en-US" sz="1600" dirty="0">
-                <a:latin typeface="Roboto" panose="02000000000000000000" pitchFamily="2" charset="0"/>
-                <a:ea typeface="Roboto" panose="02000000000000000000" pitchFamily="2" charset="0"/>
-                <a:cs typeface="Roboto" panose="02000000000000000000" pitchFamily="2" charset="0"/>
-              </a:rPr>
-              <a:t>Floor 1: 72% aligned — office-heavy, low flex capacity</a:t>
-            </a:r>
-          </a:p>
-          <a:p>
-            <a:pPr marL="285750" indent="-285750">
-              <a:buFont typeface="Arial" panose="020B0604020202020204" pitchFamily="34" charset="0"/>
-              <a:buChar char="•"/>
-            </a:pPr>
-            <a:r>
-              <a:rPr lang="en-US" sz="1600" dirty="0">
-                <a:latin typeface="Roboto" panose="02000000000000000000" pitchFamily="2" charset="0"/>
-                <a:ea typeface="Roboto" panose="02000000000000000000" pitchFamily="2" charset="0"/>
-                <a:cs typeface="Roboto" panose="02000000000000000000" pitchFamily="2" charset="0"/>
-              </a:rPr>
-              <a:t>Floor 2: 65% aligned — more flex seats, but overflow spills into other orgs' space</a:t>
-            </a:r>
-          </a:p>
-          <a:p>
-            <a:pPr marL="285750" indent="-285750">
-              <a:buFont typeface="Arial" panose="020B0604020202020204" pitchFamily="34" charset="0"/>
-              <a:buChar char="•"/>
-            </a:pPr>
-            <a:r>
-              <a:rPr lang="en-US" sz="1600" dirty="0">
-                <a:latin typeface="Roboto" panose="02000000000000000000" pitchFamily="2" charset="0"/>
-                <a:ea typeface="Roboto" panose="02000000000000000000" pitchFamily="2" charset="0"/>
-                <a:cs typeface="Roboto" panose="02000000000000000000" pitchFamily="2" charset="0"/>
-              </a:rPr>
-              <a:t>Root cause: insufficient Retail-allocated seats on either floor</a:t>
-            </a:r>
-          </a:p>
-        </p:txBody>
-      </p:sp>
       <p:sp>
         <p:nvSpPr>
           <p:cNvPr id="8" name="Content Placeholder 2">
@@ -7125,39 +10830,39 @@
         <a:sysClr val="window" lastClr="FFFFFF"/>
       </a:lt1>
       <a:dk2>
-        <a:srgbClr val="44546A"/>
+        <a:srgbClr val="0E2841"/>
       </a:dk2>
       <a:lt2>
-        <a:srgbClr val="E7E6E6"/>
+        <a:srgbClr val="E8E8E8"/>
       </a:lt2>
       <a:accent1>
-        <a:srgbClr val="5B9BD5"/>
+        <a:srgbClr val="156082"/>
       </a:accent1>
       <a:accent2>
-        <a:srgbClr val="ED7D31"/>
+        <a:srgbClr val="E97132"/>
       </a:accent2>
       <a:accent3>
-        <a:srgbClr val="A5A5A5"/>
+        <a:srgbClr val="196B24"/>
       </a:accent3>
       <a:accent4>
-        <a:srgbClr val="FFC000"/>
+        <a:srgbClr val="0F9ED5"/>
       </a:accent4>
       <a:accent5>
-        <a:srgbClr val="4472C4"/>
+        <a:srgbClr val="A02B93"/>
       </a:accent5>
       <a:accent6>
-        <a:srgbClr val="70AD47"/>
+        <a:srgbClr val="4EA72E"/>
       </a:accent6>
       <a:hlink>
-        <a:srgbClr val="0563C1"/>
+        <a:srgbClr val="467886"/>
       </a:hlink>
       <a:folHlink>
-        <a:srgbClr val="954F72"/>
+        <a:srgbClr val="96607D"/>
       </a:folHlink>
     </a:clrScheme>
     <a:fontScheme name="Office">
       <a:majorFont>
-        <a:latin typeface="Calibri Light" panose="020F0302020204030204"/>
+        <a:latin typeface="Aptos Display" panose="02110004020202020204"/>
         <a:ea typeface=""/>
         <a:cs typeface=""/>
         <a:font script="Jpan" typeface="游ゴシック Light"/>
@@ -7190,9 +10895,26 @@
         <a:font script="Viet" typeface="Times New Roman"/>
         <a:font script="Uigh" typeface="Microsoft Uighur"/>
         <a:font script="Geor" typeface="Sylfaen"/>
+        <a:font script="Armn" typeface="Arial"/>
+        <a:font script="Bugi" typeface="Leelawadee UI"/>
+        <a:font script="Bopo" typeface="Microsoft JhengHei"/>
+        <a:font script="Java" typeface="Javanese Text"/>
+        <a:font script="Lisu" typeface="Segoe UI"/>
+        <a:font script="Mymr" typeface="Myanmar Text"/>
+        <a:font script="Nkoo" typeface="Ebrima"/>
+        <a:font script="Olck" typeface="Nirmala UI"/>
+        <a:font script="Osma" typeface="Ebrima"/>
+        <a:font script="Phag" typeface="Phagspa"/>
+        <a:font script="Syrn" typeface="Estrangelo Edessa"/>
+        <a:font script="Syrj" typeface="Estrangelo Edessa"/>
+        <a:font script="Syre" typeface="Estrangelo Edessa"/>
+        <a:font script="Sora" typeface="Nirmala UI"/>
+        <a:font script="Tale" typeface="Microsoft Tai Le"/>
+        <a:font script="Talu" typeface="Microsoft New Tai Lue"/>
+        <a:font script="Tfng" typeface="Ebrima"/>
       </a:majorFont>
       <a:minorFont>
-        <a:latin typeface="Calibri" panose="020F0502020204030204"/>
+        <a:latin typeface="Aptos" panose="02110004020202020204"/>
         <a:ea typeface=""/>
         <a:cs typeface=""/>
         <a:font script="Jpan" typeface="游ゴシック"/>
@@ -7225,6 +10947,23 @@
         <a:font script="Viet" typeface="Arial"/>
         <a:font script="Uigh" typeface="Microsoft Uighur"/>
         <a:font script="Geor" typeface="Sylfaen"/>
+        <a:font script="Armn" typeface="Arial"/>
+        <a:font script="Bugi" typeface="Leelawadee UI"/>
+        <a:font script="Bopo" typeface="Microsoft JhengHei"/>
+        <a:font script="Java" typeface="Javanese Text"/>
+        <a:font script="Lisu" typeface="Segoe UI"/>
+        <a:font script="Mymr" typeface="Myanmar Text"/>
+        <a:font script="Nkoo" typeface="Ebrima"/>
+        <a:font script="Olck" typeface="Nirmala UI"/>
+        <a:font script="Osma" typeface="Ebrima"/>
+        <a:font script="Phag" typeface="Phagspa"/>
+        <a:font script="Syrn" typeface="Estrangelo Edessa"/>
+        <a:font script="Syrj" typeface="Estrangelo Edessa"/>
+        <a:font script="Syre" typeface="Estrangelo Edessa"/>
+        <a:font script="Sora" typeface="Nirmala UI"/>
+        <a:font script="Tale" typeface="Microsoft Tai Le"/>
+        <a:font script="Talu" typeface="Microsoft New Tai Lue"/>
+        <a:font script="Tfng" typeface="Ebrima"/>
       </a:minorFont>
     </a:fontScheme>
     <a:fmtScheme name="Office">
@@ -7286,13 +11025,6 @@
         </a:gradFill>
       </a:fillStyleLst>
       <a:lnStyleLst>
-        <a:ln w="6350" cap="flat" cmpd="sng" algn="ctr">
-          <a:solidFill>
-            <a:schemeClr val="phClr"/>
-          </a:solidFill>
-          <a:prstDash val="solid"/>
-          <a:miter lim="800000"/>
-        </a:ln>
         <a:ln w="12700" cap="flat" cmpd="sng" algn="ctr">
           <a:solidFill>
             <a:schemeClr val="phClr"/>
@@ -7301,6 +11033,13 @@
           <a:miter lim="800000"/>
         </a:ln>
         <a:ln w="19050" cap="flat" cmpd="sng" algn="ctr">
+          <a:solidFill>
+            <a:schemeClr val="phClr"/>
+          </a:solidFill>
+          <a:prstDash val="solid"/>
+          <a:miter lim="800000"/>
+        </a:ln>
+        <a:ln w="25400" cap="flat" cmpd="sng" algn="ctr">
           <a:solidFill>
             <a:schemeClr val="phClr"/>
           </a:solidFill>
@@ -7365,11 +11104,31 @@
       </a:bgFillStyleLst>
     </a:fmtScheme>
   </a:themeElements>
-  <a:objectDefaults/>
+  <a:objectDefaults>
+    <a:lnDef>
+      <a:spPr/>
+      <a:bodyPr/>
+      <a:lstStyle/>
+      <a:style>
+        <a:lnRef idx="2">
+          <a:schemeClr val="accent1"/>
+        </a:lnRef>
+        <a:fillRef idx="0">
+          <a:schemeClr val="accent1"/>
+        </a:fillRef>
+        <a:effectRef idx="1">
+          <a:schemeClr val="accent1"/>
+        </a:effectRef>
+        <a:fontRef idx="minor">
+          <a:schemeClr val="tx1"/>
+        </a:fontRef>
+      </a:style>
+    </a:lnDef>
+  </a:objectDefaults>
   <a:extraClrSchemeLst/>
   <a:extLst>
     <a:ext uri="{05A4C25C-085E-4340-85A3-A5531E510DB2}">
-      <thm15:themeFamily xmlns:thm15="http://schemas.microsoft.com/office/thememl/2012/main" name="Office Theme" id="{62F939B6-93AF-4DB8-9C6B-D6C7DFDC589F}" vid="{4A3C46E8-61CC-4603-A589-7422A47A8E4A}"/>
+      <thm15:themeFamily xmlns:thm15="http://schemas.microsoft.com/office/thememl/2012/main" name="Office Theme" id="{2E142A2C-CD16-42D6-873A-C26D2A0506FA}" vid="{1BDDFF52-6CD6-40A5-AB3C-68EB2F1E4D0A}"/>
     </a:ext>
   </a:extLst>
 </a:theme>
@@ -7636,7 +11395,283 @@
 </a:theme>
 </file>
 
+<file path=ppt/theme/theme5.xml><?xml version="1.0" encoding="utf-8"?>
+<a:theme xmlns:a="http://schemas.openxmlformats.org/drawingml/2006/main" name="Office Theme">
+  <a:themeElements>
+    <a:clrScheme name="Office">
+      <a:dk1>
+        <a:sysClr val="windowText" lastClr="000000"/>
+      </a:dk1>
+      <a:lt1>
+        <a:sysClr val="window" lastClr="FFFFFF"/>
+      </a:lt1>
+      <a:dk2>
+        <a:srgbClr val="44546A"/>
+      </a:dk2>
+      <a:lt2>
+        <a:srgbClr val="E7E6E6"/>
+      </a:lt2>
+      <a:accent1>
+        <a:srgbClr val="5B9BD5"/>
+      </a:accent1>
+      <a:accent2>
+        <a:srgbClr val="ED7D31"/>
+      </a:accent2>
+      <a:accent3>
+        <a:srgbClr val="A5A5A5"/>
+      </a:accent3>
+      <a:accent4>
+        <a:srgbClr val="FFC000"/>
+      </a:accent4>
+      <a:accent5>
+        <a:srgbClr val="4472C4"/>
+      </a:accent5>
+      <a:accent6>
+        <a:srgbClr val="70AD47"/>
+      </a:accent6>
+      <a:hlink>
+        <a:srgbClr val="0563C1"/>
+      </a:hlink>
+      <a:folHlink>
+        <a:srgbClr val="954F72"/>
+      </a:folHlink>
+    </a:clrScheme>
+    <a:fontScheme name="Office">
+      <a:majorFont>
+        <a:latin typeface="Calibri Light" panose="020F0302020204030204"/>
+        <a:ea typeface=""/>
+        <a:cs typeface=""/>
+        <a:font script="Jpan" typeface="游ゴシック Light"/>
+        <a:font script="Hang" typeface="맑은 고딕"/>
+        <a:font script="Hans" typeface="等线 Light"/>
+        <a:font script="Hant" typeface="新細明體"/>
+        <a:font script="Arab" typeface="Times New Roman"/>
+        <a:font script="Hebr" typeface="Times New Roman"/>
+        <a:font script="Thai" typeface="Angsana New"/>
+        <a:font script="Ethi" typeface="Nyala"/>
+        <a:font script="Beng" typeface="Vrinda"/>
+        <a:font script="Gujr" typeface="Shruti"/>
+        <a:font script="Khmr" typeface="MoolBoran"/>
+        <a:font script="Knda" typeface="Tunga"/>
+        <a:font script="Guru" typeface="Raavi"/>
+        <a:font script="Cans" typeface="Euphemia"/>
+        <a:font script="Cher" typeface="Plantagenet Cherokee"/>
+        <a:font script="Yiii" typeface="Microsoft Yi Baiti"/>
+        <a:font script="Tibt" typeface="Microsoft Himalaya"/>
+        <a:font script="Thaa" typeface="MV Boli"/>
+        <a:font script="Deva" typeface="Mangal"/>
+        <a:font script="Telu" typeface="Gautami"/>
+        <a:font script="Taml" typeface="Latha"/>
+        <a:font script="Syrc" typeface="Estrangelo Edessa"/>
+        <a:font script="Orya" typeface="Kalinga"/>
+        <a:font script="Mlym" typeface="Kartika"/>
+        <a:font script="Laoo" typeface="DokChampa"/>
+        <a:font script="Sinh" typeface="Iskoola Pota"/>
+        <a:font script="Mong" typeface="Mongolian Baiti"/>
+        <a:font script="Viet" typeface="Times New Roman"/>
+        <a:font script="Uigh" typeface="Microsoft Uighur"/>
+        <a:font script="Geor" typeface="Sylfaen"/>
+      </a:majorFont>
+      <a:minorFont>
+        <a:latin typeface="Calibri" panose="020F0502020204030204"/>
+        <a:ea typeface=""/>
+        <a:cs typeface=""/>
+        <a:font script="Jpan" typeface="游ゴシック"/>
+        <a:font script="Hang" typeface="맑은 고딕"/>
+        <a:font script="Hans" typeface="等线"/>
+        <a:font script="Hant" typeface="新細明體"/>
+        <a:font script="Arab" typeface="Arial"/>
+        <a:font script="Hebr" typeface="Arial"/>
+        <a:font script="Thai" typeface="Cordia New"/>
+        <a:font script="Ethi" typeface="Nyala"/>
+        <a:font script="Beng" typeface="Vrinda"/>
+        <a:font script="Gujr" typeface="Shruti"/>
+        <a:font script="Khmr" typeface="DaunPenh"/>
+        <a:font script="Knda" typeface="Tunga"/>
+        <a:font script="Guru" typeface="Raavi"/>
+        <a:font script="Cans" typeface="Euphemia"/>
+        <a:font script="Cher" typeface="Plantagenet Cherokee"/>
+        <a:font script="Yiii" typeface="Microsoft Yi Baiti"/>
+        <a:font script="Tibt" typeface="Microsoft Himalaya"/>
+        <a:font script="Thaa" typeface="MV Boli"/>
+        <a:font script="Deva" typeface="Mangal"/>
+        <a:font script="Telu" typeface="Gautami"/>
+        <a:font script="Taml" typeface="Latha"/>
+        <a:font script="Syrc" typeface="Estrangelo Edessa"/>
+        <a:font script="Orya" typeface="Kalinga"/>
+        <a:font script="Mlym" typeface="Kartika"/>
+        <a:font script="Laoo" typeface="DokChampa"/>
+        <a:font script="Sinh" typeface="Iskoola Pota"/>
+        <a:font script="Mong" typeface="Mongolian Baiti"/>
+        <a:font script="Viet" typeface="Arial"/>
+        <a:font script="Uigh" typeface="Microsoft Uighur"/>
+        <a:font script="Geor" typeface="Sylfaen"/>
+      </a:minorFont>
+    </a:fontScheme>
+    <a:fmtScheme name="Office">
+      <a:fillStyleLst>
+        <a:solidFill>
+          <a:schemeClr val="phClr"/>
+        </a:solidFill>
+        <a:gradFill rotWithShape="1">
+          <a:gsLst>
+            <a:gs pos="0">
+              <a:schemeClr val="phClr">
+                <a:lumMod val="110000"/>
+                <a:satMod val="105000"/>
+                <a:tint val="67000"/>
+              </a:schemeClr>
+            </a:gs>
+            <a:gs pos="50000">
+              <a:schemeClr val="phClr">
+                <a:lumMod val="105000"/>
+                <a:satMod val="103000"/>
+                <a:tint val="73000"/>
+              </a:schemeClr>
+            </a:gs>
+            <a:gs pos="100000">
+              <a:schemeClr val="phClr">
+                <a:lumMod val="105000"/>
+                <a:satMod val="109000"/>
+                <a:tint val="81000"/>
+              </a:schemeClr>
+            </a:gs>
+          </a:gsLst>
+          <a:lin ang="5400000" scaled="0"/>
+        </a:gradFill>
+        <a:gradFill rotWithShape="1">
+          <a:gsLst>
+            <a:gs pos="0">
+              <a:schemeClr val="phClr">
+                <a:satMod val="103000"/>
+                <a:lumMod val="102000"/>
+                <a:tint val="94000"/>
+              </a:schemeClr>
+            </a:gs>
+            <a:gs pos="50000">
+              <a:schemeClr val="phClr">
+                <a:satMod val="110000"/>
+                <a:lumMod val="100000"/>
+                <a:shade val="100000"/>
+              </a:schemeClr>
+            </a:gs>
+            <a:gs pos="100000">
+              <a:schemeClr val="phClr">
+                <a:lumMod val="99000"/>
+                <a:satMod val="120000"/>
+                <a:shade val="78000"/>
+              </a:schemeClr>
+            </a:gs>
+          </a:gsLst>
+          <a:lin ang="5400000" scaled="0"/>
+        </a:gradFill>
+      </a:fillStyleLst>
+      <a:lnStyleLst>
+        <a:ln w="6350" cap="flat" cmpd="sng" algn="ctr">
+          <a:solidFill>
+            <a:schemeClr val="phClr"/>
+          </a:solidFill>
+          <a:prstDash val="solid"/>
+          <a:miter lim="800000"/>
+        </a:ln>
+        <a:ln w="12700" cap="flat" cmpd="sng" algn="ctr">
+          <a:solidFill>
+            <a:schemeClr val="phClr"/>
+          </a:solidFill>
+          <a:prstDash val="solid"/>
+          <a:miter lim="800000"/>
+        </a:ln>
+        <a:ln w="19050" cap="flat" cmpd="sng" algn="ctr">
+          <a:solidFill>
+            <a:schemeClr val="phClr"/>
+          </a:solidFill>
+          <a:prstDash val="solid"/>
+          <a:miter lim="800000"/>
+        </a:ln>
+      </a:lnStyleLst>
+      <a:effectStyleLst>
+        <a:effectStyle>
+          <a:effectLst/>
+        </a:effectStyle>
+        <a:effectStyle>
+          <a:effectLst/>
+        </a:effectStyle>
+        <a:effectStyle>
+          <a:effectLst>
+            <a:outerShdw blurRad="57150" dist="19050" dir="5400000" algn="ctr" rotWithShape="0">
+              <a:srgbClr val="000000">
+                <a:alpha val="63000"/>
+              </a:srgbClr>
+            </a:outerShdw>
+          </a:effectLst>
+        </a:effectStyle>
+      </a:effectStyleLst>
+      <a:bgFillStyleLst>
+        <a:solidFill>
+          <a:schemeClr val="phClr"/>
+        </a:solidFill>
+        <a:solidFill>
+          <a:schemeClr val="phClr">
+            <a:tint val="95000"/>
+            <a:satMod val="170000"/>
+          </a:schemeClr>
+        </a:solidFill>
+        <a:gradFill rotWithShape="1">
+          <a:gsLst>
+            <a:gs pos="0">
+              <a:schemeClr val="phClr">
+                <a:tint val="93000"/>
+                <a:satMod val="150000"/>
+                <a:shade val="98000"/>
+                <a:lumMod val="102000"/>
+              </a:schemeClr>
+            </a:gs>
+            <a:gs pos="50000">
+              <a:schemeClr val="phClr">
+                <a:tint val="98000"/>
+                <a:satMod val="130000"/>
+                <a:shade val="90000"/>
+                <a:lumMod val="103000"/>
+              </a:schemeClr>
+            </a:gs>
+            <a:gs pos="100000">
+              <a:schemeClr val="phClr">
+                <a:shade val="63000"/>
+                <a:satMod val="120000"/>
+              </a:schemeClr>
+            </a:gs>
+          </a:gsLst>
+          <a:lin ang="5400000" scaled="0"/>
+        </a:gradFill>
+      </a:bgFillStyleLst>
+    </a:fmtScheme>
+  </a:themeElements>
+  <a:objectDefaults/>
+  <a:extraClrSchemeLst/>
+  <a:extLst>
+    <a:ext uri="{05A4C25C-085E-4340-85A3-A5531E510DB2}">
+      <thm15:themeFamily xmlns:thm15="http://schemas.microsoft.com/office/thememl/2012/main" name="Office Theme" id="{62F939B6-93AF-4DB8-9C6B-D6C7DFDC589F}" vid="{4A3C46E8-61CC-4603-A589-7422A47A8E4A}"/>
+    </a:ext>
+  </a:extLst>
+</a:theme>
+</file>
+
 <file path=customXml/item1.xml><?xml version="1.0" encoding="utf-8"?>
+<p:properties xmlns:p="http://schemas.microsoft.com/office/2006/metadata/properties" xmlns:xsi="http://www.w3.org/2001/XMLSchema-instance" xmlns:pc="http://schemas.microsoft.com/office/infopath/2007/PartnerControls">
+  <documentManagement/>
+</p:properties>
+</file>
+
+<file path=customXml/item2.xml><?xml version="1.0" encoding="utf-8"?>
+<?mso-contentType ?>
+<FormTemplates xmlns="http://schemas.microsoft.com/sharepoint/v3/contenttype/forms">
+  <Display>DocumentLibraryForm</Display>
+  <Edit>DocumentLibraryForm</Edit>
+  <New>DocumentLibraryForm</New>
+</FormTemplates>
+</file>
+
+<file path=customXml/item3.xml><?xml version="1.0" encoding="utf-8"?>
 <ct:contentTypeSchema xmlns:ct="http://schemas.microsoft.com/office/2006/metadata/contentType" xmlns:ma="http://schemas.microsoft.com/office/2006/metadata/properties/metaAttributes" ct:_="" ma:_="" ma:contentTypeName="Document" ma:contentTypeID="0x01010028474C0DDFCB744F82F415B088B01E4B" ma:contentTypeVersion="14" ma:contentTypeDescription="Create a new document." ma:contentTypeScope="" ma:versionID="e5e9462897096f16b0008292cbb975dd">
   <xsd:schema xmlns:xsd="http://www.w3.org/2001/XMLSchema" xmlns:xs="http://www.w3.org/2001/XMLSchema" xmlns:p="http://schemas.microsoft.com/office/2006/metadata/properties" xmlns:ns3="1c75bd5f-743b-40f2-bae2-8e86a640c5ff" xmlns:ns4="153ae615-e700-431c-905c-1e4cee6d6937" targetNamespace="http://schemas.microsoft.com/office/2006/metadata/properties" ma:root="true" ma:fieldsID="590d4ed62c67927dcdef9f8de5167c65" ns3:_="" ns4:_="">
     <xsd:import namespace="1c75bd5f-743b-40f2-bae2-8e86a640c5ff"/>
@@ -7865,22 +11900,32 @@
 </ct:contentTypeSchema>
 </file>
 
-<file path=customXml/item2.xml><?xml version="1.0" encoding="utf-8"?>
-<?mso-contentType ?>
-<FormTemplates xmlns="http://schemas.microsoft.com/sharepoint/v3/contenttype/forms">
-  <Display>DocumentLibraryForm</Display>
-  <Edit>DocumentLibraryForm</Edit>
-  <New>DocumentLibraryForm</New>
-</FormTemplates>
+<file path=customXml/itemProps1.xml><?xml version="1.0" encoding="utf-8"?>
+<ds:datastoreItem xmlns:ds="http://schemas.openxmlformats.org/officeDocument/2006/customXml" ds:itemID="{B45D76EC-F2F5-48B8-95DA-EF0FB4B2183F}">
+  <ds:schemaRefs>
+    <ds:schemaRef ds:uri="http://purl.org/dc/elements/1.1/"/>
+    <ds:schemaRef ds:uri="http://schemas.microsoft.com/office/2006/metadata/properties"/>
+    <ds:schemaRef ds:uri="1c75bd5f-743b-40f2-bae2-8e86a640c5ff"/>
+    <ds:schemaRef ds:uri="http://purl.org/dc/terms/"/>
+    <ds:schemaRef ds:uri="153ae615-e700-431c-905c-1e4cee6d6937"/>
+    <ds:schemaRef ds:uri="http://schemas.microsoft.com/office/2006/documentManagement/types"/>
+    <ds:schemaRef ds:uri="http://schemas.microsoft.com/office/infopath/2007/PartnerControls"/>
+    <ds:schemaRef ds:uri="http://schemas.openxmlformats.org/package/2006/metadata/core-properties"/>
+    <ds:schemaRef ds:uri="http://www.w3.org/XML/1998/namespace"/>
+    <ds:schemaRef ds:uri="http://purl.org/dc/dcmitype/"/>
+  </ds:schemaRefs>
+</ds:datastoreItem>
 </file>
 
-<file path=customXml/item3.xml><?xml version="1.0" encoding="utf-8"?>
-<p:properties xmlns:p="http://schemas.microsoft.com/office/2006/metadata/properties" xmlns:xsi="http://www.w3.org/2001/XMLSchema-instance" xmlns:pc="http://schemas.microsoft.com/office/infopath/2007/PartnerControls">
-  <documentManagement/>
-</p:properties>
+<file path=customXml/itemProps2.xml><?xml version="1.0" encoding="utf-8"?>
+<ds:datastoreItem xmlns:ds="http://schemas.openxmlformats.org/officeDocument/2006/customXml" ds:itemID="{1D4F0347-749B-4FE7-BD83-FBDC671D74F1}">
+  <ds:schemaRefs>
+    <ds:schemaRef ds:uri="http://schemas.microsoft.com/sharepoint/v3/contenttype/forms"/>
+  </ds:schemaRefs>
+</ds:datastoreItem>
 </file>
 
-<file path=customXml/itemProps1.xml><?xml version="1.0" encoding="utf-8"?>
+<file path=customXml/itemProps3.xml><?xml version="1.0" encoding="utf-8"?>
 <ds:datastoreItem xmlns:ds="http://schemas.openxmlformats.org/officeDocument/2006/customXml" ds:itemID="{D98D8A7F-A9E3-46B6-AF87-01F7F1B98009}">
   <ds:schemaRefs>
     <ds:schemaRef ds:uri="http://schemas.microsoft.com/office/2006/metadata/contentType"/>
@@ -7899,31 +11944,6 @@
 </ds:datastoreItem>
 </file>
 
-<file path=customXml/itemProps2.xml><?xml version="1.0" encoding="utf-8"?>
-<ds:datastoreItem xmlns:ds="http://schemas.openxmlformats.org/officeDocument/2006/customXml" ds:itemID="{1D4F0347-749B-4FE7-BD83-FBDC671D74F1}">
-  <ds:schemaRefs>
-    <ds:schemaRef ds:uri="http://schemas.microsoft.com/sharepoint/v3/contenttype/forms"/>
-  </ds:schemaRefs>
-</ds:datastoreItem>
-</file>
-
-<file path=customXml/itemProps3.xml><?xml version="1.0" encoding="utf-8"?>
-<ds:datastoreItem xmlns:ds="http://schemas.openxmlformats.org/officeDocument/2006/customXml" ds:itemID="{B45D76EC-F2F5-48B8-95DA-EF0FB4B2183F}">
-  <ds:schemaRefs>
-    <ds:schemaRef ds:uri="http://purl.org/dc/elements/1.1/"/>
-    <ds:schemaRef ds:uri="http://schemas.microsoft.com/office/2006/metadata/properties"/>
-    <ds:schemaRef ds:uri="1c75bd5f-743b-40f2-bae2-8e86a640c5ff"/>
-    <ds:schemaRef ds:uri="http://purl.org/dc/terms/"/>
-    <ds:schemaRef ds:uri="153ae615-e700-431c-905c-1e4cee6d6937"/>
-    <ds:schemaRef ds:uri="http://schemas.microsoft.com/office/2006/documentManagement/types"/>
-    <ds:schemaRef ds:uri="http://schemas.microsoft.com/office/infopath/2007/PartnerControls"/>
-    <ds:schemaRef ds:uri="http://schemas.openxmlformats.org/package/2006/metadata/core-properties"/>
-    <ds:schemaRef ds:uri="http://www.w3.org/XML/1998/namespace"/>
-    <ds:schemaRef ds:uri="http://purl.org/dc/dcmitype/"/>
-  </ds:schemaRefs>
-</ds:datastoreItem>
-</file>
-
 <file path=docMetadata/LabelInfo.xml><?xml version="1.0" encoding="utf-8"?>
 <clbl:labelList xmlns:clbl="http://schemas.microsoft.com/office/2020/mipLabelMetadata">
   <clbl:label id="{f42aa342-8706-4288-bd11-ebb85995028c}" enabled="1" method="Standard" siteId="{72f988bf-86f1-41af-91ab-2d7cd011db47}" contentBits="0" removed="0"/>

</xml_diff>